<commit_message>
Footer change to reflect true URL
</commit_message>
<xml_diff>
--- a/SCOB-Dashboard-User-Guide.pptx
+++ b/SCOB-Dashboard-User-Guide.pptx
@@ -6631,7 +6631,7 @@
                 </a:solidFill>
                 <a:latin typeface="Calibri"/>
               </a:rPr>
-              <a:t>Version 3.42  ·  Updated weekly, ahead of the session</a:t>
+              <a:t>Version 3.43  ·  Updated weekly, ahead of the session</a:t>
             </a:r>
           </a:p>
         </p:txBody>
@@ -6881,7 +6881,7 @@
                 </a:solidFill>
                 <a:latin typeface="Calibri"/>
               </a:rPr>
-              <a:t>SCOB Night-Sky Dashboard  ·  Volunteer User Guide  ·  v3.42</a:t>
+              <a:t>SCOB Night-Sky Dashboard  ·  Volunteer User Guide  ·  v3.43</a:t>
             </a:r>
           </a:p>
         </p:txBody>
@@ -8115,7 +8115,7 @@
                 </a:solidFill>
                 <a:latin typeface="Calibri"/>
               </a:rPr>
-              <a:t>SCOB Night-Sky Dashboard  ·  Volunteer User Guide  ·  v3.42</a:t>
+              <a:t>SCOB Night-Sky Dashboard  ·  Volunteer User Guide  ·  v3.43</a:t>
             </a:r>
           </a:p>
         </p:txBody>
@@ -9233,7 +9233,7 @@
                 </a:solidFill>
                 <a:latin typeface="Calibri"/>
               </a:rPr>
-              <a:t>SCOB Night-Sky Dashboard  ·  Volunteer User Guide  ·  v3.42</a:t>
+              <a:t>SCOB Night-Sky Dashboard  ·  Volunteer User Guide  ·  v3.43</a:t>
             </a:r>
           </a:p>
         </p:txBody>
@@ -10020,7 +10020,7 @@
                 </a:solidFill>
                 <a:latin typeface="Calibri"/>
               </a:rPr>
-              <a:t>SCOB Night-Sky Dashboard  ·  Volunteer User Guide  ·  v3.42</a:t>
+              <a:t>SCOB Night-Sky Dashboard  ·  Volunteer User Guide  ·  v3.43</a:t>
             </a:r>
           </a:p>
         </p:txBody>
@@ -11192,7 +11192,7 @@
                 </a:solidFill>
                 <a:latin typeface="Calibri"/>
               </a:rPr>
-              <a:t>SCOB Night-Sky Dashboard  ·  Volunteer User Guide  ·  v3.42</a:t>
+              <a:t>SCOB Night-Sky Dashboard  ·  Volunteer User Guide  ·  v3.43</a:t>
             </a:r>
           </a:p>
         </p:txBody>
@@ -12373,7 +12373,7 @@
                 </a:solidFill>
                 <a:latin typeface="Calibri"/>
               </a:rPr>
-              <a:t>SCOB Night-Sky Dashboard  ·  Volunteer User Guide  ·  v3.42</a:t>
+              <a:t>SCOB Night-Sky Dashboard  ·  Volunteer User Guide  ·  v3.43</a:t>
             </a:r>
           </a:p>
         </p:txBody>
@@ -13161,7 +13161,7 @@
                 </a:solidFill>
                 <a:latin typeface="Calibri"/>
               </a:rPr>
-              <a:t>SCOB Night-Sky Dashboard  ·  Volunteer User Guide  ·  v3.42</a:t>
+              <a:t>SCOB Night-Sky Dashboard  ·  Volunteer User Guide  ·  v3.43</a:t>
             </a:r>
           </a:p>
         </p:txBody>
@@ -13930,7 +13930,7 @@
                 </a:solidFill>
                 <a:latin typeface="Calibri"/>
               </a:rPr>
-              <a:t>SCOB Night-Sky Dashboard  ·  Volunteer User Guide  ·  v3.42</a:t>
+              <a:t>SCOB Night-Sky Dashboard  ·  Volunteer User Guide  ·  v3.43</a:t>
             </a:r>
           </a:p>
         </p:txBody>
@@ -14899,7 +14899,7 @@
                 </a:solidFill>
                 <a:latin typeface="Calibri"/>
               </a:rPr>
-              <a:t>SCOB Night-Sky Dashboard  ·  Volunteer User Guide  ·  v3.42</a:t>
+              <a:t>SCOB Night-Sky Dashboard  ·  Volunteer User Guide  ·  v3.43</a:t>
             </a:r>
           </a:p>
         </p:txBody>
@@ -15787,7 +15787,7 @@
                 </a:solidFill>
                 <a:latin typeface="Calibri"/>
               </a:rPr>
-              <a:t>SCOB Night-Sky Dashboard  ·  Volunteer User Guide  ·  v3.42</a:t>
+              <a:t>SCOB Night-Sky Dashboard  ·  Volunteer User Guide  ·  v3.43</a:t>
             </a:r>
           </a:p>
         </p:txBody>
@@ -16751,7 +16751,7 @@
                 </a:solidFill>
                 <a:latin typeface="Calibri"/>
               </a:rPr>
-              <a:t>SCOB Night-Sky Dashboard  ·  Volunteer User Guide  ·  v3.42</a:t>
+              <a:t>SCOB Night-Sky Dashboard  ·  Volunteer User Guide  ·  v3.43</a:t>
             </a:r>
           </a:p>
         </p:txBody>
@@ -17619,7 +17619,7 @@
                 </a:solidFill>
                 <a:latin typeface="Calibri"/>
               </a:rPr>
-              <a:t>SCOB Night-Sky Dashboard  ·  Volunteer User Guide  ·  v3.42</a:t>
+              <a:t>SCOB Night-Sky Dashboard  ·  Volunteer User Guide  ·  v3.43</a:t>
             </a:r>
           </a:p>
         </p:txBody>
@@ -18691,7 +18691,7 @@
                 </a:solidFill>
                 <a:latin typeface="Calibri"/>
               </a:rPr>
-              <a:t>SCOB Night-Sky Dashboard  ·  Volunteer User Guide  ·  v3.42</a:t>
+              <a:t>SCOB Night-Sky Dashboard  ·  Volunteer User Guide  ·  v3.43</a:t>
             </a:r>
           </a:p>
         </p:txBody>
@@ -19407,7 +19407,7 @@
                 </a:solidFill>
                 <a:latin typeface="Calibri"/>
               </a:rPr>
-              <a:t>SCOB Night-Sky Dashboard  ·  Volunteer User Guide  ·  v3.42</a:t>
+              <a:t>SCOB Night-Sky Dashboard  ·  Volunteer User Guide  ·  v3.43</a:t>
             </a:r>
           </a:p>
         </p:txBody>
@@ -20554,7 +20554,7 @@
                 </a:solidFill>
                 <a:latin typeface="Calibri"/>
               </a:rPr>
-              <a:t>SCOB Night-Sky Dashboard  ·  Volunteer User Guide  ·  v3.42</a:t>
+              <a:t>SCOB Night-Sky Dashboard  ·  Volunteer User Guide  ·  v3.43</a:t>
             </a:r>
           </a:p>
         </p:txBody>
@@ -21701,7 +21701,7 @@
                 </a:solidFill>
                 <a:latin typeface="Calibri"/>
               </a:rPr>
-              <a:t>SCOB Night-Sky Dashboard  ·  Volunteer User Guide  ·  v3.42</a:t>
+              <a:t>SCOB Night-Sky Dashboard  ·  Volunteer User Guide  ·  v3.43</a:t>
             </a:r>
           </a:p>
         </p:txBody>
@@ -22848,7 +22848,7 @@
                 </a:solidFill>
                 <a:latin typeface="Calibri"/>
               </a:rPr>
-              <a:t>SCOB Night-Sky Dashboard  ·  Volunteer User Guide  ·  v3.42</a:t>
+              <a:t>SCOB Night-Sky Dashboard  ·  Volunteer User Guide  ·  v3.43</a:t>
             </a:r>
           </a:p>
         </p:txBody>
@@ -23995,7 +23995,7 @@
                 </a:solidFill>
                 <a:latin typeface="Calibri"/>
               </a:rPr>
-              <a:t>SCOB Night-Sky Dashboard  ·  Volunteer User Guide  ·  v3.42</a:t>
+              <a:t>SCOB Night-Sky Dashboard  ·  Volunteer User Guide  ·  v3.43</a:t>
             </a:r>
           </a:p>
         </p:txBody>
@@ -25142,7 +25142,7 @@
                 </a:solidFill>
                 <a:latin typeface="Calibri"/>
               </a:rPr>
-              <a:t>SCOB Night-Sky Dashboard  ·  Volunteer User Guide  ·  v3.42</a:t>
+              <a:t>SCOB Night-Sky Dashboard  ·  Volunteer User Guide  ·  v3.43</a:t>
             </a:r>
           </a:p>
         </p:txBody>
@@ -26289,7 +26289,7 @@
                 </a:solidFill>
                 <a:latin typeface="Calibri"/>
               </a:rPr>
-              <a:t>SCOB Night-Sky Dashboard  ·  Volunteer User Guide  ·  v3.42</a:t>
+              <a:t>SCOB Night-Sky Dashboard  ·  Volunteer User Guide  ·  v3.43</a:t>
             </a:r>
           </a:p>
         </p:txBody>
@@ -27436,7 +27436,7 @@
                 </a:solidFill>
                 <a:latin typeface="Calibri"/>
               </a:rPr>
-              <a:t>SCOB Night-Sky Dashboard  ·  Volunteer User Guide  ·  v3.42</a:t>
+              <a:t>SCOB Night-Sky Dashboard  ·  Volunteer User Guide  ·  v3.43</a:t>
             </a:r>
           </a:p>
         </p:txBody>
@@ -28598,7 +28598,7 @@
                 </a:solidFill>
                 <a:latin typeface="Calibri"/>
               </a:rPr>
-              <a:t>SCOB Night-Sky Dashboard  ·  Volunteer User Guide  ·  v3.42</a:t>
+              <a:t>SCOB Night-Sky Dashboard  ·  Volunteer User Guide  ·  v3.43</a:t>
             </a:r>
           </a:p>
         </p:txBody>
@@ -29406,7 +29406,7 @@
                 </a:solidFill>
                 <a:latin typeface="Calibri"/>
               </a:rPr>
-              <a:t>SCOB Night-Sky Dashboard  ·  Volunteer User Guide  ·  v3.42</a:t>
+              <a:t>SCOB Night-Sky Dashboard  ·  Volunteer User Guide  ·  v3.43</a:t>
             </a:r>
           </a:p>
         </p:txBody>
@@ -30553,7 +30553,7 @@
                 </a:solidFill>
                 <a:latin typeface="Calibri"/>
               </a:rPr>
-              <a:t>SCOB Night-Sky Dashboard  ·  Volunteer User Guide  ·  v3.42</a:t>
+              <a:t>SCOB Night-Sky Dashboard  ·  Volunteer User Guide  ·  v3.43</a:t>
             </a:r>
           </a:p>
         </p:txBody>
@@ -31700,7 +31700,7 @@
                 </a:solidFill>
                 <a:latin typeface="Calibri"/>
               </a:rPr>
-              <a:t>SCOB Night-Sky Dashboard  ·  Volunteer User Guide  ·  v3.42</a:t>
+              <a:t>SCOB Night-Sky Dashboard  ·  Volunteer User Guide  ·  v3.43</a:t>
             </a:r>
           </a:p>
         </p:txBody>
@@ -32847,7 +32847,7 @@
                 </a:solidFill>
                 <a:latin typeface="Calibri"/>
               </a:rPr>
-              <a:t>SCOB Night-Sky Dashboard  ·  Volunteer User Guide  ·  v3.42</a:t>
+              <a:t>SCOB Night-Sky Dashboard  ·  Volunteer User Guide  ·  v3.43</a:t>
             </a:r>
           </a:p>
         </p:txBody>
@@ -33994,7 +33994,7 @@
                 </a:solidFill>
                 <a:latin typeface="Calibri"/>
               </a:rPr>
-              <a:t>SCOB Night-Sky Dashboard  ·  Volunteer User Guide  ·  v3.42</a:t>
+              <a:t>SCOB Night-Sky Dashboard  ·  Volunteer User Guide  ·  v3.43</a:t>
             </a:r>
           </a:p>
         </p:txBody>
@@ -35141,7 +35141,7 @@
                 </a:solidFill>
                 <a:latin typeface="Calibri"/>
               </a:rPr>
-              <a:t>SCOB Night-Sky Dashboard  ·  Volunteer User Guide  ·  v3.42</a:t>
+              <a:t>SCOB Night-Sky Dashboard  ·  Volunteer User Guide  ·  v3.43</a:t>
             </a:r>
           </a:p>
         </p:txBody>
@@ -36288,7 +36288,7 @@
                 </a:solidFill>
                 <a:latin typeface="Calibri"/>
               </a:rPr>
-              <a:t>SCOB Night-Sky Dashboard  ·  Volunteer User Guide  ·  v3.42</a:t>
+              <a:t>SCOB Night-Sky Dashboard  ·  Volunteer User Guide  ·  v3.43</a:t>
             </a:r>
           </a:p>
         </p:txBody>
@@ -37435,7 +37435,7 @@
                 </a:solidFill>
                 <a:latin typeface="Calibri"/>
               </a:rPr>
-              <a:t>SCOB Night-Sky Dashboard  ·  Volunteer User Guide  ·  v3.42</a:t>
+              <a:t>SCOB Night-Sky Dashboard  ·  Volunteer User Guide  ·  v3.43</a:t>
             </a:r>
           </a:p>
         </p:txBody>
@@ -38582,7 +38582,7 @@
                 </a:solidFill>
                 <a:latin typeface="Calibri"/>
               </a:rPr>
-              <a:t>SCOB Night-Sky Dashboard  ·  Volunteer User Guide  ·  v3.42</a:t>
+              <a:t>SCOB Night-Sky Dashboard  ·  Volunteer User Guide  ·  v3.43</a:t>
             </a:r>
           </a:p>
         </p:txBody>
@@ -43066,7 +43066,7 @@
                 </a:solidFill>
                 <a:latin typeface="Calibri"/>
               </a:rPr>
-              <a:t>SCOB Night-Sky Dashboard  ·  Volunteer User Guide  ·  v3.42</a:t>
+              <a:t>SCOB Night-Sky Dashboard  ·  Volunteer User Guide  ·  v3.43</a:t>
             </a:r>
           </a:p>
         </p:txBody>
@@ -44228,7 +44228,7 @@
                 </a:solidFill>
                 <a:latin typeface="Calibri"/>
               </a:rPr>
-              <a:t>SCOB Night-Sky Dashboard  ·  Volunteer User Guide  ·  v3.42</a:t>
+              <a:t>SCOB Night-Sky Dashboard  ·  Volunteer User Guide  ·  v3.43</a:t>
             </a:r>
           </a:p>
         </p:txBody>
@@ -45376,7 +45376,7 @@
                 </a:solidFill>
                 <a:latin typeface="Calibri"/>
               </a:rPr>
-              <a:t>SCOB Night-Sky Dashboard  ·  Volunteer User Guide  ·  v3.42</a:t>
+              <a:t>SCOB Night-Sky Dashboard  ·  Volunteer User Guide  ·  v3.43</a:t>
             </a:r>
           </a:p>
         </p:txBody>
@@ -48135,7 +48135,7 @@
                 </a:solidFill>
                 <a:latin typeface="Calibri"/>
               </a:rPr>
-              <a:t>SCOB Night-Sky Dashboard  ·  Volunteer User Guide  ·  v3.42</a:t>
+              <a:t>SCOB Night-Sky Dashboard  ·  Volunteer User Guide  ·  v3.43</a:t>
             </a:r>
           </a:p>
         </p:txBody>
@@ -49138,7 +49138,7 @@
                 </a:solidFill>
                 <a:latin typeface="Calibri"/>
               </a:rPr>
-              <a:t>SCOB Night-Sky Dashboard  ·  Volunteer User Guide  ·  v3.42</a:t>
+              <a:t>SCOB Night-Sky Dashboard  ·  Volunteer User Guide  ·  v3.43</a:t>
             </a:r>
           </a:p>
         </p:txBody>
@@ -52175,7 +52175,7 @@
                 </a:solidFill>
                 <a:latin typeface="Calibri"/>
               </a:rPr>
-              <a:t>SCOB Night-Sky Dashboard  ·  Volunteer User Guide  ·  v3.42</a:t>
+              <a:t>SCOB Night-Sky Dashboard  ·  Volunteer User Guide  ·  v3.43</a:t>
             </a:r>
           </a:p>
         </p:txBody>

</xml_diff>

<commit_message>
change to footer to reflect true URL pointing
</commit_message>
<xml_diff>
--- a/SCOB-Dashboard-User-Guide.pptx
+++ b/SCOB-Dashboard-User-Guide.pptx
@@ -6631,7 +6631,7 @@
                 </a:solidFill>
                 <a:latin typeface="Calibri"/>
               </a:rPr>
-              <a:t>Version 3.43  ·  Updated weekly, ahead of the session</a:t>
+              <a:t>Version 3.44  ·  Updated weekly, ahead of the session</a:t>
             </a:r>
           </a:p>
         </p:txBody>
@@ -6881,7 +6881,7 @@
                 </a:solidFill>
                 <a:latin typeface="Calibri"/>
               </a:rPr>
-              <a:t>SCOB Night-Sky Dashboard  ·  Volunteer User Guide  ·  v3.43</a:t>
+              <a:t>SCOB Night-Sky Dashboard  ·  Volunteer User Guide  ·  v3.44</a:t>
             </a:r>
           </a:p>
         </p:txBody>
@@ -8115,7 +8115,7 @@
                 </a:solidFill>
                 <a:latin typeface="Calibri"/>
               </a:rPr>
-              <a:t>SCOB Night-Sky Dashboard  ·  Volunteer User Guide  ·  v3.43</a:t>
+              <a:t>SCOB Night-Sky Dashboard  ·  Volunteer User Guide  ·  v3.44</a:t>
             </a:r>
           </a:p>
         </p:txBody>
@@ -9233,7 +9233,7 @@
                 </a:solidFill>
                 <a:latin typeface="Calibri"/>
               </a:rPr>
-              <a:t>SCOB Night-Sky Dashboard  ·  Volunteer User Guide  ·  v3.43</a:t>
+              <a:t>SCOB Night-Sky Dashboard  ·  Volunteer User Guide  ·  v3.44</a:t>
             </a:r>
           </a:p>
         </p:txBody>
@@ -10020,7 +10020,7 @@
                 </a:solidFill>
                 <a:latin typeface="Calibri"/>
               </a:rPr>
-              <a:t>SCOB Night-Sky Dashboard  ·  Volunteer User Guide  ·  v3.43</a:t>
+              <a:t>SCOB Night-Sky Dashboard  ·  Volunteer User Guide  ·  v3.44</a:t>
             </a:r>
           </a:p>
         </p:txBody>
@@ -11192,7 +11192,7 @@
                 </a:solidFill>
                 <a:latin typeface="Calibri"/>
               </a:rPr>
-              <a:t>SCOB Night-Sky Dashboard  ·  Volunteer User Guide  ·  v3.43</a:t>
+              <a:t>SCOB Night-Sky Dashboard  ·  Volunteer User Guide  ·  v3.44</a:t>
             </a:r>
           </a:p>
         </p:txBody>
@@ -12373,7 +12373,7 @@
                 </a:solidFill>
                 <a:latin typeface="Calibri"/>
               </a:rPr>
-              <a:t>SCOB Night-Sky Dashboard  ·  Volunteer User Guide  ·  v3.43</a:t>
+              <a:t>SCOB Night-Sky Dashboard  ·  Volunteer User Guide  ·  v3.44</a:t>
             </a:r>
           </a:p>
         </p:txBody>
@@ -13161,7 +13161,7 @@
                 </a:solidFill>
                 <a:latin typeface="Calibri"/>
               </a:rPr>
-              <a:t>SCOB Night-Sky Dashboard  ·  Volunteer User Guide  ·  v3.43</a:t>
+              <a:t>SCOB Night-Sky Dashboard  ·  Volunteer User Guide  ·  v3.44</a:t>
             </a:r>
           </a:p>
         </p:txBody>
@@ -13930,7 +13930,7 @@
                 </a:solidFill>
                 <a:latin typeface="Calibri"/>
               </a:rPr>
-              <a:t>SCOB Night-Sky Dashboard  ·  Volunteer User Guide  ·  v3.43</a:t>
+              <a:t>SCOB Night-Sky Dashboard  ·  Volunteer User Guide  ·  v3.44</a:t>
             </a:r>
           </a:p>
         </p:txBody>
@@ -14899,7 +14899,7 @@
                 </a:solidFill>
                 <a:latin typeface="Calibri"/>
               </a:rPr>
-              <a:t>SCOB Night-Sky Dashboard  ·  Volunteer User Guide  ·  v3.43</a:t>
+              <a:t>SCOB Night-Sky Dashboard  ·  Volunteer User Guide  ·  v3.44</a:t>
             </a:r>
           </a:p>
         </p:txBody>
@@ -15787,7 +15787,7 @@
                 </a:solidFill>
                 <a:latin typeface="Calibri"/>
               </a:rPr>
-              <a:t>SCOB Night-Sky Dashboard  ·  Volunteer User Guide  ·  v3.43</a:t>
+              <a:t>SCOB Night-Sky Dashboard  ·  Volunteer User Guide  ·  v3.44</a:t>
             </a:r>
           </a:p>
         </p:txBody>
@@ -16751,7 +16751,7 @@
                 </a:solidFill>
                 <a:latin typeface="Calibri"/>
               </a:rPr>
-              <a:t>SCOB Night-Sky Dashboard  ·  Volunteer User Guide  ·  v3.43</a:t>
+              <a:t>SCOB Night-Sky Dashboard  ·  Volunteer User Guide  ·  v3.44</a:t>
             </a:r>
           </a:p>
         </p:txBody>
@@ -17619,7 +17619,7 @@
                 </a:solidFill>
                 <a:latin typeface="Calibri"/>
               </a:rPr>
-              <a:t>SCOB Night-Sky Dashboard  ·  Volunteer User Guide  ·  v3.43</a:t>
+              <a:t>SCOB Night-Sky Dashboard  ·  Volunteer User Guide  ·  v3.44</a:t>
             </a:r>
           </a:p>
         </p:txBody>
@@ -18691,7 +18691,7 @@
                 </a:solidFill>
                 <a:latin typeface="Calibri"/>
               </a:rPr>
-              <a:t>SCOB Night-Sky Dashboard  ·  Volunteer User Guide  ·  v3.43</a:t>
+              <a:t>SCOB Night-Sky Dashboard  ·  Volunteer User Guide  ·  v3.44</a:t>
             </a:r>
           </a:p>
         </p:txBody>
@@ -19407,7 +19407,7 @@
                 </a:solidFill>
                 <a:latin typeface="Calibri"/>
               </a:rPr>
-              <a:t>SCOB Night-Sky Dashboard  ·  Volunteer User Guide  ·  v3.43</a:t>
+              <a:t>SCOB Night-Sky Dashboard  ·  Volunteer User Guide  ·  v3.44</a:t>
             </a:r>
           </a:p>
         </p:txBody>
@@ -20554,7 +20554,7 @@
                 </a:solidFill>
                 <a:latin typeface="Calibri"/>
               </a:rPr>
-              <a:t>SCOB Night-Sky Dashboard  ·  Volunteer User Guide  ·  v3.43</a:t>
+              <a:t>SCOB Night-Sky Dashboard  ·  Volunteer User Guide  ·  v3.44</a:t>
             </a:r>
           </a:p>
         </p:txBody>
@@ -21701,7 +21701,7 @@
                 </a:solidFill>
                 <a:latin typeface="Calibri"/>
               </a:rPr>
-              <a:t>SCOB Night-Sky Dashboard  ·  Volunteer User Guide  ·  v3.43</a:t>
+              <a:t>SCOB Night-Sky Dashboard  ·  Volunteer User Guide  ·  v3.44</a:t>
             </a:r>
           </a:p>
         </p:txBody>
@@ -22848,7 +22848,7 @@
                 </a:solidFill>
                 <a:latin typeface="Calibri"/>
               </a:rPr>
-              <a:t>SCOB Night-Sky Dashboard  ·  Volunteer User Guide  ·  v3.43</a:t>
+              <a:t>SCOB Night-Sky Dashboard  ·  Volunteer User Guide  ·  v3.44</a:t>
             </a:r>
           </a:p>
         </p:txBody>
@@ -23995,7 +23995,7 @@
                 </a:solidFill>
                 <a:latin typeface="Calibri"/>
               </a:rPr>
-              <a:t>SCOB Night-Sky Dashboard  ·  Volunteer User Guide  ·  v3.43</a:t>
+              <a:t>SCOB Night-Sky Dashboard  ·  Volunteer User Guide  ·  v3.44</a:t>
             </a:r>
           </a:p>
         </p:txBody>
@@ -25142,7 +25142,7 @@
                 </a:solidFill>
                 <a:latin typeface="Calibri"/>
               </a:rPr>
-              <a:t>SCOB Night-Sky Dashboard  ·  Volunteer User Guide  ·  v3.43</a:t>
+              <a:t>SCOB Night-Sky Dashboard  ·  Volunteer User Guide  ·  v3.44</a:t>
             </a:r>
           </a:p>
         </p:txBody>
@@ -26289,7 +26289,7 @@
                 </a:solidFill>
                 <a:latin typeface="Calibri"/>
               </a:rPr>
-              <a:t>SCOB Night-Sky Dashboard  ·  Volunteer User Guide  ·  v3.43</a:t>
+              <a:t>SCOB Night-Sky Dashboard  ·  Volunteer User Guide  ·  v3.44</a:t>
             </a:r>
           </a:p>
         </p:txBody>
@@ -27436,7 +27436,7 @@
                 </a:solidFill>
                 <a:latin typeface="Calibri"/>
               </a:rPr>
-              <a:t>SCOB Night-Sky Dashboard  ·  Volunteer User Guide  ·  v3.43</a:t>
+              <a:t>SCOB Night-Sky Dashboard  ·  Volunteer User Guide  ·  v3.44</a:t>
             </a:r>
           </a:p>
         </p:txBody>
@@ -28598,7 +28598,7 @@
                 </a:solidFill>
                 <a:latin typeface="Calibri"/>
               </a:rPr>
-              <a:t>SCOB Night-Sky Dashboard  ·  Volunteer User Guide  ·  v3.43</a:t>
+              <a:t>SCOB Night-Sky Dashboard  ·  Volunteer User Guide  ·  v3.44</a:t>
             </a:r>
           </a:p>
         </p:txBody>
@@ -29406,7 +29406,7 @@
                 </a:solidFill>
                 <a:latin typeface="Calibri"/>
               </a:rPr>
-              <a:t>SCOB Night-Sky Dashboard  ·  Volunteer User Guide  ·  v3.43</a:t>
+              <a:t>SCOB Night-Sky Dashboard  ·  Volunteer User Guide  ·  v3.44</a:t>
             </a:r>
           </a:p>
         </p:txBody>
@@ -30553,7 +30553,7 @@
                 </a:solidFill>
                 <a:latin typeface="Calibri"/>
               </a:rPr>
-              <a:t>SCOB Night-Sky Dashboard  ·  Volunteer User Guide  ·  v3.43</a:t>
+              <a:t>SCOB Night-Sky Dashboard  ·  Volunteer User Guide  ·  v3.44</a:t>
             </a:r>
           </a:p>
         </p:txBody>
@@ -31700,7 +31700,7 @@
                 </a:solidFill>
                 <a:latin typeface="Calibri"/>
               </a:rPr>
-              <a:t>SCOB Night-Sky Dashboard  ·  Volunteer User Guide  ·  v3.43</a:t>
+              <a:t>SCOB Night-Sky Dashboard  ·  Volunteer User Guide  ·  v3.44</a:t>
             </a:r>
           </a:p>
         </p:txBody>
@@ -32847,7 +32847,7 @@
                 </a:solidFill>
                 <a:latin typeface="Calibri"/>
               </a:rPr>
-              <a:t>SCOB Night-Sky Dashboard  ·  Volunteer User Guide  ·  v3.43</a:t>
+              <a:t>SCOB Night-Sky Dashboard  ·  Volunteer User Guide  ·  v3.44</a:t>
             </a:r>
           </a:p>
         </p:txBody>
@@ -33994,7 +33994,7 @@
                 </a:solidFill>
                 <a:latin typeface="Calibri"/>
               </a:rPr>
-              <a:t>SCOB Night-Sky Dashboard  ·  Volunteer User Guide  ·  v3.43</a:t>
+              <a:t>SCOB Night-Sky Dashboard  ·  Volunteer User Guide  ·  v3.44</a:t>
             </a:r>
           </a:p>
         </p:txBody>
@@ -35141,7 +35141,7 @@
                 </a:solidFill>
                 <a:latin typeface="Calibri"/>
               </a:rPr>
-              <a:t>SCOB Night-Sky Dashboard  ·  Volunteer User Guide  ·  v3.43</a:t>
+              <a:t>SCOB Night-Sky Dashboard  ·  Volunteer User Guide  ·  v3.44</a:t>
             </a:r>
           </a:p>
         </p:txBody>
@@ -36288,7 +36288,7 @@
                 </a:solidFill>
                 <a:latin typeface="Calibri"/>
               </a:rPr>
-              <a:t>SCOB Night-Sky Dashboard  ·  Volunteer User Guide  ·  v3.43</a:t>
+              <a:t>SCOB Night-Sky Dashboard  ·  Volunteer User Guide  ·  v3.44</a:t>
             </a:r>
           </a:p>
         </p:txBody>
@@ -37435,7 +37435,7 @@
                 </a:solidFill>
                 <a:latin typeface="Calibri"/>
               </a:rPr>
-              <a:t>SCOB Night-Sky Dashboard  ·  Volunteer User Guide  ·  v3.43</a:t>
+              <a:t>SCOB Night-Sky Dashboard  ·  Volunteer User Guide  ·  v3.44</a:t>
             </a:r>
           </a:p>
         </p:txBody>
@@ -38582,7 +38582,7 @@
                 </a:solidFill>
                 <a:latin typeface="Calibri"/>
               </a:rPr>
-              <a:t>SCOB Night-Sky Dashboard  ·  Volunteer User Guide  ·  v3.43</a:t>
+              <a:t>SCOB Night-Sky Dashboard  ·  Volunteer User Guide  ·  v3.44</a:t>
             </a:r>
           </a:p>
         </p:txBody>
@@ -43066,7 +43066,7 @@
                 </a:solidFill>
                 <a:latin typeface="Calibri"/>
               </a:rPr>
-              <a:t>SCOB Night-Sky Dashboard  ·  Volunteer User Guide  ·  v3.43</a:t>
+              <a:t>SCOB Night-Sky Dashboard  ·  Volunteer User Guide  ·  v3.44</a:t>
             </a:r>
           </a:p>
         </p:txBody>
@@ -44228,7 +44228,7 @@
                 </a:solidFill>
                 <a:latin typeface="Calibri"/>
               </a:rPr>
-              <a:t>SCOB Night-Sky Dashboard  ·  Volunteer User Guide  ·  v3.43</a:t>
+              <a:t>SCOB Night-Sky Dashboard  ·  Volunteer User Guide  ·  v3.44</a:t>
             </a:r>
           </a:p>
         </p:txBody>
@@ -45376,7 +45376,7 @@
                 </a:solidFill>
                 <a:latin typeface="Calibri"/>
               </a:rPr>
-              <a:t>SCOB Night-Sky Dashboard  ·  Volunteer User Guide  ·  v3.43</a:t>
+              <a:t>SCOB Night-Sky Dashboard  ·  Volunteer User Guide  ·  v3.44</a:t>
             </a:r>
           </a:p>
         </p:txBody>
@@ -48135,7 +48135,7 @@
                 </a:solidFill>
                 <a:latin typeface="Calibri"/>
               </a:rPr>
-              <a:t>SCOB Night-Sky Dashboard  ·  Volunteer User Guide  ·  v3.43</a:t>
+              <a:t>SCOB Night-Sky Dashboard  ·  Volunteer User Guide  ·  v3.44</a:t>
             </a:r>
           </a:p>
         </p:txBody>
@@ -49138,7 +49138,7 @@
                 </a:solidFill>
                 <a:latin typeface="Calibri"/>
               </a:rPr>
-              <a:t>SCOB Night-Sky Dashboard  ·  Volunteer User Guide  ·  v3.43</a:t>
+              <a:t>SCOB Night-Sky Dashboard  ·  Volunteer User Guide  ·  v3.44</a:t>
             </a:r>
           </a:p>
         </p:txBody>
@@ -52175,7 +52175,7 @@
                 </a:solidFill>
                 <a:latin typeface="Calibri"/>
               </a:rPr>
-              <a:t>SCOB Night-Sky Dashboard  ·  Volunteer User Guide  ·  v3.43</a:t>
+              <a:t>SCOB Night-Sky Dashboard  ·  Volunteer User Guide  ·  v3.44</a:t>
             </a:r>
           </a:p>
         </p:txBody>

</xml_diff>

<commit_message>
credits update to imdependent page
</commit_message>
<xml_diff>
--- a/SCOB-Dashboard-User-Guide.pptx
+++ b/SCOB-Dashboard-User-Guide.pptx
@@ -45,6 +45,7 @@
     <p:sldId id="294" r:id="rId45"/>
     <p:sldId id="295" r:id="rId46"/>
     <p:sldId id="296" r:id="rId47"/>
+    <p:sldId id="297" r:id="rId48"/>
     <p:sldId id="277" r:id="rId24"/>
   </p:sldIdLst>
   <p:sldSz cx="12192000" cy="6858000"/>
@@ -6633,7 +6634,7 @@
                 </a:solidFill>
                 <a:latin typeface="Calibri"/>
               </a:rPr>
-              <a:t>Version 3.46  ·  Updated weekly, ahead of the session</a:t>
+              <a:t>Version 3.47  ·  Updated weekly, ahead of the session</a:t>
             </a:r>
           </a:p>
         </p:txBody>
@@ -6883,7 +6884,7 @@
                 </a:solidFill>
                 <a:latin typeface="Calibri"/>
               </a:rPr>
-              <a:t>SCOB Night-Sky Dashboard  ·  Volunteer User Guide  ·  v3.46</a:t>
+              <a:t>SCOB Night-Sky Dashboard  ·  Volunteer User Guide  ·  v3.47</a:t>
             </a:r>
           </a:p>
         </p:txBody>
@@ -8117,7 +8118,7 @@
                 </a:solidFill>
                 <a:latin typeface="Calibri"/>
               </a:rPr>
-              <a:t>SCOB Night-Sky Dashboard  ·  Volunteer User Guide  ·  v3.46</a:t>
+              <a:t>SCOB Night-Sky Dashboard  ·  Volunteer User Guide  ·  v3.47</a:t>
             </a:r>
           </a:p>
         </p:txBody>
@@ -9235,7 +9236,7 @@
                 </a:solidFill>
                 <a:latin typeface="Calibri"/>
               </a:rPr>
-              <a:t>SCOB Night-Sky Dashboard  ·  Volunteer User Guide  ·  v3.46</a:t>
+              <a:t>SCOB Night-Sky Dashboard  ·  Volunteer User Guide  ·  v3.47</a:t>
             </a:r>
           </a:p>
         </p:txBody>
@@ -10022,7 +10023,7 @@
                 </a:solidFill>
                 <a:latin typeface="Calibri"/>
               </a:rPr>
-              <a:t>SCOB Night-Sky Dashboard  ·  Volunteer User Guide  ·  v3.46</a:t>
+              <a:t>SCOB Night-Sky Dashboard  ·  Volunteer User Guide  ·  v3.47</a:t>
             </a:r>
           </a:p>
         </p:txBody>
@@ -11194,7 +11195,7 @@
                 </a:solidFill>
                 <a:latin typeface="Calibri"/>
               </a:rPr>
-              <a:t>SCOB Night-Sky Dashboard  ·  Volunteer User Guide  ·  v3.46</a:t>
+              <a:t>SCOB Night-Sky Dashboard  ·  Volunteer User Guide  ·  v3.47</a:t>
             </a:r>
           </a:p>
         </p:txBody>
@@ -12375,7 +12376,7 @@
                 </a:solidFill>
                 <a:latin typeface="Calibri"/>
               </a:rPr>
-              <a:t>SCOB Night-Sky Dashboard  ·  Volunteer User Guide  ·  v3.46</a:t>
+              <a:t>SCOB Night-Sky Dashboard  ·  Volunteer User Guide  ·  v3.47</a:t>
             </a:r>
           </a:p>
         </p:txBody>
@@ -13163,7 +13164,7 @@
                 </a:solidFill>
                 <a:latin typeface="Calibri"/>
               </a:rPr>
-              <a:t>SCOB Night-Sky Dashboard  ·  Volunteer User Guide  ·  v3.46</a:t>
+              <a:t>SCOB Night-Sky Dashboard  ·  Volunteer User Guide  ·  v3.47</a:t>
             </a:r>
           </a:p>
         </p:txBody>
@@ -13932,7 +13933,7 @@
                 </a:solidFill>
                 <a:latin typeface="Calibri"/>
               </a:rPr>
-              <a:t>SCOB Night-Sky Dashboard  ·  Volunteer User Guide  ·  v3.46</a:t>
+              <a:t>SCOB Night-Sky Dashboard  ·  Volunteer User Guide  ·  v3.47</a:t>
             </a:r>
           </a:p>
         </p:txBody>
@@ -14901,7 +14902,7 @@
                 </a:solidFill>
                 <a:latin typeface="Calibri"/>
               </a:rPr>
-              <a:t>SCOB Night-Sky Dashboard  ·  Volunteer User Guide  ·  v3.46</a:t>
+              <a:t>SCOB Night-Sky Dashboard  ·  Volunteer User Guide  ·  v3.47</a:t>
             </a:r>
           </a:p>
         </p:txBody>
@@ -15789,7 +15790,7 @@
                 </a:solidFill>
                 <a:latin typeface="Calibri"/>
               </a:rPr>
-              <a:t>SCOB Night-Sky Dashboard  ·  Volunteer User Guide  ·  v3.46</a:t>
+              <a:t>SCOB Night-Sky Dashboard  ·  Volunteer User Guide  ·  v3.47</a:t>
             </a:r>
           </a:p>
         </p:txBody>
@@ -16753,7 +16754,7 @@
                 </a:solidFill>
                 <a:latin typeface="Calibri"/>
               </a:rPr>
-              <a:t>SCOB Night-Sky Dashboard  ·  Volunteer User Guide  ·  v3.46</a:t>
+              <a:t>SCOB Night-Sky Dashboard  ·  Volunteer User Guide  ·  v3.47</a:t>
             </a:r>
           </a:p>
         </p:txBody>
@@ -17621,7 +17622,7 @@
                 </a:solidFill>
                 <a:latin typeface="Calibri"/>
               </a:rPr>
-              <a:t>SCOB Night-Sky Dashboard  ·  Volunteer User Guide  ·  v3.46</a:t>
+              <a:t>SCOB Night-Sky Dashboard  ·  Volunteer User Guide  ·  v3.47</a:t>
             </a:r>
           </a:p>
         </p:txBody>
@@ -18693,7 +18694,7 @@
                 </a:solidFill>
                 <a:latin typeface="Calibri"/>
               </a:rPr>
-              <a:t>SCOB Night-Sky Dashboard  ·  Volunteer User Guide  ·  v3.46</a:t>
+              <a:t>SCOB Night-Sky Dashboard  ·  Volunteer User Guide  ·  v3.47</a:t>
             </a:r>
           </a:p>
         </p:txBody>
@@ -19409,7 +19410,7 @@
                 </a:solidFill>
                 <a:latin typeface="Calibri"/>
               </a:rPr>
-              <a:t>SCOB Night-Sky Dashboard  ·  Volunteer User Guide  ·  v3.46</a:t>
+              <a:t>SCOB Night-Sky Dashboard  ·  Volunteer User Guide  ·  v3.47</a:t>
             </a:r>
           </a:p>
         </p:txBody>
@@ -20556,7 +20557,7 @@
                 </a:solidFill>
                 <a:latin typeface="Calibri"/>
               </a:rPr>
-              <a:t>SCOB Night-Sky Dashboard  ·  Volunteer User Guide  ·  v3.46</a:t>
+              <a:t>SCOB Night-Sky Dashboard  ·  Volunteer User Guide  ·  v3.47</a:t>
             </a:r>
           </a:p>
         </p:txBody>
@@ -21703,7 +21704,7 @@
                 </a:solidFill>
                 <a:latin typeface="Calibri"/>
               </a:rPr>
-              <a:t>SCOB Night-Sky Dashboard  ·  Volunteer User Guide  ·  v3.46</a:t>
+              <a:t>SCOB Night-Sky Dashboard  ·  Volunteer User Guide  ·  v3.47</a:t>
             </a:r>
           </a:p>
         </p:txBody>
@@ -22850,7 +22851,7 @@
                 </a:solidFill>
                 <a:latin typeface="Calibri"/>
               </a:rPr>
-              <a:t>SCOB Night-Sky Dashboard  ·  Volunteer User Guide  ·  v3.46</a:t>
+              <a:t>SCOB Night-Sky Dashboard  ·  Volunteer User Guide  ·  v3.47</a:t>
             </a:r>
           </a:p>
         </p:txBody>
@@ -23997,7 +23998,7 @@
                 </a:solidFill>
                 <a:latin typeface="Calibri"/>
               </a:rPr>
-              <a:t>SCOB Night-Sky Dashboard  ·  Volunteer User Guide  ·  v3.46</a:t>
+              <a:t>SCOB Night-Sky Dashboard  ·  Volunteer User Guide  ·  v3.47</a:t>
             </a:r>
           </a:p>
         </p:txBody>
@@ -25144,7 +25145,7 @@
                 </a:solidFill>
                 <a:latin typeface="Calibri"/>
               </a:rPr>
-              <a:t>SCOB Night-Sky Dashboard  ·  Volunteer User Guide  ·  v3.46</a:t>
+              <a:t>SCOB Night-Sky Dashboard  ·  Volunteer User Guide  ·  v3.47</a:t>
             </a:r>
           </a:p>
         </p:txBody>
@@ -26291,7 +26292,7 @@
                 </a:solidFill>
                 <a:latin typeface="Calibri"/>
               </a:rPr>
-              <a:t>SCOB Night-Sky Dashboard  ·  Volunteer User Guide  ·  v3.46</a:t>
+              <a:t>SCOB Night-Sky Dashboard  ·  Volunteer User Guide  ·  v3.47</a:t>
             </a:r>
           </a:p>
         </p:txBody>
@@ -27438,7 +27439,7 @@
                 </a:solidFill>
                 <a:latin typeface="Calibri"/>
               </a:rPr>
-              <a:t>SCOB Night-Sky Dashboard  ·  Volunteer User Guide  ·  v3.46</a:t>
+              <a:t>SCOB Night-Sky Dashboard  ·  Volunteer User Guide  ·  v3.47</a:t>
             </a:r>
           </a:p>
         </p:txBody>
@@ -28600,7 +28601,7 @@
                 </a:solidFill>
                 <a:latin typeface="Calibri"/>
               </a:rPr>
-              <a:t>SCOB Night-Sky Dashboard  ·  Volunteer User Guide  ·  v3.46</a:t>
+              <a:t>SCOB Night-Sky Dashboard  ·  Volunteer User Guide  ·  v3.47</a:t>
             </a:r>
           </a:p>
         </p:txBody>
@@ -29408,7 +29409,7 @@
                 </a:solidFill>
                 <a:latin typeface="Calibri"/>
               </a:rPr>
-              <a:t>SCOB Night-Sky Dashboard  ·  Volunteer User Guide  ·  v3.46</a:t>
+              <a:t>SCOB Night-Sky Dashboard  ·  Volunteer User Guide  ·  v3.47</a:t>
             </a:r>
           </a:p>
         </p:txBody>
@@ -30555,7 +30556,7 @@
                 </a:solidFill>
                 <a:latin typeface="Calibri"/>
               </a:rPr>
-              <a:t>SCOB Night-Sky Dashboard  ·  Volunteer User Guide  ·  v3.46</a:t>
+              <a:t>SCOB Night-Sky Dashboard  ·  Volunteer User Guide  ·  v3.47</a:t>
             </a:r>
           </a:p>
         </p:txBody>
@@ -31702,7 +31703,7 @@
                 </a:solidFill>
                 <a:latin typeface="Calibri"/>
               </a:rPr>
-              <a:t>SCOB Night-Sky Dashboard  ·  Volunteer User Guide  ·  v3.46</a:t>
+              <a:t>SCOB Night-Sky Dashboard  ·  Volunteer User Guide  ·  v3.47</a:t>
             </a:r>
           </a:p>
         </p:txBody>
@@ -32849,7 +32850,7 @@
                 </a:solidFill>
                 <a:latin typeface="Calibri"/>
               </a:rPr>
-              <a:t>SCOB Night-Sky Dashboard  ·  Volunteer User Guide  ·  v3.46</a:t>
+              <a:t>SCOB Night-Sky Dashboard  ·  Volunteer User Guide  ·  v3.47</a:t>
             </a:r>
           </a:p>
         </p:txBody>
@@ -33996,7 +33997,7 @@
                 </a:solidFill>
                 <a:latin typeface="Calibri"/>
               </a:rPr>
-              <a:t>SCOB Night-Sky Dashboard  ·  Volunteer User Guide  ·  v3.46</a:t>
+              <a:t>SCOB Night-Sky Dashboard  ·  Volunteer User Guide  ·  v3.47</a:t>
             </a:r>
           </a:p>
         </p:txBody>
@@ -35143,7 +35144,7 @@
                 </a:solidFill>
                 <a:latin typeface="Calibri"/>
               </a:rPr>
-              <a:t>SCOB Night-Sky Dashboard  ·  Volunteer User Guide  ·  v3.46</a:t>
+              <a:t>SCOB Night-Sky Dashboard  ·  Volunteer User Guide  ·  v3.47</a:t>
             </a:r>
           </a:p>
         </p:txBody>
@@ -36290,7 +36291,7 @@
                 </a:solidFill>
                 <a:latin typeface="Calibri"/>
               </a:rPr>
-              <a:t>SCOB Night-Sky Dashboard  ·  Volunteer User Guide  ·  v3.46</a:t>
+              <a:t>SCOB Night-Sky Dashboard  ·  Volunteer User Guide  ·  v3.47</a:t>
             </a:r>
           </a:p>
         </p:txBody>
@@ -37437,7 +37438,7 @@
                 </a:solidFill>
                 <a:latin typeface="Calibri"/>
               </a:rPr>
-              <a:t>SCOB Night-Sky Dashboard  ·  Volunteer User Guide  ·  v3.46</a:t>
+              <a:t>SCOB Night-Sky Dashboard  ·  Volunteer User Guide  ·  v3.47</a:t>
             </a:r>
           </a:p>
         </p:txBody>
@@ -38584,7 +38585,7 @@
                 </a:solidFill>
                 <a:latin typeface="Calibri"/>
               </a:rPr>
-              <a:t>SCOB Night-Sky Dashboard  ·  Volunteer User Guide  ·  v3.46</a:t>
+              <a:t>SCOB Night-Sky Dashboard  ·  Volunteer User Guide  ·  v3.47</a:t>
             </a:r>
           </a:p>
         </p:txBody>
@@ -39731,7 +39732,7 @@
                 </a:solidFill>
                 <a:latin typeface="Calibri"/>
               </a:rPr>
-              <a:t>SCOB Night-Sky Dashboard  ·  Volunteer User Guide  ·  v3.46</a:t>
+              <a:t>SCOB Night-Sky Dashboard  ·  Volunteer User Guide  ·  v3.47</a:t>
             </a:r>
           </a:p>
         </p:txBody>
@@ -40893,7 +40894,7 @@
                 </a:solidFill>
                 <a:latin typeface="Calibri"/>
               </a:rPr>
-              <a:t>SCOB Night-Sky Dashboard  ·  Volunteer User Guide  ·  v3.46</a:t>
+              <a:t>SCOB Night-Sky Dashboard  ·  Volunteer User Guide  ·  v3.47</a:t>
             </a:r>
           </a:p>
         </p:txBody>
@@ -41856,6 +41857,1153 @@
 </file>
 
 <file path=ppt/slides/slide40.xml><?xml version="1.0" encoding="utf-8"?>
+<p:sld xmlns:a="http://schemas.openxmlformats.org/drawingml/2006/main" xmlns:p="http://schemas.openxmlformats.org/presentationml/2006/main" xmlns:r="http://schemas.openxmlformats.org/officeDocument/2006/relationships">
+  <p:cSld>
+    <p:spTree>
+      <p:nvGrpSpPr>
+        <p:cNvPr id="1" name=""/>
+        <p:cNvGrpSpPr/>
+        <p:nvPr/>
+      </p:nvGrpSpPr>
+      <p:grpSpPr/>
+      <p:sp>
+        <p:nvSpPr>
+          <p:cNvPr id="2" name="Oval 1"/>
+          <p:cNvSpPr/>
+          <p:nvPr/>
+        </p:nvSpPr>
+        <p:spPr>
+          <a:xfrm>
+            <a:off x="502920" y="457200"/>
+            <a:ext cx="146304" cy="146304"/>
+          </a:xfrm>
+          <a:prstGeom prst="ellipse">
+            <a:avLst/>
+          </a:prstGeom>
+          <a:solidFill>
+            <a:srgbClr val="E0A930"/>
+          </a:solidFill>
+          <a:ln>
+            <a:noFill/>
+          </a:ln>
+          <a:effectLst/>
+        </p:spPr>
+        <p:style>
+          <a:lnRef idx="1">
+            <a:schemeClr val="accent1"/>
+          </a:lnRef>
+          <a:fillRef idx="3">
+            <a:schemeClr val="accent1"/>
+          </a:fillRef>
+          <a:effectRef idx="2">
+            <a:schemeClr val="accent1"/>
+          </a:effectRef>
+          <a:fontRef idx="minor">
+            <a:schemeClr val="lt1"/>
+          </a:fontRef>
+        </p:style>
+        <p:txBody>
+          <a:bodyPr wrap="none" lIns="0" tIns="0" rIns="0" bIns="0" rtlCol="0" anchor="ctr"/>
+          <a:lstStyle/>
+          <a:p>
+            <a:pPr algn="ctr"/>
+            <a:endParaRPr/>
+          </a:p>
+        </p:txBody>
+      </p:sp>
+      <p:sp>
+        <p:nvSpPr>
+          <p:cNvPr id="3" name="TextBox 2"/>
+          <p:cNvSpPr txBox="1"/>
+          <p:nvPr/>
+        </p:nvSpPr>
+        <p:spPr>
+          <a:xfrm>
+            <a:off x="731520" y="384048"/>
+            <a:ext cx="7315200" cy="274320"/>
+          </a:xfrm>
+          <a:prstGeom prst="rect">
+            <a:avLst/>
+          </a:prstGeom>
+          <a:noFill/>
+        </p:spPr>
+        <p:txBody>
+          <a:bodyPr wrap="square" lIns="0" tIns="0" rIns="0" bIns="0" anchor="t">
+            <a:spAutoFit/>
+          </a:bodyPr>
+          <a:lstStyle/>
+          <a:p>
+            <a:pPr algn="l">
+              <a:lnSpc>
+                <a:spcPct val="100000"/>
+              </a:lnSpc>
+              <a:spcBef>
+                <a:spcPts val="0"/>
+              </a:spcBef>
+              <a:spcAft>
+                <a:spcPts val="400"/>
+              </a:spcAft>
+            </a:pPr>
+            <a:r>
+              <a:rPr sz="1100" b="1" i="0">
+                <a:solidFill>
+                  <a:srgbClr val="E0A930"/>
+                </a:solidFill>
+                <a:latin typeface="Calibri"/>
+              </a:rPr>
+              <a:t>WHAT’S NEW IN v3.46</a:t>
+            </a:r>
+          </a:p>
+        </p:txBody>
+      </p:sp>
+      <p:sp>
+        <p:nvSpPr>
+          <p:cNvPr id="4" name="TextBox 3"/>
+          <p:cNvSpPr txBox="1"/>
+          <p:nvPr/>
+        </p:nvSpPr>
+        <p:spPr>
+          <a:xfrm>
+            <a:off x="502920" y="658368"/>
+            <a:ext cx="10515600" cy="731520"/>
+          </a:xfrm>
+          <a:prstGeom prst="rect">
+            <a:avLst/>
+          </a:prstGeom>
+          <a:noFill/>
+        </p:spPr>
+        <p:txBody>
+          <a:bodyPr wrap="square" lIns="0" tIns="0" rIns="0" bIns="0" anchor="t">
+            <a:spAutoFit/>
+          </a:bodyPr>
+          <a:lstStyle/>
+          <a:p>
+            <a:pPr algn="l">
+              <a:lnSpc>
+                <a:spcPct val="100000"/>
+              </a:lnSpc>
+              <a:spcBef>
+                <a:spcPts val="0"/>
+              </a:spcBef>
+              <a:spcAft>
+                <a:spcPts val="400"/>
+              </a:spcAft>
+            </a:pPr>
+            <a:r>
+              <a:rPr sz="3000" b="1" i="0">
+                <a:solidFill>
+                  <a:srgbClr val="1B2A5B"/>
+                </a:solidFill>
+                <a:latin typeface="Cambria"/>
+              </a:rPr>
+              <a:t>Sky lore for all — and in Tamil</a:t>
+            </a:r>
+          </a:p>
+        </p:txBody>
+      </p:sp>
+      <p:sp>
+        <p:nvSpPr>
+          <p:cNvPr id="5" name="TextBox 4"/>
+          <p:cNvSpPr txBox="1"/>
+          <p:nvPr/>
+        </p:nvSpPr>
+        <p:spPr>
+          <a:xfrm>
+            <a:off x="502920" y="6455664"/>
+            <a:ext cx="8229600" cy="274320"/>
+          </a:xfrm>
+          <a:prstGeom prst="rect">
+            <a:avLst/>
+          </a:prstGeom>
+          <a:noFill/>
+        </p:spPr>
+        <p:txBody>
+          <a:bodyPr wrap="square" lIns="0" tIns="0" rIns="0" bIns="0" anchor="t">
+            <a:spAutoFit/>
+          </a:bodyPr>
+          <a:lstStyle/>
+          <a:p>
+            <a:pPr algn="l">
+              <a:lnSpc>
+                <a:spcPct val="100000"/>
+              </a:lnSpc>
+              <a:spcBef>
+                <a:spcPts val="0"/>
+              </a:spcBef>
+              <a:spcAft>
+                <a:spcPts val="400"/>
+              </a:spcAft>
+            </a:pPr>
+            <a:r>
+              <a:rPr sz="900" b="0" i="0">
+                <a:solidFill>
+                  <a:srgbClr val="9AA2B0"/>
+                </a:solidFill>
+                <a:latin typeface="Calibri"/>
+              </a:rPr>
+              <a:t>SCOB Night-Sky Dashboard  ·  Volunteer User Guide  ·  v3.47</a:t>
+            </a:r>
+          </a:p>
+        </p:txBody>
+      </p:sp>
+      <p:sp>
+        <p:nvSpPr>
+          <p:cNvPr id="6" name="TextBox 5"/>
+          <p:cNvSpPr txBox="1"/>
+          <p:nvPr/>
+        </p:nvSpPr>
+        <p:spPr>
+          <a:xfrm>
+            <a:off x="10607040" y="6455664"/>
+            <a:ext cx="1097280" cy="274320"/>
+          </a:xfrm>
+          <a:prstGeom prst="rect">
+            <a:avLst/>
+          </a:prstGeom>
+          <a:noFill/>
+        </p:spPr>
+        <p:txBody>
+          <a:bodyPr wrap="square" lIns="0" tIns="0" rIns="0" bIns="0" anchor="t">
+            <a:spAutoFit/>
+          </a:bodyPr>
+          <a:lstStyle/>
+          <a:p>
+            <a:pPr algn="r">
+              <a:lnSpc>
+                <a:spcPct val="100000"/>
+              </a:lnSpc>
+              <a:spcBef>
+                <a:spcPts val="0"/>
+              </a:spcBef>
+              <a:spcAft>
+                <a:spcPts val="400"/>
+              </a:spcAft>
+            </a:pPr>
+            <a:r>
+              <a:rPr sz="900" b="1" i="0">
+                <a:solidFill>
+                  <a:srgbClr val="9AA2B0"/>
+                </a:solidFill>
+                <a:latin typeface="Calibri"/>
+              </a:rPr>
+              <a:t>40</a:t>
+            </a:r>
+          </a:p>
+        </p:txBody>
+      </p:sp>
+      <p:sp>
+        <p:nvSpPr>
+          <p:cNvPr id="7" name="TextBox 6"/>
+          <p:cNvSpPr txBox="1"/>
+          <p:nvPr/>
+        </p:nvSpPr>
+        <p:spPr>
+          <a:xfrm>
+            <a:off x="502920" y="1554480"/>
+            <a:ext cx="10972800" cy="502920"/>
+          </a:xfrm>
+          <a:prstGeom prst="rect">
+            <a:avLst/>
+          </a:prstGeom>
+          <a:noFill/>
+        </p:spPr>
+        <p:txBody>
+          <a:bodyPr wrap="square" lIns="0" tIns="0" rIns="0" bIns="0" anchor="t">
+            <a:spAutoFit/>
+          </a:bodyPr>
+          <a:lstStyle/>
+          <a:p>
+            <a:pPr algn="l">
+              <a:lnSpc>
+                <a:spcPct val="125000"/>
+              </a:lnSpc>
+              <a:spcBef>
+                <a:spcPts val="0"/>
+              </a:spcBef>
+              <a:spcAft>
+                <a:spcPts val="400"/>
+              </a:spcAft>
+            </a:pPr>
+            <a:r>
+              <a:rPr sz="1450" b="0" i="0">
+                <a:solidFill>
+                  <a:srgbClr val="222833"/>
+                </a:solidFill>
+                <a:latin typeface="Calibri"/>
+              </a:rPr>
+              <a:t>The multicultural “same stars, around the world” lore now covers every one of the 16 constellations, with Tamil star-names added.</a:t>
+            </a:r>
+          </a:p>
+        </p:txBody>
+      </p:sp>
+      <p:sp>
+        <p:nvSpPr>
+          <p:cNvPr id="8" name="Rounded Rectangle 7"/>
+          <p:cNvSpPr/>
+          <p:nvPr/>
+        </p:nvSpPr>
+        <p:spPr>
+          <a:xfrm>
+            <a:off x="548640" y="2377440"/>
+            <a:ext cx="3611880" cy="1234440"/>
+          </a:xfrm>
+          <a:prstGeom prst="roundRect">
+            <a:avLst>
+              <a:gd name="adj" fmla="val 10000"/>
+            </a:avLst>
+          </a:prstGeom>
+          <a:solidFill>
+            <a:srgbClr val="F3F5FA"/>
+          </a:solidFill>
+          <a:ln>
+            <a:noFill/>
+          </a:ln>
+          <a:effectLst/>
+        </p:spPr>
+        <p:style>
+          <a:lnRef idx="1">
+            <a:schemeClr val="accent1"/>
+          </a:lnRef>
+          <a:fillRef idx="3">
+            <a:schemeClr val="accent1"/>
+          </a:fillRef>
+          <a:effectRef idx="2">
+            <a:schemeClr val="accent1"/>
+          </a:effectRef>
+          <a:fontRef idx="minor">
+            <a:schemeClr val="lt1"/>
+          </a:fontRef>
+        </p:style>
+        <p:txBody>
+          <a:bodyPr rtlCol="0" anchor="ctr"/>
+          <a:lstStyle/>
+          <a:p>
+            <a:pPr algn="ctr"/>
+            <a:endParaRPr/>
+          </a:p>
+        </p:txBody>
+      </p:sp>
+      <p:sp>
+        <p:nvSpPr>
+          <p:cNvPr id="9" name="TextBox 8"/>
+          <p:cNvSpPr txBox="1"/>
+          <p:nvPr/>
+        </p:nvSpPr>
+        <p:spPr>
+          <a:xfrm>
+            <a:off x="768096" y="2523744"/>
+            <a:ext cx="3200400" cy="365760"/>
+          </a:xfrm>
+          <a:prstGeom prst="rect">
+            <a:avLst/>
+          </a:prstGeom>
+          <a:noFill/>
+        </p:spPr>
+        <p:txBody>
+          <a:bodyPr wrap="square" lIns="0" tIns="0" rIns="0" bIns="0" anchor="t">
+            <a:spAutoFit/>
+          </a:bodyPr>
+          <a:lstStyle/>
+          <a:p>
+            <a:pPr algn="l">
+              <a:lnSpc>
+                <a:spcPct val="100000"/>
+              </a:lnSpc>
+              <a:spcBef>
+                <a:spcPts val="0"/>
+              </a:spcBef>
+              <a:spcAft>
+                <a:spcPts val="400"/>
+              </a:spcAft>
+            </a:pPr>
+            <a:r>
+              <a:rPr sz="1450" b="1" i="0">
+                <a:solidFill>
+                  <a:srgbClr val="1B2A5B"/>
+                </a:solidFill>
+                <a:latin typeface="Cambria"/>
+              </a:rPr>
+              <a:t>All 16 covered</a:t>
+            </a:r>
+          </a:p>
+        </p:txBody>
+      </p:sp>
+      <p:sp>
+        <p:nvSpPr>
+          <p:cNvPr id="10" name="TextBox 9"/>
+          <p:cNvSpPr txBox="1"/>
+          <p:nvPr/>
+        </p:nvSpPr>
+        <p:spPr>
+          <a:xfrm>
+            <a:off x="768096" y="2907792"/>
+            <a:ext cx="3200400" cy="640080"/>
+          </a:xfrm>
+          <a:prstGeom prst="rect">
+            <a:avLst/>
+          </a:prstGeom>
+          <a:noFill/>
+        </p:spPr>
+        <p:txBody>
+          <a:bodyPr wrap="square" lIns="0" tIns="0" rIns="0" bIns="0" anchor="t">
+            <a:spAutoFit/>
+          </a:bodyPr>
+          <a:lstStyle/>
+          <a:p>
+            <a:pPr algn="l">
+              <a:lnSpc>
+                <a:spcPct val="113000"/>
+              </a:lnSpc>
+              <a:spcBef>
+                <a:spcPts val="0"/>
+              </a:spcBef>
+              <a:spcAft>
+                <a:spcPts val="400"/>
+              </a:spcAft>
+            </a:pPr>
+            <a:r>
+              <a:rPr sz="1200" b="0" i="0">
+                <a:solidFill>
+                  <a:srgbClr val="636B7A"/>
+                </a:solidFill>
+                <a:latin typeface="Calibri"/>
+              </a:rPr>
+              <a:t>Every constellation on the page now shows its Chinese, Malay and Indian names beside the Greek myth — up from six.</a:t>
+            </a:r>
+          </a:p>
+        </p:txBody>
+      </p:sp>
+      <p:sp>
+        <p:nvSpPr>
+          <p:cNvPr id="11" name="Rounded Rectangle 10"/>
+          <p:cNvSpPr/>
+          <p:nvPr/>
+        </p:nvSpPr>
+        <p:spPr>
+          <a:xfrm>
+            <a:off x="4325112" y="2377440"/>
+            <a:ext cx="3611880" cy="1234440"/>
+          </a:xfrm>
+          <a:prstGeom prst="roundRect">
+            <a:avLst>
+              <a:gd name="adj" fmla="val 10000"/>
+            </a:avLst>
+          </a:prstGeom>
+          <a:solidFill>
+            <a:srgbClr val="F3F5FA"/>
+          </a:solidFill>
+          <a:ln>
+            <a:noFill/>
+          </a:ln>
+          <a:effectLst/>
+        </p:spPr>
+        <p:style>
+          <a:lnRef idx="1">
+            <a:schemeClr val="accent1"/>
+          </a:lnRef>
+          <a:fillRef idx="3">
+            <a:schemeClr val="accent1"/>
+          </a:fillRef>
+          <a:effectRef idx="2">
+            <a:schemeClr val="accent1"/>
+          </a:effectRef>
+          <a:fontRef idx="minor">
+            <a:schemeClr val="lt1"/>
+          </a:fontRef>
+        </p:style>
+        <p:txBody>
+          <a:bodyPr rtlCol="0" anchor="ctr"/>
+          <a:lstStyle/>
+          <a:p>
+            <a:pPr algn="ctr"/>
+            <a:endParaRPr/>
+          </a:p>
+        </p:txBody>
+      </p:sp>
+      <p:sp>
+        <p:nvSpPr>
+          <p:cNvPr id="12" name="TextBox 11"/>
+          <p:cNvSpPr txBox="1"/>
+          <p:nvPr/>
+        </p:nvSpPr>
+        <p:spPr>
+          <a:xfrm>
+            <a:off x="4544568" y="2523744"/>
+            <a:ext cx="3200400" cy="365760"/>
+          </a:xfrm>
+          <a:prstGeom prst="rect">
+            <a:avLst/>
+          </a:prstGeom>
+          <a:noFill/>
+        </p:spPr>
+        <p:txBody>
+          <a:bodyPr wrap="square" lIns="0" tIns="0" rIns="0" bIns="0" anchor="t">
+            <a:spAutoFit/>
+          </a:bodyPr>
+          <a:lstStyle/>
+          <a:p>
+            <a:pPr algn="l">
+              <a:lnSpc>
+                <a:spcPct val="100000"/>
+              </a:lnSpc>
+              <a:spcBef>
+                <a:spcPts val="0"/>
+              </a:spcBef>
+              <a:spcAft>
+                <a:spcPts val="400"/>
+              </a:spcAft>
+            </a:pPr>
+            <a:r>
+              <a:rPr sz="1450" b="1" i="0">
+                <a:solidFill>
+                  <a:srgbClr val="1B2A5B"/>
+                </a:solidFill>
+                <a:latin typeface="Cambria"/>
+              </a:rPr>
+              <a:t>The Qixi love story</a:t>
+            </a:r>
+          </a:p>
+        </p:txBody>
+      </p:sp>
+      <p:sp>
+        <p:nvSpPr>
+          <p:cNvPr id="13" name="TextBox 12"/>
+          <p:cNvSpPr txBox="1"/>
+          <p:nvPr/>
+        </p:nvSpPr>
+        <p:spPr>
+          <a:xfrm>
+            <a:off x="4544568" y="2907792"/>
+            <a:ext cx="3200400" cy="640080"/>
+          </a:xfrm>
+          <a:prstGeom prst="rect">
+            <a:avLst/>
+          </a:prstGeom>
+          <a:noFill/>
+        </p:spPr>
+        <p:txBody>
+          <a:bodyPr wrap="square" lIns="0" tIns="0" rIns="0" bIns="0" anchor="t">
+            <a:spAutoFit/>
+          </a:bodyPr>
+          <a:lstStyle/>
+          <a:p>
+            <a:pPr algn="l">
+              <a:lnSpc>
+                <a:spcPct val="113000"/>
+              </a:lnSpc>
+              <a:spcBef>
+                <a:spcPts val="0"/>
+              </a:spcBef>
+              <a:spcAft>
+                <a:spcPts val="400"/>
+              </a:spcAft>
+            </a:pPr>
+            <a:r>
+              <a:rPr sz="1200" b="0" i="0">
+                <a:solidFill>
+                  <a:srgbClr val="636B7A"/>
+                </a:solidFill>
+                <a:latin typeface="Calibri"/>
+              </a:rPr>
+              <a:t>Vega (the Weaving Girl), Altair (the Cowherd) and Cygnus (the Celestial Ford) tell the tale of lovers parted by the Milky Way, meeting once a year.</a:t>
+            </a:r>
+          </a:p>
+        </p:txBody>
+      </p:sp>
+      <p:sp>
+        <p:nvSpPr>
+          <p:cNvPr id="14" name="Rounded Rectangle 13"/>
+          <p:cNvSpPr/>
+          <p:nvPr/>
+        </p:nvSpPr>
+        <p:spPr>
+          <a:xfrm>
+            <a:off x="8101583" y="2377440"/>
+            <a:ext cx="3611880" cy="1234440"/>
+          </a:xfrm>
+          <a:prstGeom prst="roundRect">
+            <a:avLst>
+              <a:gd name="adj" fmla="val 10000"/>
+            </a:avLst>
+          </a:prstGeom>
+          <a:solidFill>
+            <a:srgbClr val="F3F5FA"/>
+          </a:solidFill>
+          <a:ln>
+            <a:noFill/>
+          </a:ln>
+          <a:effectLst/>
+        </p:spPr>
+        <p:style>
+          <a:lnRef idx="1">
+            <a:schemeClr val="accent1"/>
+          </a:lnRef>
+          <a:fillRef idx="3">
+            <a:schemeClr val="accent1"/>
+          </a:fillRef>
+          <a:effectRef idx="2">
+            <a:schemeClr val="accent1"/>
+          </a:effectRef>
+          <a:fontRef idx="minor">
+            <a:schemeClr val="lt1"/>
+          </a:fontRef>
+        </p:style>
+        <p:txBody>
+          <a:bodyPr rtlCol="0" anchor="ctr"/>
+          <a:lstStyle/>
+          <a:p>
+            <a:pPr algn="ctr"/>
+            <a:endParaRPr/>
+          </a:p>
+        </p:txBody>
+      </p:sp>
+      <p:sp>
+        <p:nvSpPr>
+          <p:cNvPr id="15" name="TextBox 14"/>
+          <p:cNvSpPr txBox="1"/>
+          <p:nvPr/>
+        </p:nvSpPr>
+        <p:spPr>
+          <a:xfrm>
+            <a:off x="8321040" y="2523744"/>
+            <a:ext cx="3200400" cy="365760"/>
+          </a:xfrm>
+          <a:prstGeom prst="rect">
+            <a:avLst/>
+          </a:prstGeom>
+          <a:noFill/>
+        </p:spPr>
+        <p:txBody>
+          <a:bodyPr wrap="square" lIns="0" tIns="0" rIns="0" bIns="0" anchor="t">
+            <a:spAutoFit/>
+          </a:bodyPr>
+          <a:lstStyle/>
+          <a:p>
+            <a:pPr algn="l">
+              <a:lnSpc>
+                <a:spcPct val="100000"/>
+              </a:lnSpc>
+              <a:spcBef>
+                <a:spcPts val="0"/>
+              </a:spcBef>
+              <a:spcAft>
+                <a:spcPts val="400"/>
+              </a:spcAft>
+            </a:pPr>
+            <a:r>
+              <a:rPr sz="1450" b="1" i="0">
+                <a:solidFill>
+                  <a:srgbClr val="1B2A5B"/>
+                </a:solidFill>
+                <a:latin typeface="Cambria"/>
+              </a:rPr>
+              <a:t>Southern sky lore</a:t>
+            </a:r>
+          </a:p>
+        </p:txBody>
+      </p:sp>
+      <p:sp>
+        <p:nvSpPr>
+          <p:cNvPr id="16" name="TextBox 15"/>
+          <p:cNvSpPr txBox="1"/>
+          <p:nvPr/>
+        </p:nvSpPr>
+        <p:spPr>
+          <a:xfrm>
+            <a:off x="8321040" y="2907792"/>
+            <a:ext cx="3200400" cy="640080"/>
+          </a:xfrm>
+          <a:prstGeom prst="rect">
+            <a:avLst/>
+          </a:prstGeom>
+          <a:noFill/>
+        </p:spPr>
+        <p:txBody>
+          <a:bodyPr wrap="square" lIns="0" tIns="0" rIns="0" bIns="0" anchor="t">
+            <a:spAutoFit/>
+          </a:bodyPr>
+          <a:lstStyle/>
+          <a:p>
+            <a:pPr algn="l">
+              <a:lnSpc>
+                <a:spcPct val="113000"/>
+              </a:lnSpc>
+              <a:spcBef>
+                <a:spcPts val="0"/>
+              </a:spcBef>
+              <a:spcAft>
+                <a:spcPts val="400"/>
+              </a:spcAft>
+            </a:pPr>
+            <a:r>
+              <a:rPr sz="1200" b="0" i="0">
+                <a:solidFill>
+                  <a:srgbClr val="636B7A"/>
+                </a:solidFill>
+                <a:latin typeface="Calibri"/>
+              </a:rPr>
+              <a:t>Alpha Centauri as the Chinese “Southern Gate”; the Southern Cross as the Malay stingray; Arcturus as the “Great Horn.”</a:t>
+            </a:r>
+          </a:p>
+        </p:txBody>
+      </p:sp>
+      <p:sp>
+        <p:nvSpPr>
+          <p:cNvPr id="17" name="Rounded Rectangle 16"/>
+          <p:cNvSpPr/>
+          <p:nvPr/>
+        </p:nvSpPr>
+        <p:spPr>
+          <a:xfrm>
+            <a:off x="548640" y="3794760"/>
+            <a:ext cx="3611880" cy="1234440"/>
+          </a:xfrm>
+          <a:prstGeom prst="roundRect">
+            <a:avLst>
+              <a:gd name="adj" fmla="val 10000"/>
+            </a:avLst>
+          </a:prstGeom>
+          <a:solidFill>
+            <a:srgbClr val="F3F5FA"/>
+          </a:solidFill>
+          <a:ln>
+            <a:noFill/>
+          </a:ln>
+          <a:effectLst/>
+        </p:spPr>
+        <p:style>
+          <a:lnRef idx="1">
+            <a:schemeClr val="accent1"/>
+          </a:lnRef>
+          <a:fillRef idx="3">
+            <a:schemeClr val="accent1"/>
+          </a:fillRef>
+          <a:effectRef idx="2">
+            <a:schemeClr val="accent1"/>
+          </a:effectRef>
+          <a:fontRef idx="minor">
+            <a:schemeClr val="lt1"/>
+          </a:fontRef>
+        </p:style>
+        <p:txBody>
+          <a:bodyPr rtlCol="0" anchor="ctr"/>
+          <a:lstStyle/>
+          <a:p>
+            <a:pPr algn="ctr"/>
+            <a:endParaRPr/>
+          </a:p>
+        </p:txBody>
+      </p:sp>
+      <p:sp>
+        <p:nvSpPr>
+          <p:cNvPr id="18" name="TextBox 17"/>
+          <p:cNvSpPr txBox="1"/>
+          <p:nvPr/>
+        </p:nvSpPr>
+        <p:spPr>
+          <a:xfrm>
+            <a:off x="768096" y="3941064"/>
+            <a:ext cx="3200400" cy="365760"/>
+          </a:xfrm>
+          <a:prstGeom prst="rect">
+            <a:avLst/>
+          </a:prstGeom>
+          <a:noFill/>
+        </p:spPr>
+        <p:txBody>
+          <a:bodyPr wrap="square" lIns="0" tIns="0" rIns="0" bIns="0" anchor="t">
+            <a:spAutoFit/>
+          </a:bodyPr>
+          <a:lstStyle/>
+          <a:p>
+            <a:pPr algn="l">
+              <a:lnSpc>
+                <a:spcPct val="100000"/>
+              </a:lnSpc>
+              <a:spcBef>
+                <a:spcPts val="0"/>
+              </a:spcBef>
+              <a:spcAft>
+                <a:spcPts val="400"/>
+              </a:spcAft>
+            </a:pPr>
+            <a:r>
+              <a:rPr sz="1450" b="1" i="0">
+                <a:solidFill>
+                  <a:srgbClr val="1B2A5B"/>
+                </a:solidFill>
+                <a:latin typeface="Cambria"/>
+              </a:rPr>
+              <a:t>Tamil names added</a:t>
+            </a:r>
+          </a:p>
+        </p:txBody>
+      </p:sp>
+      <p:sp>
+        <p:nvSpPr>
+          <p:cNvPr id="19" name="TextBox 18"/>
+          <p:cNvSpPr txBox="1"/>
+          <p:nvPr/>
+        </p:nvSpPr>
+        <p:spPr>
+          <a:xfrm>
+            <a:off x="768096" y="4325112"/>
+            <a:ext cx="3200400" cy="640080"/>
+          </a:xfrm>
+          <a:prstGeom prst="rect">
+            <a:avLst/>
+          </a:prstGeom>
+          <a:noFill/>
+        </p:spPr>
+        <p:txBody>
+          <a:bodyPr wrap="square" lIns="0" tIns="0" rIns="0" bIns="0" anchor="t">
+            <a:spAutoFit/>
+          </a:bodyPr>
+          <a:lstStyle/>
+          <a:p>
+            <a:pPr algn="l">
+              <a:lnSpc>
+                <a:spcPct val="113000"/>
+              </a:lnSpc>
+              <a:spcBef>
+                <a:spcPts val="0"/>
+              </a:spcBef>
+              <a:spcAft>
+                <a:spcPts val="400"/>
+              </a:spcAft>
+            </a:pPr>
+            <a:r>
+              <a:rPr sz="1200" b="0" i="0">
+                <a:solidFill>
+                  <a:srgbClr val="636B7A"/>
+                </a:solidFill>
+                <a:latin typeface="Calibri"/>
+              </a:rPr>
+              <a:t>The Indian entries now carry Tamil star-names too — Kārttikai, Kēṭṭai, Chittirai, Magam — for Singapore’s Tamil community.</a:t>
+            </a:r>
+          </a:p>
+        </p:txBody>
+      </p:sp>
+      <p:sp>
+        <p:nvSpPr>
+          <p:cNvPr id="20" name="Rounded Rectangle 19"/>
+          <p:cNvSpPr/>
+          <p:nvPr/>
+        </p:nvSpPr>
+        <p:spPr>
+          <a:xfrm>
+            <a:off x="4325112" y="3794760"/>
+            <a:ext cx="3611880" cy="1234440"/>
+          </a:xfrm>
+          <a:prstGeom prst="roundRect">
+            <a:avLst>
+              <a:gd name="adj" fmla="val 10000"/>
+            </a:avLst>
+          </a:prstGeom>
+          <a:solidFill>
+            <a:srgbClr val="F3F5FA"/>
+          </a:solidFill>
+          <a:ln>
+            <a:noFill/>
+          </a:ln>
+          <a:effectLst/>
+        </p:spPr>
+        <p:style>
+          <a:lnRef idx="1">
+            <a:schemeClr val="accent1"/>
+          </a:lnRef>
+          <a:fillRef idx="3">
+            <a:schemeClr val="accent1"/>
+          </a:fillRef>
+          <a:effectRef idx="2">
+            <a:schemeClr val="accent1"/>
+          </a:effectRef>
+          <a:fontRef idx="minor">
+            <a:schemeClr val="lt1"/>
+          </a:fontRef>
+        </p:style>
+        <p:txBody>
+          <a:bodyPr rtlCol="0" anchor="ctr"/>
+          <a:lstStyle/>
+          <a:p>
+            <a:pPr algn="ctr"/>
+            <a:endParaRPr/>
+          </a:p>
+        </p:txBody>
+      </p:sp>
+      <p:sp>
+        <p:nvSpPr>
+          <p:cNvPr id="21" name="TextBox 20"/>
+          <p:cNvSpPr txBox="1"/>
+          <p:nvPr/>
+        </p:nvSpPr>
+        <p:spPr>
+          <a:xfrm>
+            <a:off x="4544568" y="3941064"/>
+            <a:ext cx="3200400" cy="365760"/>
+          </a:xfrm>
+          <a:prstGeom prst="rect">
+            <a:avLst/>
+          </a:prstGeom>
+          <a:noFill/>
+        </p:spPr>
+        <p:txBody>
+          <a:bodyPr wrap="square" lIns="0" tIns="0" rIns="0" bIns="0" anchor="t">
+            <a:spAutoFit/>
+          </a:bodyPr>
+          <a:lstStyle/>
+          <a:p>
+            <a:pPr algn="l">
+              <a:lnSpc>
+                <a:spcPct val="100000"/>
+              </a:lnSpc>
+              <a:spcBef>
+                <a:spcPts val="0"/>
+              </a:spcBef>
+              <a:spcAft>
+                <a:spcPts val="400"/>
+              </a:spcAft>
+            </a:pPr>
+            <a:r>
+              <a:rPr sz="1450" b="1" i="0">
+                <a:solidFill>
+                  <a:srgbClr val="1B2A5B"/>
+                </a:solidFill>
+                <a:latin typeface="Cambria"/>
+              </a:rPr>
+              <a:t>All web-verified</a:t>
+            </a:r>
+          </a:p>
+        </p:txBody>
+      </p:sp>
+      <p:sp>
+        <p:nvSpPr>
+          <p:cNvPr id="22" name="TextBox 21"/>
+          <p:cNvSpPr txBox="1"/>
+          <p:nvPr/>
+        </p:nvSpPr>
+        <p:spPr>
+          <a:xfrm>
+            <a:off x="4544568" y="4325112"/>
+            <a:ext cx="3200400" cy="640080"/>
+          </a:xfrm>
+          <a:prstGeom prst="rect">
+            <a:avLst/>
+          </a:prstGeom>
+          <a:noFill/>
+        </p:spPr>
+        <p:txBody>
+          <a:bodyPr wrap="square" lIns="0" tIns="0" rIns="0" bIns="0" anchor="t">
+            <a:spAutoFit/>
+          </a:bodyPr>
+          <a:lstStyle/>
+          <a:p>
+            <a:pPr algn="l">
+              <a:lnSpc>
+                <a:spcPct val="113000"/>
+              </a:lnSpc>
+              <a:spcBef>
+                <a:spcPts val="0"/>
+              </a:spcBef>
+              <a:spcAft>
+                <a:spcPts val="400"/>
+              </a:spcAft>
+            </a:pPr>
+            <a:r>
+              <a:rPr sz="1200" b="0" i="0">
+                <a:solidFill>
+                  <a:srgbClr val="636B7A"/>
+                </a:solidFill>
+                <a:latin typeface="Calibri"/>
+              </a:rPr>
+              <a:t>Every name checked against the Chinese lunar-mansion, Malay/Javanese and Indian nakshatra traditions.</a:t>
+            </a:r>
+          </a:p>
+        </p:txBody>
+      </p:sp>
+      <p:sp>
+        <p:nvSpPr>
+          <p:cNvPr id="23" name="Rounded Rectangle 22"/>
+          <p:cNvSpPr/>
+          <p:nvPr/>
+        </p:nvSpPr>
+        <p:spPr>
+          <a:xfrm>
+            <a:off x="8101583" y="3794760"/>
+            <a:ext cx="3611880" cy="1234440"/>
+          </a:xfrm>
+          <a:prstGeom prst="roundRect">
+            <a:avLst>
+              <a:gd name="adj" fmla="val 10000"/>
+            </a:avLst>
+          </a:prstGeom>
+          <a:solidFill>
+            <a:srgbClr val="F3F5FA"/>
+          </a:solidFill>
+          <a:ln>
+            <a:noFill/>
+          </a:ln>
+          <a:effectLst/>
+        </p:spPr>
+        <p:style>
+          <a:lnRef idx="1">
+            <a:schemeClr val="accent1"/>
+          </a:lnRef>
+          <a:fillRef idx="3">
+            <a:schemeClr val="accent1"/>
+          </a:fillRef>
+          <a:effectRef idx="2">
+            <a:schemeClr val="accent1"/>
+          </a:effectRef>
+          <a:fontRef idx="minor">
+            <a:schemeClr val="lt1"/>
+          </a:fontRef>
+        </p:style>
+        <p:txBody>
+          <a:bodyPr rtlCol="0" anchor="ctr"/>
+          <a:lstStyle/>
+          <a:p>
+            <a:pPr algn="ctr"/>
+            <a:endParaRPr/>
+          </a:p>
+        </p:txBody>
+      </p:sp>
+      <p:sp>
+        <p:nvSpPr>
+          <p:cNvPr id="24" name="TextBox 23"/>
+          <p:cNvSpPr txBox="1"/>
+          <p:nvPr/>
+        </p:nvSpPr>
+        <p:spPr>
+          <a:xfrm>
+            <a:off x="8321040" y="3941064"/>
+            <a:ext cx="3200400" cy="365760"/>
+          </a:xfrm>
+          <a:prstGeom prst="rect">
+            <a:avLst/>
+          </a:prstGeom>
+          <a:noFill/>
+        </p:spPr>
+        <p:txBody>
+          <a:bodyPr wrap="square" lIns="0" tIns="0" rIns="0" bIns="0" anchor="t">
+            <a:spAutoFit/>
+          </a:bodyPr>
+          <a:lstStyle/>
+          <a:p>
+            <a:pPr algn="l">
+              <a:lnSpc>
+                <a:spcPct val="100000"/>
+              </a:lnSpc>
+              <a:spcBef>
+                <a:spcPts val="0"/>
+              </a:spcBef>
+              <a:spcAft>
+                <a:spcPts val="400"/>
+              </a:spcAft>
+            </a:pPr>
+            <a:r>
+              <a:rPr sz="1450" b="1" i="0">
+                <a:solidFill>
+                  <a:srgbClr val="1B2A5B"/>
+                </a:solidFill>
+                <a:latin typeface="Cambria"/>
+              </a:rPr>
+              <a:t>“Learn more” links</a:t>
+            </a:r>
+          </a:p>
+        </p:txBody>
+      </p:sp>
+      <p:sp>
+        <p:nvSpPr>
+          <p:cNvPr id="25" name="TextBox 24"/>
+          <p:cNvSpPr txBox="1"/>
+          <p:nvPr/>
+        </p:nvSpPr>
+        <p:spPr>
+          <a:xfrm>
+            <a:off x="8321040" y="4325112"/>
+            <a:ext cx="3200400" cy="640080"/>
+          </a:xfrm>
+          <a:prstGeom prst="rect">
+            <a:avLst/>
+          </a:prstGeom>
+          <a:noFill/>
+        </p:spPr>
+        <p:txBody>
+          <a:bodyPr wrap="square" lIns="0" tIns="0" rIns="0" bIns="0" anchor="t">
+            <a:spAutoFit/>
+          </a:bodyPr>
+          <a:lstStyle/>
+          <a:p>
+            <a:pPr algn="l">
+              <a:lnSpc>
+                <a:spcPct val="113000"/>
+              </a:lnSpc>
+              <a:spcBef>
+                <a:spcPts val="0"/>
+              </a:spcBef>
+              <a:spcAft>
+                <a:spcPts val="400"/>
+              </a:spcAft>
+            </a:pPr>
+            <a:r>
+              <a:rPr sz="1200" b="0" i="0">
+                <a:solidFill>
+                  <a:srgbClr val="636B7A"/>
+                </a:solidFill>
+                <a:latin typeface="Calibri"/>
+              </a:rPr>
+              <a:t>The cosmic-extremes, Singapore-sky and light-pollution pages now link out to NASA, ESA/ESO and DarkSky for the curious.</a:t>
+            </a:r>
+          </a:p>
+        </p:txBody>
+      </p:sp>
+      <p:sp>
+        <p:nvSpPr>
+          <p:cNvPr id="26" name="RS_Classification">
+            <a:extLst>
+              <a:ext uri="{FF2B5EF4-FFF2-40B4-BE49-F238E27FC236}">
+                <a16:creationId xmlns:a16="http://schemas.microsoft.com/office/drawing/2014/main" id="{2375B548-02D6-6383-5DC1-367F1F6C4B7E}"/>
+              </a:ext>
+            </a:extLst>
+          </p:cNvPr>
+          <p:cNvSpPr txBox="1"/>
+          <p:nvPr/>
+        </p:nvSpPr>
+        <p:spPr>
+          <a:xfrm>
+            <a:off x="11999640" y="6289521"/>
+            <a:ext cx="192360" cy="212879"/>
+          </a:xfrm>
+          <a:prstGeom prst="rect">
+            <a:avLst/>
+          </a:prstGeom>
+          <a:solidFill>
+            <a:schemeClr val="accent1"/>
+          </a:solidFill>
+        </p:spPr>
+        <p:txBody>
+          <a:bodyPr vert="horz" wrap="none" lIns="76200" tIns="36830" rIns="76200" bIns="36830" rtlCol="0" anchor="ctr">
+            <a:spAutoFit/>
+          </a:bodyPr>
+          <a:lstStyle/>
+          <a:p>
+            <a:r>
+              <a:rPr lang="en-SG" sz="900" b="1" kern="900" spc="100"/>
+              <a:t> </a:t>
+            </a:r>
+          </a:p>
+        </p:txBody>
+      </p:sp>
+    </p:spTree>
+  </p:cSld>
+  <p:clrMapOvr>
+    <a:masterClrMapping/>
+  </p:clrMapOvr>
+</p:sld>
+</file>
+
+<file path=ppt/slides/slide41.xml><?xml version="1.0" encoding="utf-8"?>
 <p:sld xmlns:a="http://schemas.openxmlformats.org/drawingml/2006/main" xmlns:r="http://schemas.openxmlformats.org/officeDocument/2006/relationships" xmlns:p="http://schemas.openxmlformats.org/presentationml/2006/main">
   <p:cSld>
     <p:bg>
@@ -45177,7 +46325,7 @@
 </p:sld>
 </file>
 
-<file path=ppt/slides/slide41.xml><?xml version="1.0" encoding="utf-8"?>
+<file path=ppt/slides/slide42.xml><?xml version="1.0" encoding="utf-8"?>
 <p:sld xmlns:a="http://schemas.openxmlformats.org/drawingml/2006/main" xmlns:p="http://schemas.openxmlformats.org/presentationml/2006/main" xmlns:r="http://schemas.openxmlformats.org/officeDocument/2006/relationships">
   <p:cSld>
     <p:spTree>
@@ -45272,7 +46420,7 @@
                 </a:solidFill>
                 <a:latin typeface="Calibri"/>
               </a:rPr>
-              <a:t>WHAT’S NEW IN v3.46</a:t>
+              <a:t>WHAT’S NEW IN v3.47</a:t>
             </a:r>
           </a:p>
         </p:txBody>
@@ -45317,7 +46465,7 @@
                 </a:solidFill>
                 <a:latin typeface="Cambria"/>
               </a:rPr>
-              <a:t>Sky lore for all — and in Tamil</a:t>
+              <a:t>An About &amp; Credits page</a:t>
             </a:r>
           </a:p>
         </p:txBody>
@@ -45362,7 +46510,7 @@
                 </a:solidFill>
                 <a:latin typeface="Calibri"/>
               </a:rPr>
-              <a:t>SCOB Night-Sky Dashboard  ·  Volunteer User Guide  ·  v3.46</a:t>
+              <a:t>SCOB Night-Sky Dashboard  ·  Volunteer User Guide  ·  v3.47</a:t>
             </a:r>
           </a:p>
         </p:txBody>
@@ -45407,7 +46555,7 @@
                 </a:solidFill>
                 <a:latin typeface="Calibri"/>
               </a:rPr>
-              <a:t>40</a:t>
+              <a:t>41</a:t>
             </a:r>
           </a:p>
         </p:txBody>
@@ -45452,7 +46600,7 @@
                 </a:solidFill>
                 <a:latin typeface="Calibri"/>
               </a:rPr>
-              <a:t>The multicultural “same stars, around the world” lore now covers every one of the 16 constellations, with Tamil star-names added.</a:t>
+              <a:t>One authoritative page explaining what the app is, that it respects privacy, where every number comes from, and who to credit.</a:t>
             </a:r>
           </a:p>
         </p:txBody>
@@ -45544,7 +46692,7 @@
                 </a:solidFill>
                 <a:latin typeface="Cambria"/>
               </a:rPr>
-              <a:t>All 16 covered</a:t>
+              <a:t>What it is</a:t>
             </a:r>
           </a:p>
         </p:txBody>
@@ -45589,7 +46737,7 @@
                 </a:solidFill>
                 <a:latin typeface="Calibri"/>
               </a:rPr>
-              <a:t>Every constellation on the page now shows its Chinese, Malay and Indian names beside the Greek myth — up from six.</a:t>
+              <a:t>A one-paragraph summary: an offline-first, on-device companion for the Friday sessions, with a volunteer dashboard and a visitor Sky Guide.</a:t>
             </a:r>
           </a:p>
         </p:txBody>
@@ -45681,7 +46829,7 @@
                 </a:solidFill>
                 <a:latin typeface="Cambria"/>
               </a:rPr>
-              <a:t>The Qixi love story</a:t>
+              <a:t>Private by design</a:t>
             </a:r>
           </a:p>
         </p:txBody>
@@ -45726,7 +46874,7 @@
                 </a:solidFill>
                 <a:latin typeface="Calibri"/>
               </a:rPr>
-              <a:t>Vega (the Weaving Girl), Altair (the Cowherd) and Cygnus (the Celestial Ford) tell the tale of lovers parted by the Milky Way, meeting once a year.</a:t>
+              <a:t>States plainly: no accounts, no tracking, no analytics — only the live weather leaves the device.</a:t>
             </a:r>
           </a:p>
         </p:txBody>
@@ -45818,7 +46966,7 @@
                 </a:solidFill>
                 <a:latin typeface="Cambria"/>
               </a:rPr>
-              <a:t>Southern sky lore</a:t>
+              <a:t>Every source, listed</a:t>
             </a:r>
           </a:p>
         </p:txBody>
@@ -45863,7 +47011,7 @@
                 </a:solidFill>
                 <a:latin typeface="Calibri"/>
               </a:rPr>
-              <a:t>Alpha Centauri as the Chinese “Southern Gate”; the Southern Cross as the Malay stingray; Arcturus as the “Great Horn.”</a:t>
+              <a:t>Schlyter, Meeus, AstroPixels, WDS/SIMBAD, CelesTrak + satellite.js, Open-Meteo, MSS, NEA, NOAA, NASA/ESA — each linked.</a:t>
             </a:r>
           </a:p>
         </p:txBody>
@@ -45955,7 +47103,7 @@
                 </a:solidFill>
                 <a:latin typeface="Cambria"/>
               </a:rPr>
-              <a:t>Tamil names added</a:t>
+              <a:t>Cultural lore credited</a:t>
             </a:r>
           </a:p>
         </p:txBody>
@@ -46000,7 +47148,7 @@
                 </a:solidFill>
                 <a:latin typeface="Calibri"/>
               </a:rPr>
-              <a:t>The Indian entries now carry Tamil star-names too — Kārttikai, Kēṭṭai, Chittirai, Magam — for Singapore’s Tamil community.</a:t>
+              <a:t>Respectful sourcing for the Chinese, Malay/Javanese and Indian (with Tamil) star-name traditions, and an invitation to send corrections.</a:t>
             </a:r>
           </a:p>
         </p:txBody>
@@ -46092,7 +47240,7 @@
                 </a:solidFill>
                 <a:latin typeface="Cambria"/>
               </a:rPr>
-              <a:t>All web-verified</a:t>
+              <a:t>The telescope fleet</a:t>
             </a:r>
           </a:p>
         </p:txBody>
@@ -46137,7 +47285,7 @@
                 </a:solidFill>
                 <a:latin typeface="Calibri"/>
               </a:rPr>
-              <a:t>Every name checked against the Chinese lunar-mansion, Malay/Javanese and Indian nakshatra traditions.</a:t>
+              <a:t>A tidy summary of the SCOB instruments the whole app is tuned to.</a:t>
             </a:r>
           </a:p>
         </p:txBody>
@@ -46229,7 +47377,7 @@
                 </a:solidFill>
                 <a:latin typeface="Cambria"/>
               </a:rPr>
-              <a:t>“Learn more” links</a:t>
+              <a:t>Where to find it</a:t>
             </a:r>
           </a:p>
         </p:txBody>
@@ -46274,7 +47422,7 @@
                 </a:solidFill>
                 <a:latin typeface="Calibri"/>
               </a:rPr>
-              <a:t>The cosmic-extremes, Singapore-sky and light-pollution pages now link out to NASA, ESA/ESO and DarkSky for the curious.</a:t>
+              <a:t>Linked from the dashboard menu under Reference guides; a quiet page, but the credible backbone of a public site.</a:t>
             </a:r>
           </a:p>
         </p:txBody>
@@ -46524,7 +47672,7 @@
                 </a:solidFill>
                 <a:latin typeface="Calibri"/>
               </a:rPr>
-              <a:t>SCOB Night-Sky Dashboard  ·  Volunteer User Guide  ·  v3.46</a:t>
+              <a:t>SCOB Night-Sky Dashboard  ·  Volunteer User Guide  ·  v3.47</a:t>
             </a:r>
           </a:p>
         </p:txBody>
@@ -47672,7 +48820,7 @@
                 </a:solidFill>
                 <a:latin typeface="Calibri"/>
               </a:rPr>
-              <a:t>SCOB Night-Sky Dashboard  ·  Volunteer User Guide  ·  v3.46</a:t>
+              <a:t>SCOB Night-Sky Dashboard  ·  Volunteer User Guide  ·  v3.47</a:t>
             </a:r>
           </a:p>
         </p:txBody>
@@ -50431,7 +51579,7 @@
                 </a:solidFill>
                 <a:latin typeface="Calibri"/>
               </a:rPr>
-              <a:t>SCOB Night-Sky Dashboard  ·  Volunteer User Guide  ·  v3.46</a:t>
+              <a:t>SCOB Night-Sky Dashboard  ·  Volunteer User Guide  ·  v3.47</a:t>
             </a:r>
           </a:p>
         </p:txBody>
@@ -51434,7 +52582,7 @@
                 </a:solidFill>
                 <a:latin typeface="Calibri"/>
               </a:rPr>
-              <a:t>SCOB Night-Sky Dashboard  ·  Volunteer User Guide  ·  v3.46</a:t>
+              <a:t>SCOB Night-Sky Dashboard  ·  Volunteer User Guide  ·  v3.47</a:t>
             </a:r>
           </a:p>
         </p:txBody>
@@ -54471,7 +55619,7 @@
                 </a:solidFill>
                 <a:latin typeface="Calibri"/>
               </a:rPr>
-              <a:t>SCOB Night-Sky Dashboard  ·  Volunteer User Guide  ·  v3.46</a:t>
+              <a:t>SCOB Night-Sky Dashboard  ·  Volunteer User Guide  ·  v3.47</a:t>
             </a:r>
           </a:p>
         </p:txBody>

</xml_diff>

<commit_message>
Correction of spacing in meteors page
</commit_message>
<xml_diff>
--- a/SCOB-Dashboard-User-Guide.pptx
+++ b/SCOB-Dashboard-User-Guide.pptx
@@ -6635,7 +6635,7 @@
                 </a:solidFill>
                 <a:latin typeface="Calibri"/>
               </a:rPr>
-              <a:t>Version 3.48  ·  Updated weekly, ahead of the session</a:t>
+              <a:t>Version 3.49  ·  Updated weekly, ahead of the session</a:t>
             </a:r>
           </a:p>
         </p:txBody>
@@ -6885,7 +6885,7 @@
                 </a:solidFill>
                 <a:latin typeface="Calibri"/>
               </a:rPr>
-              <a:t>SCOB Night-Sky Dashboard  ·  Volunteer User Guide  ·  v3.48</a:t>
+              <a:t>SCOB Night-Sky Dashboard  ·  Volunteer User Guide  ·  v3.49</a:t>
             </a:r>
           </a:p>
         </p:txBody>
@@ -8119,7 +8119,7 @@
                 </a:solidFill>
                 <a:latin typeface="Calibri"/>
               </a:rPr>
-              <a:t>SCOB Night-Sky Dashboard  ·  Volunteer User Guide  ·  v3.48</a:t>
+              <a:t>SCOB Night-Sky Dashboard  ·  Volunteer User Guide  ·  v3.49</a:t>
             </a:r>
           </a:p>
         </p:txBody>
@@ -9237,7 +9237,7 @@
                 </a:solidFill>
                 <a:latin typeface="Calibri"/>
               </a:rPr>
-              <a:t>SCOB Night-Sky Dashboard  ·  Volunteer User Guide  ·  v3.48</a:t>
+              <a:t>SCOB Night-Sky Dashboard  ·  Volunteer User Guide  ·  v3.49</a:t>
             </a:r>
           </a:p>
         </p:txBody>
@@ -10024,7 +10024,7 @@
                 </a:solidFill>
                 <a:latin typeface="Calibri"/>
               </a:rPr>
-              <a:t>SCOB Night-Sky Dashboard  ·  Volunteer User Guide  ·  v3.48</a:t>
+              <a:t>SCOB Night-Sky Dashboard  ·  Volunteer User Guide  ·  v3.49</a:t>
             </a:r>
           </a:p>
         </p:txBody>
@@ -11196,7 +11196,7 @@
                 </a:solidFill>
                 <a:latin typeface="Calibri"/>
               </a:rPr>
-              <a:t>SCOB Night-Sky Dashboard  ·  Volunteer User Guide  ·  v3.48</a:t>
+              <a:t>SCOB Night-Sky Dashboard  ·  Volunteer User Guide  ·  v3.49</a:t>
             </a:r>
           </a:p>
         </p:txBody>
@@ -12377,7 +12377,7 @@
                 </a:solidFill>
                 <a:latin typeface="Calibri"/>
               </a:rPr>
-              <a:t>SCOB Night-Sky Dashboard  ·  Volunteer User Guide  ·  v3.48</a:t>
+              <a:t>SCOB Night-Sky Dashboard  ·  Volunteer User Guide  ·  v3.49</a:t>
             </a:r>
           </a:p>
         </p:txBody>
@@ -13165,7 +13165,7 @@
                 </a:solidFill>
                 <a:latin typeface="Calibri"/>
               </a:rPr>
-              <a:t>SCOB Night-Sky Dashboard  ·  Volunteer User Guide  ·  v3.48</a:t>
+              <a:t>SCOB Night-Sky Dashboard  ·  Volunteer User Guide  ·  v3.49</a:t>
             </a:r>
           </a:p>
         </p:txBody>
@@ -13934,7 +13934,7 @@
                 </a:solidFill>
                 <a:latin typeface="Calibri"/>
               </a:rPr>
-              <a:t>SCOB Night-Sky Dashboard  ·  Volunteer User Guide  ·  v3.48</a:t>
+              <a:t>SCOB Night-Sky Dashboard  ·  Volunteer User Guide  ·  v3.49</a:t>
             </a:r>
           </a:p>
         </p:txBody>
@@ -14903,7 +14903,7 @@
                 </a:solidFill>
                 <a:latin typeface="Calibri"/>
               </a:rPr>
-              <a:t>SCOB Night-Sky Dashboard  ·  Volunteer User Guide  ·  v3.48</a:t>
+              <a:t>SCOB Night-Sky Dashboard  ·  Volunteer User Guide  ·  v3.49</a:t>
             </a:r>
           </a:p>
         </p:txBody>
@@ -15791,7 +15791,7 @@
                 </a:solidFill>
                 <a:latin typeface="Calibri"/>
               </a:rPr>
-              <a:t>SCOB Night-Sky Dashboard  ·  Volunteer User Guide  ·  v3.48</a:t>
+              <a:t>SCOB Night-Sky Dashboard  ·  Volunteer User Guide  ·  v3.49</a:t>
             </a:r>
           </a:p>
         </p:txBody>
@@ -16755,7 +16755,7 @@
                 </a:solidFill>
                 <a:latin typeface="Calibri"/>
               </a:rPr>
-              <a:t>SCOB Night-Sky Dashboard  ·  Volunteer User Guide  ·  v3.48</a:t>
+              <a:t>SCOB Night-Sky Dashboard  ·  Volunteer User Guide  ·  v3.49</a:t>
             </a:r>
           </a:p>
         </p:txBody>
@@ -17623,7 +17623,7 @@
                 </a:solidFill>
                 <a:latin typeface="Calibri"/>
               </a:rPr>
-              <a:t>SCOB Night-Sky Dashboard  ·  Volunteer User Guide  ·  v3.48</a:t>
+              <a:t>SCOB Night-Sky Dashboard  ·  Volunteer User Guide  ·  v3.49</a:t>
             </a:r>
           </a:p>
         </p:txBody>
@@ -18695,7 +18695,7 @@
                 </a:solidFill>
                 <a:latin typeface="Calibri"/>
               </a:rPr>
-              <a:t>SCOB Night-Sky Dashboard  ·  Volunteer User Guide  ·  v3.48</a:t>
+              <a:t>SCOB Night-Sky Dashboard  ·  Volunteer User Guide  ·  v3.49</a:t>
             </a:r>
           </a:p>
         </p:txBody>
@@ -19411,7 +19411,7 @@
                 </a:solidFill>
                 <a:latin typeface="Calibri"/>
               </a:rPr>
-              <a:t>SCOB Night-Sky Dashboard  ·  Volunteer User Guide  ·  v3.48</a:t>
+              <a:t>SCOB Night-Sky Dashboard  ·  Volunteer User Guide  ·  v3.49</a:t>
             </a:r>
           </a:p>
         </p:txBody>
@@ -20558,7 +20558,7 @@
                 </a:solidFill>
                 <a:latin typeface="Calibri"/>
               </a:rPr>
-              <a:t>SCOB Night-Sky Dashboard  ·  Volunteer User Guide  ·  v3.48</a:t>
+              <a:t>SCOB Night-Sky Dashboard  ·  Volunteer User Guide  ·  v3.49</a:t>
             </a:r>
           </a:p>
         </p:txBody>
@@ -21705,7 +21705,7 @@
                 </a:solidFill>
                 <a:latin typeface="Calibri"/>
               </a:rPr>
-              <a:t>SCOB Night-Sky Dashboard  ·  Volunteer User Guide  ·  v3.48</a:t>
+              <a:t>SCOB Night-Sky Dashboard  ·  Volunteer User Guide  ·  v3.49</a:t>
             </a:r>
           </a:p>
         </p:txBody>
@@ -22852,7 +22852,7 @@
                 </a:solidFill>
                 <a:latin typeface="Calibri"/>
               </a:rPr>
-              <a:t>SCOB Night-Sky Dashboard  ·  Volunteer User Guide  ·  v3.48</a:t>
+              <a:t>SCOB Night-Sky Dashboard  ·  Volunteer User Guide  ·  v3.49</a:t>
             </a:r>
           </a:p>
         </p:txBody>
@@ -23999,7 +23999,7 @@
                 </a:solidFill>
                 <a:latin typeface="Calibri"/>
               </a:rPr>
-              <a:t>SCOB Night-Sky Dashboard  ·  Volunteer User Guide  ·  v3.48</a:t>
+              <a:t>SCOB Night-Sky Dashboard  ·  Volunteer User Guide  ·  v3.49</a:t>
             </a:r>
           </a:p>
         </p:txBody>
@@ -25146,7 +25146,7 @@
                 </a:solidFill>
                 <a:latin typeface="Calibri"/>
               </a:rPr>
-              <a:t>SCOB Night-Sky Dashboard  ·  Volunteer User Guide  ·  v3.48</a:t>
+              <a:t>SCOB Night-Sky Dashboard  ·  Volunteer User Guide  ·  v3.49</a:t>
             </a:r>
           </a:p>
         </p:txBody>
@@ -26293,7 +26293,7 @@
                 </a:solidFill>
                 <a:latin typeface="Calibri"/>
               </a:rPr>
-              <a:t>SCOB Night-Sky Dashboard  ·  Volunteer User Guide  ·  v3.48</a:t>
+              <a:t>SCOB Night-Sky Dashboard  ·  Volunteer User Guide  ·  v3.49</a:t>
             </a:r>
           </a:p>
         </p:txBody>
@@ -27440,7 +27440,7 @@
                 </a:solidFill>
                 <a:latin typeface="Calibri"/>
               </a:rPr>
-              <a:t>SCOB Night-Sky Dashboard  ·  Volunteer User Guide  ·  v3.48</a:t>
+              <a:t>SCOB Night-Sky Dashboard  ·  Volunteer User Guide  ·  v3.49</a:t>
             </a:r>
           </a:p>
         </p:txBody>
@@ -28602,7 +28602,7 @@
                 </a:solidFill>
                 <a:latin typeface="Calibri"/>
               </a:rPr>
-              <a:t>SCOB Night-Sky Dashboard  ·  Volunteer User Guide  ·  v3.48</a:t>
+              <a:t>SCOB Night-Sky Dashboard  ·  Volunteer User Guide  ·  v3.49</a:t>
             </a:r>
           </a:p>
         </p:txBody>
@@ -29410,7 +29410,7 @@
                 </a:solidFill>
                 <a:latin typeface="Calibri"/>
               </a:rPr>
-              <a:t>SCOB Night-Sky Dashboard  ·  Volunteer User Guide  ·  v3.48</a:t>
+              <a:t>SCOB Night-Sky Dashboard  ·  Volunteer User Guide  ·  v3.49</a:t>
             </a:r>
           </a:p>
         </p:txBody>
@@ -30557,7 +30557,7 @@
                 </a:solidFill>
                 <a:latin typeface="Calibri"/>
               </a:rPr>
-              <a:t>SCOB Night-Sky Dashboard  ·  Volunteer User Guide  ·  v3.48</a:t>
+              <a:t>SCOB Night-Sky Dashboard  ·  Volunteer User Guide  ·  v3.49</a:t>
             </a:r>
           </a:p>
         </p:txBody>
@@ -31704,7 +31704,7 @@
                 </a:solidFill>
                 <a:latin typeface="Calibri"/>
               </a:rPr>
-              <a:t>SCOB Night-Sky Dashboard  ·  Volunteer User Guide  ·  v3.48</a:t>
+              <a:t>SCOB Night-Sky Dashboard  ·  Volunteer User Guide  ·  v3.49</a:t>
             </a:r>
           </a:p>
         </p:txBody>
@@ -32851,7 +32851,7 @@
                 </a:solidFill>
                 <a:latin typeface="Calibri"/>
               </a:rPr>
-              <a:t>SCOB Night-Sky Dashboard  ·  Volunteer User Guide  ·  v3.48</a:t>
+              <a:t>SCOB Night-Sky Dashboard  ·  Volunteer User Guide  ·  v3.49</a:t>
             </a:r>
           </a:p>
         </p:txBody>
@@ -33998,7 +33998,7 @@
                 </a:solidFill>
                 <a:latin typeface="Calibri"/>
               </a:rPr>
-              <a:t>SCOB Night-Sky Dashboard  ·  Volunteer User Guide  ·  v3.48</a:t>
+              <a:t>SCOB Night-Sky Dashboard  ·  Volunteer User Guide  ·  v3.49</a:t>
             </a:r>
           </a:p>
         </p:txBody>
@@ -35145,7 +35145,7 @@
                 </a:solidFill>
                 <a:latin typeface="Calibri"/>
               </a:rPr>
-              <a:t>SCOB Night-Sky Dashboard  ·  Volunteer User Guide  ·  v3.48</a:t>
+              <a:t>SCOB Night-Sky Dashboard  ·  Volunteer User Guide  ·  v3.49</a:t>
             </a:r>
           </a:p>
         </p:txBody>
@@ -36292,7 +36292,7 @@
                 </a:solidFill>
                 <a:latin typeface="Calibri"/>
               </a:rPr>
-              <a:t>SCOB Night-Sky Dashboard  ·  Volunteer User Guide  ·  v3.48</a:t>
+              <a:t>SCOB Night-Sky Dashboard  ·  Volunteer User Guide  ·  v3.49</a:t>
             </a:r>
           </a:p>
         </p:txBody>
@@ -37439,7 +37439,7 @@
                 </a:solidFill>
                 <a:latin typeface="Calibri"/>
               </a:rPr>
-              <a:t>SCOB Night-Sky Dashboard  ·  Volunteer User Guide  ·  v3.48</a:t>
+              <a:t>SCOB Night-Sky Dashboard  ·  Volunteer User Guide  ·  v3.49</a:t>
             </a:r>
           </a:p>
         </p:txBody>
@@ -38586,7 +38586,7 @@
                 </a:solidFill>
                 <a:latin typeface="Calibri"/>
               </a:rPr>
-              <a:t>SCOB Night-Sky Dashboard  ·  Volunteer User Guide  ·  v3.48</a:t>
+              <a:t>SCOB Night-Sky Dashboard  ·  Volunteer User Guide  ·  v3.49</a:t>
             </a:r>
           </a:p>
         </p:txBody>
@@ -39733,7 +39733,7 @@
                 </a:solidFill>
                 <a:latin typeface="Calibri"/>
               </a:rPr>
-              <a:t>SCOB Night-Sky Dashboard  ·  Volunteer User Guide  ·  v3.48</a:t>
+              <a:t>SCOB Night-Sky Dashboard  ·  Volunteer User Guide  ·  v3.49</a:t>
             </a:r>
           </a:p>
         </p:txBody>
@@ -40895,7 +40895,7 @@
                 </a:solidFill>
                 <a:latin typeface="Calibri"/>
               </a:rPr>
-              <a:t>SCOB Night-Sky Dashboard  ·  Volunteer User Guide  ·  v3.48</a:t>
+              <a:t>SCOB Night-Sky Dashboard  ·  Volunteer User Guide  ·  v3.49</a:t>
             </a:r>
           </a:p>
         </p:txBody>
@@ -42042,7 +42042,7 @@
                 </a:solidFill>
                 <a:latin typeface="Calibri"/>
               </a:rPr>
-              <a:t>SCOB Night-Sky Dashboard  ·  Volunteer User Guide  ·  v3.48</a:t>
+              <a:t>SCOB Night-Sky Dashboard  ·  Volunteer User Guide  ·  v3.49</a:t>
             </a:r>
           </a:p>
         </p:txBody>
@@ -43189,7 +43189,7 @@
                 </a:solidFill>
                 <a:latin typeface="Calibri"/>
               </a:rPr>
-              <a:t>SCOB Night-Sky Dashboard  ·  Volunteer User Guide  ·  v3.48</a:t>
+              <a:t>SCOB Night-Sky Dashboard  ·  Volunteer User Guide  ·  v3.49</a:t>
             </a:r>
           </a:p>
         </p:txBody>
@@ -44152,6 +44152,1153 @@
 </file>
 
 <file path=ppt/slides/slide42.xml><?xml version="1.0" encoding="utf-8"?>
+<p:sld xmlns:a="http://schemas.openxmlformats.org/drawingml/2006/main" xmlns:p="http://schemas.openxmlformats.org/presentationml/2006/main" xmlns:r="http://schemas.openxmlformats.org/officeDocument/2006/relationships">
+  <p:cSld>
+    <p:spTree>
+      <p:nvGrpSpPr>
+        <p:cNvPr id="1" name=""/>
+        <p:cNvGrpSpPr/>
+        <p:nvPr/>
+      </p:nvGrpSpPr>
+      <p:grpSpPr/>
+      <p:sp>
+        <p:nvSpPr>
+          <p:cNvPr id="2" name="Oval 1"/>
+          <p:cNvSpPr/>
+          <p:nvPr/>
+        </p:nvSpPr>
+        <p:spPr>
+          <a:xfrm>
+            <a:off x="502920" y="457200"/>
+            <a:ext cx="146304" cy="146304"/>
+          </a:xfrm>
+          <a:prstGeom prst="ellipse">
+            <a:avLst/>
+          </a:prstGeom>
+          <a:solidFill>
+            <a:srgbClr val="E0A930"/>
+          </a:solidFill>
+          <a:ln>
+            <a:noFill/>
+          </a:ln>
+          <a:effectLst/>
+        </p:spPr>
+        <p:style>
+          <a:lnRef idx="1">
+            <a:schemeClr val="accent1"/>
+          </a:lnRef>
+          <a:fillRef idx="3">
+            <a:schemeClr val="accent1"/>
+          </a:fillRef>
+          <a:effectRef idx="2">
+            <a:schemeClr val="accent1"/>
+          </a:effectRef>
+          <a:fontRef idx="minor">
+            <a:schemeClr val="lt1"/>
+          </a:fontRef>
+        </p:style>
+        <p:txBody>
+          <a:bodyPr wrap="none" lIns="0" tIns="0" rIns="0" bIns="0" rtlCol="0" anchor="ctr"/>
+          <a:lstStyle/>
+          <a:p>
+            <a:pPr algn="ctr"/>
+            <a:endParaRPr/>
+          </a:p>
+        </p:txBody>
+      </p:sp>
+      <p:sp>
+        <p:nvSpPr>
+          <p:cNvPr id="3" name="TextBox 2"/>
+          <p:cNvSpPr txBox="1"/>
+          <p:nvPr/>
+        </p:nvSpPr>
+        <p:spPr>
+          <a:xfrm>
+            <a:off x="731520" y="384048"/>
+            <a:ext cx="7315200" cy="274320"/>
+          </a:xfrm>
+          <a:prstGeom prst="rect">
+            <a:avLst/>
+          </a:prstGeom>
+          <a:noFill/>
+        </p:spPr>
+        <p:txBody>
+          <a:bodyPr wrap="square" lIns="0" tIns="0" rIns="0" bIns="0" anchor="t">
+            <a:spAutoFit/>
+          </a:bodyPr>
+          <a:lstStyle/>
+          <a:p>
+            <a:pPr algn="l">
+              <a:lnSpc>
+                <a:spcPct val="100000"/>
+              </a:lnSpc>
+              <a:spcBef>
+                <a:spcPts val="0"/>
+              </a:spcBef>
+              <a:spcAft>
+                <a:spcPts val="400"/>
+              </a:spcAft>
+            </a:pPr>
+            <a:r>
+              <a:rPr sz="1100" b="1" i="0">
+                <a:solidFill>
+                  <a:srgbClr val="E0A930"/>
+                </a:solidFill>
+                <a:latin typeface="Calibri"/>
+              </a:rPr>
+              <a:t>WHAT’S NEW IN v3.48</a:t>
+            </a:r>
+          </a:p>
+        </p:txBody>
+      </p:sp>
+      <p:sp>
+        <p:nvSpPr>
+          <p:cNvPr id="4" name="TextBox 3"/>
+          <p:cNvSpPr txBox="1"/>
+          <p:nvPr/>
+        </p:nvSpPr>
+        <p:spPr>
+          <a:xfrm>
+            <a:off x="502920" y="658368"/>
+            <a:ext cx="10515600" cy="731520"/>
+          </a:xfrm>
+          <a:prstGeom prst="rect">
+            <a:avLst/>
+          </a:prstGeom>
+          <a:noFill/>
+        </p:spPr>
+        <p:txBody>
+          <a:bodyPr wrap="square" lIns="0" tIns="0" rIns="0" bIns="0" anchor="t">
+            <a:spAutoFit/>
+          </a:bodyPr>
+          <a:lstStyle/>
+          <a:p>
+            <a:pPr algn="l">
+              <a:lnSpc>
+                <a:spcPct val="100000"/>
+              </a:lnSpc>
+              <a:spcBef>
+                <a:spcPts val="0"/>
+              </a:spcBef>
+              <a:spcAft>
+                <a:spcPts val="400"/>
+              </a:spcAft>
+            </a:pPr>
+            <a:r>
+              <a:rPr sz="3000" b="1" i="0">
+                <a:solidFill>
+                  <a:srgbClr val="1B2A5B"/>
+                </a:solidFill>
+                <a:latin typeface="Cambria"/>
+              </a:rPr>
+              <a:t>Meteor showers, explained</a:t>
+            </a:r>
+          </a:p>
+        </p:txBody>
+      </p:sp>
+      <p:sp>
+        <p:nvSpPr>
+          <p:cNvPr id="5" name="TextBox 4"/>
+          <p:cNvSpPr txBox="1"/>
+          <p:nvPr/>
+        </p:nvSpPr>
+        <p:spPr>
+          <a:xfrm>
+            <a:off x="502920" y="6455664"/>
+            <a:ext cx="8229600" cy="274320"/>
+          </a:xfrm>
+          <a:prstGeom prst="rect">
+            <a:avLst/>
+          </a:prstGeom>
+          <a:noFill/>
+        </p:spPr>
+        <p:txBody>
+          <a:bodyPr wrap="square" lIns="0" tIns="0" rIns="0" bIns="0" anchor="t">
+            <a:spAutoFit/>
+          </a:bodyPr>
+          <a:lstStyle/>
+          <a:p>
+            <a:pPr algn="l">
+              <a:lnSpc>
+                <a:spcPct val="100000"/>
+              </a:lnSpc>
+              <a:spcBef>
+                <a:spcPts val="0"/>
+              </a:spcBef>
+              <a:spcAft>
+                <a:spcPts val="400"/>
+              </a:spcAft>
+            </a:pPr>
+            <a:r>
+              <a:rPr sz="900" b="0" i="0">
+                <a:solidFill>
+                  <a:srgbClr val="9AA2B0"/>
+                </a:solidFill>
+                <a:latin typeface="Calibri"/>
+              </a:rPr>
+              <a:t>SCOB Night-Sky Dashboard  ·  Volunteer User Guide  ·  v3.49</a:t>
+            </a:r>
+          </a:p>
+        </p:txBody>
+      </p:sp>
+      <p:sp>
+        <p:nvSpPr>
+          <p:cNvPr id="6" name="TextBox 5"/>
+          <p:cNvSpPr txBox="1"/>
+          <p:nvPr/>
+        </p:nvSpPr>
+        <p:spPr>
+          <a:xfrm>
+            <a:off x="10607040" y="6455664"/>
+            <a:ext cx="1097280" cy="274320"/>
+          </a:xfrm>
+          <a:prstGeom prst="rect">
+            <a:avLst/>
+          </a:prstGeom>
+          <a:noFill/>
+        </p:spPr>
+        <p:txBody>
+          <a:bodyPr wrap="square" lIns="0" tIns="0" rIns="0" bIns="0" anchor="t">
+            <a:spAutoFit/>
+          </a:bodyPr>
+          <a:lstStyle/>
+          <a:p>
+            <a:pPr algn="r">
+              <a:lnSpc>
+                <a:spcPct val="100000"/>
+              </a:lnSpc>
+              <a:spcBef>
+                <a:spcPts val="0"/>
+              </a:spcBef>
+              <a:spcAft>
+                <a:spcPts val="400"/>
+              </a:spcAft>
+            </a:pPr>
+            <a:r>
+              <a:rPr sz="900" b="1" i="0">
+                <a:solidFill>
+                  <a:srgbClr val="9AA2B0"/>
+                </a:solidFill>
+                <a:latin typeface="Calibri"/>
+              </a:rPr>
+              <a:t>42</a:t>
+            </a:r>
+          </a:p>
+        </p:txBody>
+      </p:sp>
+      <p:sp>
+        <p:nvSpPr>
+          <p:cNvPr id="7" name="TextBox 6"/>
+          <p:cNvSpPr txBox="1"/>
+          <p:nvPr/>
+        </p:nvSpPr>
+        <p:spPr>
+          <a:xfrm>
+            <a:off x="502920" y="1554480"/>
+            <a:ext cx="10972800" cy="502920"/>
+          </a:xfrm>
+          <a:prstGeom prst="rect">
+            <a:avLst/>
+          </a:prstGeom>
+          <a:noFill/>
+        </p:spPr>
+        <p:txBody>
+          <a:bodyPr wrap="square" lIns="0" tIns="0" rIns="0" bIns="0" anchor="t">
+            <a:spAutoFit/>
+          </a:bodyPr>
+          <a:lstStyle/>
+          <a:p>
+            <a:pPr algn="l">
+              <a:lnSpc>
+                <a:spcPct val="125000"/>
+              </a:lnSpc>
+              <a:spcBef>
+                <a:spcPts val="0"/>
+              </a:spcBef>
+              <a:spcAft>
+                <a:spcPts val="400"/>
+              </a:spcAft>
+            </a:pPr>
+            <a:r>
+              <a:rPr sz="1450" b="0" i="0">
+                <a:solidFill>
+                  <a:srgbClr val="222833"/>
+                </a:solidFill>
+                <a:latin typeface="Calibri"/>
+              </a:rPr>
+              <a:t>A new explainer page on meteor showers — what they are, when to look, and the surprising way Singapore’s latitude reshuffles the “best” ones.</a:t>
+            </a:r>
+          </a:p>
+        </p:txBody>
+      </p:sp>
+      <p:sp>
+        <p:nvSpPr>
+          <p:cNvPr id="8" name="Rounded Rectangle 7"/>
+          <p:cNvSpPr/>
+          <p:nvPr/>
+        </p:nvSpPr>
+        <p:spPr>
+          <a:xfrm>
+            <a:off x="548640" y="2377440"/>
+            <a:ext cx="3611880" cy="1234440"/>
+          </a:xfrm>
+          <a:prstGeom prst="roundRect">
+            <a:avLst>
+              <a:gd name="adj" fmla="val 10000"/>
+            </a:avLst>
+          </a:prstGeom>
+          <a:solidFill>
+            <a:srgbClr val="F3F5FA"/>
+          </a:solidFill>
+          <a:ln>
+            <a:noFill/>
+          </a:ln>
+          <a:effectLst/>
+        </p:spPr>
+        <p:style>
+          <a:lnRef idx="1">
+            <a:schemeClr val="accent1"/>
+          </a:lnRef>
+          <a:fillRef idx="3">
+            <a:schemeClr val="accent1"/>
+          </a:fillRef>
+          <a:effectRef idx="2">
+            <a:schemeClr val="accent1"/>
+          </a:effectRef>
+          <a:fontRef idx="minor">
+            <a:schemeClr val="lt1"/>
+          </a:fontRef>
+        </p:style>
+        <p:txBody>
+          <a:bodyPr rtlCol="0" anchor="ctr"/>
+          <a:lstStyle/>
+          <a:p>
+            <a:pPr algn="ctr"/>
+            <a:endParaRPr/>
+          </a:p>
+        </p:txBody>
+      </p:sp>
+      <p:sp>
+        <p:nvSpPr>
+          <p:cNvPr id="9" name="TextBox 8"/>
+          <p:cNvSpPr txBox="1"/>
+          <p:nvPr/>
+        </p:nvSpPr>
+        <p:spPr>
+          <a:xfrm>
+            <a:off x="768096" y="2523744"/>
+            <a:ext cx="3200400" cy="365760"/>
+          </a:xfrm>
+          <a:prstGeom prst="rect">
+            <a:avLst/>
+          </a:prstGeom>
+          <a:noFill/>
+        </p:spPr>
+        <p:txBody>
+          <a:bodyPr wrap="square" lIns="0" tIns="0" rIns="0" bIns="0" anchor="t">
+            <a:spAutoFit/>
+          </a:bodyPr>
+          <a:lstStyle/>
+          <a:p>
+            <a:pPr algn="l">
+              <a:lnSpc>
+                <a:spcPct val="100000"/>
+              </a:lnSpc>
+              <a:spcBef>
+                <a:spcPts val="0"/>
+              </a:spcBef>
+              <a:spcAft>
+                <a:spcPts val="400"/>
+              </a:spcAft>
+            </a:pPr>
+            <a:r>
+              <a:rPr sz="1450" b="1" i="0">
+                <a:solidFill>
+                  <a:srgbClr val="1B2A5B"/>
+                </a:solidFill>
+                <a:latin typeface="Cambria"/>
+              </a:rPr>
+              <a:t>What a shower is</a:t>
+            </a:r>
+          </a:p>
+        </p:txBody>
+      </p:sp>
+      <p:sp>
+        <p:nvSpPr>
+          <p:cNvPr id="10" name="TextBox 9"/>
+          <p:cNvSpPr txBox="1"/>
+          <p:nvPr/>
+        </p:nvSpPr>
+        <p:spPr>
+          <a:xfrm>
+            <a:off x="768096" y="2907792"/>
+            <a:ext cx="3200400" cy="640080"/>
+          </a:xfrm>
+          <a:prstGeom prst="rect">
+            <a:avLst/>
+          </a:prstGeom>
+          <a:noFill/>
+        </p:spPr>
+        <p:txBody>
+          <a:bodyPr wrap="square" lIns="0" tIns="0" rIns="0" bIns="0" anchor="t">
+            <a:spAutoFit/>
+          </a:bodyPr>
+          <a:lstStyle/>
+          <a:p>
+            <a:pPr algn="l">
+              <a:lnSpc>
+                <a:spcPct val="113000"/>
+              </a:lnSpc>
+              <a:spcBef>
+                <a:spcPts val="0"/>
+              </a:spcBef>
+              <a:spcAft>
+                <a:spcPts val="400"/>
+              </a:spcAft>
+            </a:pPr>
+            <a:r>
+              <a:rPr sz="1200" b="0" i="0">
+                <a:solidFill>
+                  <a:srgbClr val="636B7A"/>
+                </a:solidFill>
+                <a:latin typeface="Calibri"/>
+              </a:rPr>
+              <a:t>Earth ploughing through a comet’s debris trail on the same dates each year; a grain of sand burning up 100 km overhead.</a:t>
+            </a:r>
+          </a:p>
+        </p:txBody>
+      </p:sp>
+      <p:sp>
+        <p:nvSpPr>
+          <p:cNvPr id="11" name="Rounded Rectangle 10"/>
+          <p:cNvSpPr/>
+          <p:nvPr/>
+        </p:nvSpPr>
+        <p:spPr>
+          <a:xfrm>
+            <a:off x="4325112" y="2377440"/>
+            <a:ext cx="3611880" cy="1234440"/>
+          </a:xfrm>
+          <a:prstGeom prst="roundRect">
+            <a:avLst>
+              <a:gd name="adj" fmla="val 10000"/>
+            </a:avLst>
+          </a:prstGeom>
+          <a:solidFill>
+            <a:srgbClr val="F3F5FA"/>
+          </a:solidFill>
+          <a:ln>
+            <a:noFill/>
+          </a:ln>
+          <a:effectLst/>
+        </p:spPr>
+        <p:style>
+          <a:lnRef idx="1">
+            <a:schemeClr val="accent1"/>
+          </a:lnRef>
+          <a:fillRef idx="3">
+            <a:schemeClr val="accent1"/>
+          </a:fillRef>
+          <a:effectRef idx="2">
+            <a:schemeClr val="accent1"/>
+          </a:effectRef>
+          <a:fontRef idx="minor">
+            <a:schemeClr val="lt1"/>
+          </a:fontRef>
+        </p:style>
+        <p:txBody>
+          <a:bodyPr rtlCol="0" anchor="ctr"/>
+          <a:lstStyle/>
+          <a:p>
+            <a:pPr algn="ctr"/>
+            <a:endParaRPr/>
+          </a:p>
+        </p:txBody>
+      </p:sp>
+      <p:sp>
+        <p:nvSpPr>
+          <p:cNvPr id="12" name="TextBox 11"/>
+          <p:cNvSpPr txBox="1"/>
+          <p:nvPr/>
+        </p:nvSpPr>
+        <p:spPr>
+          <a:xfrm>
+            <a:off x="4544568" y="2523744"/>
+            <a:ext cx="3200400" cy="365760"/>
+          </a:xfrm>
+          <a:prstGeom prst="rect">
+            <a:avLst/>
+          </a:prstGeom>
+          <a:noFill/>
+        </p:spPr>
+        <p:txBody>
+          <a:bodyPr wrap="square" lIns="0" tIns="0" rIns="0" bIns="0" anchor="t">
+            <a:spAutoFit/>
+          </a:bodyPr>
+          <a:lstStyle/>
+          <a:p>
+            <a:pPr algn="l">
+              <a:lnSpc>
+                <a:spcPct val="100000"/>
+              </a:lnSpc>
+              <a:spcBef>
+                <a:spcPts val="0"/>
+              </a:spcBef>
+              <a:spcAft>
+                <a:spcPts val="400"/>
+              </a:spcAft>
+            </a:pPr>
+            <a:r>
+              <a:rPr sz="1450" b="1" i="0">
+                <a:solidFill>
+                  <a:srgbClr val="1B2A5B"/>
+                </a:solidFill>
+                <a:latin typeface="Cambria"/>
+              </a:rPr>
+              <a:t>The radiant &amp; after-midnight</a:t>
+            </a:r>
+          </a:p>
+        </p:txBody>
+      </p:sp>
+      <p:sp>
+        <p:nvSpPr>
+          <p:cNvPr id="13" name="TextBox 12"/>
+          <p:cNvSpPr txBox="1"/>
+          <p:nvPr/>
+        </p:nvSpPr>
+        <p:spPr>
+          <a:xfrm>
+            <a:off x="4544568" y="2907792"/>
+            <a:ext cx="3200400" cy="640080"/>
+          </a:xfrm>
+          <a:prstGeom prst="rect">
+            <a:avLst/>
+          </a:prstGeom>
+          <a:noFill/>
+        </p:spPr>
+        <p:txBody>
+          <a:bodyPr wrap="square" lIns="0" tIns="0" rIns="0" bIns="0" anchor="t">
+            <a:spAutoFit/>
+          </a:bodyPr>
+          <a:lstStyle/>
+          <a:p>
+            <a:pPr algn="l">
+              <a:lnSpc>
+                <a:spcPct val="113000"/>
+              </a:lnSpc>
+              <a:spcBef>
+                <a:spcPts val="0"/>
+              </a:spcBef>
+              <a:spcAft>
+                <a:spcPts val="400"/>
+              </a:spcAft>
+            </a:pPr>
+            <a:r>
+              <a:rPr sz="1200" b="0" i="0">
+                <a:solidFill>
+                  <a:srgbClr val="636B7A"/>
+                </a:solidFill>
+                <a:latin typeface="Calibri"/>
+              </a:rPr>
+              <a:t>Why parallel meteors seem to fan from one point, and why the pre-dawn hours (Earth’s leading edge) always win.</a:t>
+            </a:r>
+          </a:p>
+        </p:txBody>
+      </p:sp>
+      <p:sp>
+        <p:nvSpPr>
+          <p:cNvPr id="14" name="Rounded Rectangle 13"/>
+          <p:cNvSpPr/>
+          <p:nvPr/>
+        </p:nvSpPr>
+        <p:spPr>
+          <a:xfrm>
+            <a:off x="8101583" y="2377440"/>
+            <a:ext cx="3611880" cy="1234440"/>
+          </a:xfrm>
+          <a:prstGeom prst="roundRect">
+            <a:avLst>
+              <a:gd name="adj" fmla="val 10000"/>
+            </a:avLst>
+          </a:prstGeom>
+          <a:solidFill>
+            <a:srgbClr val="F3F5FA"/>
+          </a:solidFill>
+          <a:ln>
+            <a:noFill/>
+          </a:ln>
+          <a:effectLst/>
+        </p:spPr>
+        <p:style>
+          <a:lnRef idx="1">
+            <a:schemeClr val="accent1"/>
+          </a:lnRef>
+          <a:fillRef idx="3">
+            <a:schemeClr val="accent1"/>
+          </a:fillRef>
+          <a:effectRef idx="2">
+            <a:schemeClr val="accent1"/>
+          </a:effectRef>
+          <a:fontRef idx="minor">
+            <a:schemeClr val="lt1"/>
+          </a:fontRef>
+        </p:style>
+        <p:txBody>
+          <a:bodyPr rtlCol="0" anchor="ctr"/>
+          <a:lstStyle/>
+          <a:p>
+            <a:pPr algn="ctr"/>
+            <a:endParaRPr/>
+          </a:p>
+        </p:txBody>
+      </p:sp>
+      <p:sp>
+        <p:nvSpPr>
+          <p:cNvPr id="15" name="TextBox 14"/>
+          <p:cNvSpPr txBox="1"/>
+          <p:nvPr/>
+        </p:nvSpPr>
+        <p:spPr>
+          <a:xfrm>
+            <a:off x="8321040" y="2523744"/>
+            <a:ext cx="3200400" cy="365760"/>
+          </a:xfrm>
+          <a:prstGeom prst="rect">
+            <a:avLst/>
+          </a:prstGeom>
+          <a:noFill/>
+        </p:spPr>
+        <p:txBody>
+          <a:bodyPr wrap="square" lIns="0" tIns="0" rIns="0" bIns="0" anchor="t">
+            <a:spAutoFit/>
+          </a:bodyPr>
+          <a:lstStyle/>
+          <a:p>
+            <a:pPr algn="l">
+              <a:lnSpc>
+                <a:spcPct val="100000"/>
+              </a:lnSpc>
+              <a:spcBef>
+                <a:spcPts val="0"/>
+              </a:spcBef>
+              <a:spcAft>
+                <a:spcPts val="400"/>
+              </a:spcAft>
+            </a:pPr>
+            <a:r>
+              <a:rPr sz="1450" b="1" i="0">
+                <a:solidFill>
+                  <a:srgbClr val="1B2A5B"/>
+                </a:solidFill>
+                <a:latin typeface="Cambria"/>
+              </a:rPr>
+              <a:t>Singapore reshuffles the ranking</a:t>
+            </a:r>
+          </a:p>
+        </p:txBody>
+      </p:sp>
+      <p:sp>
+        <p:nvSpPr>
+          <p:cNvPr id="16" name="TextBox 15"/>
+          <p:cNvSpPr txBox="1"/>
+          <p:nvPr/>
+        </p:nvSpPr>
+        <p:spPr>
+          <a:xfrm>
+            <a:off x="8321040" y="2907792"/>
+            <a:ext cx="3200400" cy="640080"/>
+          </a:xfrm>
+          <a:prstGeom prst="rect">
+            <a:avLst/>
+          </a:prstGeom>
+          <a:noFill/>
+        </p:spPr>
+        <p:txBody>
+          <a:bodyPr wrap="square" lIns="0" tIns="0" rIns="0" bIns="0" anchor="t">
+            <a:spAutoFit/>
+          </a:bodyPr>
+          <a:lstStyle/>
+          <a:p>
+            <a:pPr algn="l">
+              <a:lnSpc>
+                <a:spcPct val="113000"/>
+              </a:lnSpc>
+              <a:spcBef>
+                <a:spcPts val="0"/>
+              </a:spcBef>
+              <a:spcAft>
+                <a:spcPts val="400"/>
+              </a:spcAft>
+            </a:pPr>
+            <a:r>
+              <a:rPr sz="1200" b="0" i="0">
+                <a:solidFill>
+                  <a:srgbClr val="636B7A"/>
+                </a:solidFill>
+                <a:latin typeface="Calibri"/>
+              </a:rPr>
+              <a:t>Rate falls with the radiant’s height, so the famous Perseids and Quadrantids underperform here — while Halley’s Eta Aquariids and Orionids ride high and shine.</a:t>
+            </a:r>
+          </a:p>
+        </p:txBody>
+      </p:sp>
+      <p:sp>
+        <p:nvSpPr>
+          <p:cNvPr id="17" name="Rounded Rectangle 16"/>
+          <p:cNvSpPr/>
+          <p:nvPr/>
+        </p:nvSpPr>
+        <p:spPr>
+          <a:xfrm>
+            <a:off x="548640" y="3794760"/>
+            <a:ext cx="3611880" cy="1234440"/>
+          </a:xfrm>
+          <a:prstGeom prst="roundRect">
+            <a:avLst>
+              <a:gd name="adj" fmla="val 10000"/>
+            </a:avLst>
+          </a:prstGeom>
+          <a:solidFill>
+            <a:srgbClr val="F3F5FA"/>
+          </a:solidFill>
+          <a:ln>
+            <a:noFill/>
+          </a:ln>
+          <a:effectLst/>
+        </p:spPr>
+        <p:style>
+          <a:lnRef idx="1">
+            <a:schemeClr val="accent1"/>
+          </a:lnRef>
+          <a:fillRef idx="3">
+            <a:schemeClr val="accent1"/>
+          </a:fillRef>
+          <a:effectRef idx="2">
+            <a:schemeClr val="accent1"/>
+          </a:effectRef>
+          <a:fontRef idx="minor">
+            <a:schemeClr val="lt1"/>
+          </a:fontRef>
+        </p:style>
+        <p:txBody>
+          <a:bodyPr rtlCol="0" anchor="ctr"/>
+          <a:lstStyle/>
+          <a:p>
+            <a:pPr algn="ctr"/>
+            <a:endParaRPr/>
+          </a:p>
+        </p:txBody>
+      </p:sp>
+      <p:sp>
+        <p:nvSpPr>
+          <p:cNvPr id="18" name="TextBox 17"/>
+          <p:cNvSpPr txBox="1"/>
+          <p:nvPr/>
+        </p:nvSpPr>
+        <p:spPr>
+          <a:xfrm>
+            <a:off x="768096" y="3941064"/>
+            <a:ext cx="3200400" cy="365760"/>
+          </a:xfrm>
+          <a:prstGeom prst="rect">
+            <a:avLst/>
+          </a:prstGeom>
+          <a:noFill/>
+        </p:spPr>
+        <p:txBody>
+          <a:bodyPr wrap="square" lIns="0" tIns="0" rIns="0" bIns="0" anchor="t">
+            <a:spAutoFit/>
+          </a:bodyPr>
+          <a:lstStyle/>
+          <a:p>
+            <a:pPr algn="l">
+              <a:lnSpc>
+                <a:spcPct val="100000"/>
+              </a:lnSpc>
+              <a:spcBef>
+                <a:spcPts val="0"/>
+              </a:spcBef>
+              <a:spcAft>
+                <a:spcPts val="400"/>
+              </a:spcAft>
+            </a:pPr>
+            <a:r>
+              <a:rPr sz="1450" b="1" i="0">
+                <a:solidFill>
+                  <a:srgbClr val="1B2A5B"/>
+                </a:solidFill>
+                <a:latin typeface="Cambria"/>
+              </a:rPr>
+              <a:t>A live “next shower” panel</a:t>
+            </a:r>
+          </a:p>
+        </p:txBody>
+      </p:sp>
+      <p:sp>
+        <p:nvSpPr>
+          <p:cNvPr id="19" name="TextBox 18"/>
+          <p:cNvSpPr txBox="1"/>
+          <p:nvPr/>
+        </p:nvSpPr>
+        <p:spPr>
+          <a:xfrm>
+            <a:off x="768096" y="4325112"/>
+            <a:ext cx="3200400" cy="640080"/>
+          </a:xfrm>
+          <a:prstGeom prst="rect">
+            <a:avLst/>
+          </a:prstGeom>
+          <a:noFill/>
+        </p:spPr>
+        <p:txBody>
+          <a:bodyPr wrap="square" lIns="0" tIns="0" rIns="0" bIns="0" anchor="t">
+            <a:spAutoFit/>
+          </a:bodyPr>
+          <a:lstStyle/>
+          <a:p>
+            <a:pPr algn="l">
+              <a:lnSpc>
+                <a:spcPct val="113000"/>
+              </a:lnSpc>
+              <a:spcBef>
+                <a:spcPts val="0"/>
+              </a:spcBef>
+              <a:spcAft>
+                <a:spcPts val="400"/>
+              </a:spcAft>
+            </a:pPr>
+            <a:r>
+              <a:rPr sz="1200" b="0" i="0">
+                <a:solidFill>
+                  <a:srgbClr val="636B7A"/>
+                </a:solidFill>
+                <a:latin typeface="Calibri"/>
+              </a:rPr>
+              <a:t>Names the next shower, days to peak, its rate, how high the radiant climbs from SCOB, and this year’s Moon interference — all on-device.</a:t>
+            </a:r>
+          </a:p>
+        </p:txBody>
+      </p:sp>
+      <p:sp>
+        <p:nvSpPr>
+          <p:cNvPr id="20" name="Rounded Rectangle 19"/>
+          <p:cNvSpPr/>
+          <p:nvPr/>
+        </p:nvSpPr>
+        <p:spPr>
+          <a:xfrm>
+            <a:off x="4325112" y="3794760"/>
+            <a:ext cx="3611880" cy="1234440"/>
+          </a:xfrm>
+          <a:prstGeom prst="roundRect">
+            <a:avLst>
+              <a:gd name="adj" fmla="val 10000"/>
+            </a:avLst>
+          </a:prstGeom>
+          <a:solidFill>
+            <a:srgbClr val="F3F5FA"/>
+          </a:solidFill>
+          <a:ln>
+            <a:noFill/>
+          </a:ln>
+          <a:effectLst/>
+        </p:spPr>
+        <p:style>
+          <a:lnRef idx="1">
+            <a:schemeClr val="accent1"/>
+          </a:lnRef>
+          <a:fillRef idx="3">
+            <a:schemeClr val="accent1"/>
+          </a:fillRef>
+          <a:effectRef idx="2">
+            <a:schemeClr val="accent1"/>
+          </a:effectRef>
+          <a:fontRef idx="minor">
+            <a:schemeClr val="lt1"/>
+          </a:fontRef>
+        </p:style>
+        <p:txBody>
+          <a:bodyPr rtlCol="0" anchor="ctr"/>
+          <a:lstStyle/>
+          <a:p>
+            <a:pPr algn="ctr"/>
+            <a:endParaRPr/>
+          </a:p>
+        </p:txBody>
+      </p:sp>
+      <p:sp>
+        <p:nvSpPr>
+          <p:cNvPr id="21" name="TextBox 20"/>
+          <p:cNvSpPr txBox="1"/>
+          <p:nvPr/>
+        </p:nvSpPr>
+        <p:spPr>
+          <a:xfrm>
+            <a:off x="4544568" y="3941064"/>
+            <a:ext cx="3200400" cy="365760"/>
+          </a:xfrm>
+          <a:prstGeom prst="rect">
+            <a:avLst/>
+          </a:prstGeom>
+          <a:noFill/>
+        </p:spPr>
+        <p:txBody>
+          <a:bodyPr wrap="square" lIns="0" tIns="0" rIns="0" bIns="0" anchor="t">
+            <a:spAutoFit/>
+          </a:bodyPr>
+          <a:lstStyle/>
+          <a:p>
+            <a:pPr algn="l">
+              <a:lnSpc>
+                <a:spcPct val="100000"/>
+              </a:lnSpc>
+              <a:spcBef>
+                <a:spcPts val="0"/>
+              </a:spcBef>
+              <a:spcAft>
+                <a:spcPts val="400"/>
+              </a:spcAft>
+            </a:pPr>
+            <a:r>
+              <a:rPr sz="1450" b="1" i="0">
+                <a:solidFill>
+                  <a:srgbClr val="1B2A5B"/>
+                </a:solidFill>
+                <a:latin typeface="Cambria"/>
+              </a:rPr>
+              <a:t>The year ranked for us</a:t>
+            </a:r>
+          </a:p>
+        </p:txBody>
+      </p:sp>
+      <p:sp>
+        <p:nvSpPr>
+          <p:cNvPr id="22" name="TextBox 21"/>
+          <p:cNvSpPr txBox="1"/>
+          <p:nvPr/>
+        </p:nvSpPr>
+        <p:spPr>
+          <a:xfrm>
+            <a:off x="4544568" y="4325112"/>
+            <a:ext cx="3200400" cy="640080"/>
+          </a:xfrm>
+          <a:prstGeom prst="rect">
+            <a:avLst/>
+          </a:prstGeom>
+          <a:noFill/>
+        </p:spPr>
+        <p:txBody>
+          <a:bodyPr wrap="square" lIns="0" tIns="0" rIns="0" bIns="0" anchor="t">
+            <a:spAutoFit/>
+          </a:bodyPr>
+          <a:lstStyle/>
+          <a:p>
+            <a:pPr algn="l">
+              <a:lnSpc>
+                <a:spcPct val="113000"/>
+              </a:lnSpc>
+              <a:spcBef>
+                <a:spcPts val="0"/>
+              </a:spcBef>
+              <a:spcAft>
+                <a:spcPts val="400"/>
+              </a:spcAft>
+            </a:pPr>
+            <a:r>
+              <a:rPr sz="1200" b="0" i="0">
+                <a:solidFill>
+                  <a:srgbClr val="636B7A"/>
+                </a:solidFill>
+                <a:latin typeface="Calibri"/>
+              </a:rPr>
+              <a:t>A table of all nine major showers sorted by how well they actually fare from Singapore.</a:t>
+            </a:r>
+          </a:p>
+        </p:txBody>
+      </p:sp>
+      <p:sp>
+        <p:nvSpPr>
+          <p:cNvPr id="23" name="Rounded Rectangle 22"/>
+          <p:cNvSpPr/>
+          <p:nvPr/>
+        </p:nvSpPr>
+        <p:spPr>
+          <a:xfrm>
+            <a:off x="8101583" y="3794760"/>
+            <a:ext cx="3611880" cy="1234440"/>
+          </a:xfrm>
+          <a:prstGeom prst="roundRect">
+            <a:avLst>
+              <a:gd name="adj" fmla="val 10000"/>
+            </a:avLst>
+          </a:prstGeom>
+          <a:solidFill>
+            <a:srgbClr val="F3F5FA"/>
+          </a:solidFill>
+          <a:ln>
+            <a:noFill/>
+          </a:ln>
+          <a:effectLst/>
+        </p:spPr>
+        <p:style>
+          <a:lnRef idx="1">
+            <a:schemeClr val="accent1"/>
+          </a:lnRef>
+          <a:fillRef idx="3">
+            <a:schemeClr val="accent1"/>
+          </a:fillRef>
+          <a:effectRef idx="2">
+            <a:schemeClr val="accent1"/>
+          </a:effectRef>
+          <a:fontRef idx="minor">
+            <a:schemeClr val="lt1"/>
+          </a:fontRef>
+        </p:style>
+        <p:txBody>
+          <a:bodyPr rtlCol="0" anchor="ctr"/>
+          <a:lstStyle/>
+          <a:p>
+            <a:pPr algn="ctr"/>
+            <a:endParaRPr/>
+          </a:p>
+        </p:txBody>
+      </p:sp>
+      <p:sp>
+        <p:nvSpPr>
+          <p:cNvPr id="24" name="TextBox 23"/>
+          <p:cNvSpPr txBox="1"/>
+          <p:nvPr/>
+        </p:nvSpPr>
+        <p:spPr>
+          <a:xfrm>
+            <a:off x="8321040" y="3941064"/>
+            <a:ext cx="3200400" cy="365760"/>
+          </a:xfrm>
+          <a:prstGeom prst="rect">
+            <a:avLst/>
+          </a:prstGeom>
+          <a:noFill/>
+        </p:spPr>
+        <p:txBody>
+          <a:bodyPr wrap="square" lIns="0" tIns="0" rIns="0" bIns="0" anchor="t">
+            <a:spAutoFit/>
+          </a:bodyPr>
+          <a:lstStyle/>
+          <a:p>
+            <a:pPr algn="l">
+              <a:lnSpc>
+                <a:spcPct val="100000"/>
+              </a:lnSpc>
+              <a:spcBef>
+                <a:spcPts val="0"/>
+              </a:spcBef>
+              <a:spcAft>
+                <a:spcPts val="400"/>
+              </a:spcAft>
+            </a:pPr>
+            <a:r>
+              <a:rPr sz="1450" b="1" i="0">
+                <a:solidFill>
+                  <a:srgbClr val="1B2A5B"/>
+                </a:solidFill>
+                <a:latin typeface="Cambria"/>
+              </a:rPr>
+              <a:t>Where to find it</a:t>
+            </a:r>
+          </a:p>
+        </p:txBody>
+      </p:sp>
+      <p:sp>
+        <p:nvSpPr>
+          <p:cNvPr id="25" name="TextBox 24"/>
+          <p:cNvSpPr txBox="1"/>
+          <p:nvPr/>
+        </p:nvSpPr>
+        <p:spPr>
+          <a:xfrm>
+            <a:off x="8321040" y="4325112"/>
+            <a:ext cx="3200400" cy="640080"/>
+          </a:xfrm>
+          <a:prstGeom prst="rect">
+            <a:avLst/>
+          </a:prstGeom>
+          <a:noFill/>
+        </p:spPr>
+        <p:txBody>
+          <a:bodyPr wrap="square" lIns="0" tIns="0" rIns="0" bIns="0" anchor="t">
+            <a:spAutoFit/>
+          </a:bodyPr>
+          <a:lstStyle/>
+          <a:p>
+            <a:pPr algn="l">
+              <a:lnSpc>
+                <a:spcPct val="113000"/>
+              </a:lnSpc>
+              <a:spcBef>
+                <a:spcPts val="0"/>
+              </a:spcBef>
+              <a:spcAft>
+                <a:spcPts val="400"/>
+              </a:spcAft>
+            </a:pPr>
+            <a:r>
+              <a:rPr sz="1200" b="0" i="0">
+                <a:solidFill>
+                  <a:srgbClr val="636B7A"/>
+                </a:solidFill>
+                <a:latin typeface="Calibri"/>
+              </a:rPr>
+              <a:t>Linked from the dashboard menu, the almanac’s shower card, and the visitor Sky Guide (four languages).</a:t>
+            </a:r>
+          </a:p>
+        </p:txBody>
+      </p:sp>
+      <p:sp>
+        <p:nvSpPr>
+          <p:cNvPr id="26" name="RS_Classification">
+            <a:extLst>
+              <a:ext uri="{FF2B5EF4-FFF2-40B4-BE49-F238E27FC236}">
+                <a16:creationId xmlns:a16="http://schemas.microsoft.com/office/drawing/2014/main" id="{2375B548-02D6-6383-5DC1-367F1F6C4B7E}"/>
+              </a:ext>
+            </a:extLst>
+          </p:cNvPr>
+          <p:cNvSpPr txBox="1"/>
+          <p:nvPr/>
+        </p:nvSpPr>
+        <p:spPr>
+          <a:xfrm>
+            <a:off x="11999640" y="6289521"/>
+            <a:ext cx="192360" cy="212879"/>
+          </a:xfrm>
+          <a:prstGeom prst="rect">
+            <a:avLst/>
+          </a:prstGeom>
+          <a:solidFill>
+            <a:schemeClr val="accent1"/>
+          </a:solidFill>
+        </p:spPr>
+        <p:txBody>
+          <a:bodyPr vert="horz" wrap="none" lIns="76200" tIns="36830" rIns="76200" bIns="36830" rtlCol="0" anchor="ctr">
+            <a:spAutoFit/>
+          </a:bodyPr>
+          <a:lstStyle/>
+          <a:p>
+            <a:r>
+              <a:rPr lang="en-SG" sz="900" b="1" kern="900" spc="100"/>
+              <a:t> </a:t>
+            </a:r>
+          </a:p>
+        </p:txBody>
+      </p:sp>
+    </p:spTree>
+  </p:cSld>
+  <p:clrMapOvr>
+    <a:masterClrMapping/>
+  </p:clrMapOvr>
+</p:sld>
+</file>
+
+<file path=ppt/slides/slide43.xml><?xml version="1.0" encoding="utf-8"?>
 <p:sld xmlns:a="http://schemas.openxmlformats.org/drawingml/2006/main" xmlns:r="http://schemas.openxmlformats.org/officeDocument/2006/relationships" xmlns:p="http://schemas.openxmlformats.org/presentationml/2006/main">
   <p:cSld>
     <p:bg>
@@ -47434,1153 +48581,6 @@
             <a:extLst>
               <a:ext uri="{FF2B5EF4-FFF2-40B4-BE49-F238E27FC236}">
                 <a16:creationId xmlns:a16="http://schemas.microsoft.com/office/drawing/2014/main" id="{E4566C4E-ED38-D3B4-4801-CC02550F17FD}"/>
-              </a:ext>
-            </a:extLst>
-          </p:cNvPr>
-          <p:cNvSpPr txBox="1"/>
-          <p:nvPr/>
-        </p:nvSpPr>
-        <p:spPr>
-          <a:xfrm>
-            <a:off x="11999640" y="6289521"/>
-            <a:ext cx="192360" cy="212879"/>
-          </a:xfrm>
-          <a:prstGeom prst="rect">
-            <a:avLst/>
-          </a:prstGeom>
-          <a:solidFill>
-            <a:schemeClr val="accent1"/>
-          </a:solidFill>
-        </p:spPr>
-        <p:txBody>
-          <a:bodyPr vert="horz" wrap="none" lIns="76200" tIns="36830" rIns="76200" bIns="36830" rtlCol="0" anchor="ctr">
-            <a:spAutoFit/>
-          </a:bodyPr>
-          <a:lstStyle/>
-          <a:p>
-            <a:r>
-              <a:rPr lang="en-SG" sz="900" b="1" kern="900" spc="100"/>
-              <a:t> </a:t>
-            </a:r>
-          </a:p>
-        </p:txBody>
-      </p:sp>
-    </p:spTree>
-  </p:cSld>
-  <p:clrMapOvr>
-    <a:masterClrMapping/>
-  </p:clrMapOvr>
-</p:sld>
-</file>
-
-<file path=ppt/slides/slide43.xml><?xml version="1.0" encoding="utf-8"?>
-<p:sld xmlns:a="http://schemas.openxmlformats.org/drawingml/2006/main" xmlns:p="http://schemas.openxmlformats.org/presentationml/2006/main" xmlns:r="http://schemas.openxmlformats.org/officeDocument/2006/relationships">
-  <p:cSld>
-    <p:spTree>
-      <p:nvGrpSpPr>
-        <p:cNvPr id="1" name=""/>
-        <p:cNvGrpSpPr/>
-        <p:nvPr/>
-      </p:nvGrpSpPr>
-      <p:grpSpPr/>
-      <p:sp>
-        <p:nvSpPr>
-          <p:cNvPr id="2" name="Oval 1"/>
-          <p:cNvSpPr/>
-          <p:nvPr/>
-        </p:nvSpPr>
-        <p:spPr>
-          <a:xfrm>
-            <a:off x="502920" y="457200"/>
-            <a:ext cx="146304" cy="146304"/>
-          </a:xfrm>
-          <a:prstGeom prst="ellipse">
-            <a:avLst/>
-          </a:prstGeom>
-          <a:solidFill>
-            <a:srgbClr val="E0A930"/>
-          </a:solidFill>
-          <a:ln>
-            <a:noFill/>
-          </a:ln>
-          <a:effectLst/>
-        </p:spPr>
-        <p:style>
-          <a:lnRef idx="1">
-            <a:schemeClr val="accent1"/>
-          </a:lnRef>
-          <a:fillRef idx="3">
-            <a:schemeClr val="accent1"/>
-          </a:fillRef>
-          <a:effectRef idx="2">
-            <a:schemeClr val="accent1"/>
-          </a:effectRef>
-          <a:fontRef idx="minor">
-            <a:schemeClr val="lt1"/>
-          </a:fontRef>
-        </p:style>
-        <p:txBody>
-          <a:bodyPr wrap="none" lIns="0" tIns="0" rIns="0" bIns="0" rtlCol="0" anchor="ctr"/>
-          <a:lstStyle/>
-          <a:p>
-            <a:pPr algn="ctr"/>
-            <a:endParaRPr/>
-          </a:p>
-        </p:txBody>
-      </p:sp>
-      <p:sp>
-        <p:nvSpPr>
-          <p:cNvPr id="3" name="TextBox 2"/>
-          <p:cNvSpPr txBox="1"/>
-          <p:nvPr/>
-        </p:nvSpPr>
-        <p:spPr>
-          <a:xfrm>
-            <a:off x="731520" y="384048"/>
-            <a:ext cx="7315200" cy="274320"/>
-          </a:xfrm>
-          <a:prstGeom prst="rect">
-            <a:avLst/>
-          </a:prstGeom>
-          <a:noFill/>
-        </p:spPr>
-        <p:txBody>
-          <a:bodyPr wrap="square" lIns="0" tIns="0" rIns="0" bIns="0" anchor="t">
-            <a:spAutoFit/>
-          </a:bodyPr>
-          <a:lstStyle/>
-          <a:p>
-            <a:pPr algn="l">
-              <a:lnSpc>
-                <a:spcPct val="100000"/>
-              </a:lnSpc>
-              <a:spcBef>
-                <a:spcPts val="0"/>
-              </a:spcBef>
-              <a:spcAft>
-                <a:spcPts val="400"/>
-              </a:spcAft>
-            </a:pPr>
-            <a:r>
-              <a:rPr sz="1100" b="1" i="0">
-                <a:solidFill>
-                  <a:srgbClr val="E0A930"/>
-                </a:solidFill>
-                <a:latin typeface="Calibri"/>
-              </a:rPr>
-              <a:t>WHAT’S NEW IN v3.48</a:t>
-            </a:r>
-          </a:p>
-        </p:txBody>
-      </p:sp>
-      <p:sp>
-        <p:nvSpPr>
-          <p:cNvPr id="4" name="TextBox 3"/>
-          <p:cNvSpPr txBox="1"/>
-          <p:nvPr/>
-        </p:nvSpPr>
-        <p:spPr>
-          <a:xfrm>
-            <a:off x="502920" y="658368"/>
-            <a:ext cx="10515600" cy="731520"/>
-          </a:xfrm>
-          <a:prstGeom prst="rect">
-            <a:avLst/>
-          </a:prstGeom>
-          <a:noFill/>
-        </p:spPr>
-        <p:txBody>
-          <a:bodyPr wrap="square" lIns="0" tIns="0" rIns="0" bIns="0" anchor="t">
-            <a:spAutoFit/>
-          </a:bodyPr>
-          <a:lstStyle/>
-          <a:p>
-            <a:pPr algn="l">
-              <a:lnSpc>
-                <a:spcPct val="100000"/>
-              </a:lnSpc>
-              <a:spcBef>
-                <a:spcPts val="0"/>
-              </a:spcBef>
-              <a:spcAft>
-                <a:spcPts val="400"/>
-              </a:spcAft>
-            </a:pPr>
-            <a:r>
-              <a:rPr sz="3000" b="1" i="0">
-                <a:solidFill>
-                  <a:srgbClr val="1B2A5B"/>
-                </a:solidFill>
-                <a:latin typeface="Cambria"/>
-              </a:rPr>
-              <a:t>Meteor showers, explained</a:t>
-            </a:r>
-          </a:p>
-        </p:txBody>
-      </p:sp>
-      <p:sp>
-        <p:nvSpPr>
-          <p:cNvPr id="5" name="TextBox 4"/>
-          <p:cNvSpPr txBox="1"/>
-          <p:nvPr/>
-        </p:nvSpPr>
-        <p:spPr>
-          <a:xfrm>
-            <a:off x="502920" y="6455664"/>
-            <a:ext cx="8229600" cy="274320"/>
-          </a:xfrm>
-          <a:prstGeom prst="rect">
-            <a:avLst/>
-          </a:prstGeom>
-          <a:noFill/>
-        </p:spPr>
-        <p:txBody>
-          <a:bodyPr wrap="square" lIns="0" tIns="0" rIns="0" bIns="0" anchor="t">
-            <a:spAutoFit/>
-          </a:bodyPr>
-          <a:lstStyle/>
-          <a:p>
-            <a:pPr algn="l">
-              <a:lnSpc>
-                <a:spcPct val="100000"/>
-              </a:lnSpc>
-              <a:spcBef>
-                <a:spcPts val="0"/>
-              </a:spcBef>
-              <a:spcAft>
-                <a:spcPts val="400"/>
-              </a:spcAft>
-            </a:pPr>
-            <a:r>
-              <a:rPr sz="900" b="0" i="0">
-                <a:solidFill>
-                  <a:srgbClr val="9AA2B0"/>
-                </a:solidFill>
-                <a:latin typeface="Calibri"/>
-              </a:rPr>
-              <a:t>SCOB Night-Sky Dashboard  ·  Volunteer User Guide  ·  v3.48</a:t>
-            </a:r>
-          </a:p>
-        </p:txBody>
-      </p:sp>
-      <p:sp>
-        <p:nvSpPr>
-          <p:cNvPr id="6" name="TextBox 5"/>
-          <p:cNvSpPr txBox="1"/>
-          <p:nvPr/>
-        </p:nvSpPr>
-        <p:spPr>
-          <a:xfrm>
-            <a:off x="10607040" y="6455664"/>
-            <a:ext cx="1097280" cy="274320"/>
-          </a:xfrm>
-          <a:prstGeom prst="rect">
-            <a:avLst/>
-          </a:prstGeom>
-          <a:noFill/>
-        </p:spPr>
-        <p:txBody>
-          <a:bodyPr wrap="square" lIns="0" tIns="0" rIns="0" bIns="0" anchor="t">
-            <a:spAutoFit/>
-          </a:bodyPr>
-          <a:lstStyle/>
-          <a:p>
-            <a:pPr algn="r">
-              <a:lnSpc>
-                <a:spcPct val="100000"/>
-              </a:lnSpc>
-              <a:spcBef>
-                <a:spcPts val="0"/>
-              </a:spcBef>
-              <a:spcAft>
-                <a:spcPts val="400"/>
-              </a:spcAft>
-            </a:pPr>
-            <a:r>
-              <a:rPr sz="900" b="1" i="0">
-                <a:solidFill>
-                  <a:srgbClr val="9AA2B0"/>
-                </a:solidFill>
-                <a:latin typeface="Calibri"/>
-              </a:rPr>
-              <a:t>42</a:t>
-            </a:r>
-          </a:p>
-        </p:txBody>
-      </p:sp>
-      <p:sp>
-        <p:nvSpPr>
-          <p:cNvPr id="7" name="TextBox 6"/>
-          <p:cNvSpPr txBox="1"/>
-          <p:nvPr/>
-        </p:nvSpPr>
-        <p:spPr>
-          <a:xfrm>
-            <a:off x="502920" y="1554480"/>
-            <a:ext cx="10972800" cy="502920"/>
-          </a:xfrm>
-          <a:prstGeom prst="rect">
-            <a:avLst/>
-          </a:prstGeom>
-          <a:noFill/>
-        </p:spPr>
-        <p:txBody>
-          <a:bodyPr wrap="square" lIns="0" tIns="0" rIns="0" bIns="0" anchor="t">
-            <a:spAutoFit/>
-          </a:bodyPr>
-          <a:lstStyle/>
-          <a:p>
-            <a:pPr algn="l">
-              <a:lnSpc>
-                <a:spcPct val="125000"/>
-              </a:lnSpc>
-              <a:spcBef>
-                <a:spcPts val="0"/>
-              </a:spcBef>
-              <a:spcAft>
-                <a:spcPts val="400"/>
-              </a:spcAft>
-            </a:pPr>
-            <a:r>
-              <a:rPr sz="1450" b="0" i="0">
-                <a:solidFill>
-                  <a:srgbClr val="222833"/>
-                </a:solidFill>
-                <a:latin typeface="Calibri"/>
-              </a:rPr>
-              <a:t>A new explainer page on meteor showers — what they are, when to look, and the surprising way Singapore’s latitude reshuffles the “best” ones.</a:t>
-            </a:r>
-          </a:p>
-        </p:txBody>
-      </p:sp>
-      <p:sp>
-        <p:nvSpPr>
-          <p:cNvPr id="8" name="Rounded Rectangle 7"/>
-          <p:cNvSpPr/>
-          <p:nvPr/>
-        </p:nvSpPr>
-        <p:spPr>
-          <a:xfrm>
-            <a:off x="548640" y="2377440"/>
-            <a:ext cx="3611880" cy="1234440"/>
-          </a:xfrm>
-          <a:prstGeom prst="roundRect">
-            <a:avLst>
-              <a:gd name="adj" fmla="val 10000"/>
-            </a:avLst>
-          </a:prstGeom>
-          <a:solidFill>
-            <a:srgbClr val="F3F5FA"/>
-          </a:solidFill>
-          <a:ln>
-            <a:noFill/>
-          </a:ln>
-          <a:effectLst/>
-        </p:spPr>
-        <p:style>
-          <a:lnRef idx="1">
-            <a:schemeClr val="accent1"/>
-          </a:lnRef>
-          <a:fillRef idx="3">
-            <a:schemeClr val="accent1"/>
-          </a:fillRef>
-          <a:effectRef idx="2">
-            <a:schemeClr val="accent1"/>
-          </a:effectRef>
-          <a:fontRef idx="minor">
-            <a:schemeClr val="lt1"/>
-          </a:fontRef>
-        </p:style>
-        <p:txBody>
-          <a:bodyPr rtlCol="0" anchor="ctr"/>
-          <a:lstStyle/>
-          <a:p>
-            <a:pPr algn="ctr"/>
-            <a:endParaRPr/>
-          </a:p>
-        </p:txBody>
-      </p:sp>
-      <p:sp>
-        <p:nvSpPr>
-          <p:cNvPr id="9" name="TextBox 8"/>
-          <p:cNvSpPr txBox="1"/>
-          <p:nvPr/>
-        </p:nvSpPr>
-        <p:spPr>
-          <a:xfrm>
-            <a:off x="768096" y="2523744"/>
-            <a:ext cx="3200400" cy="365760"/>
-          </a:xfrm>
-          <a:prstGeom prst="rect">
-            <a:avLst/>
-          </a:prstGeom>
-          <a:noFill/>
-        </p:spPr>
-        <p:txBody>
-          <a:bodyPr wrap="square" lIns="0" tIns="0" rIns="0" bIns="0" anchor="t">
-            <a:spAutoFit/>
-          </a:bodyPr>
-          <a:lstStyle/>
-          <a:p>
-            <a:pPr algn="l">
-              <a:lnSpc>
-                <a:spcPct val="100000"/>
-              </a:lnSpc>
-              <a:spcBef>
-                <a:spcPts val="0"/>
-              </a:spcBef>
-              <a:spcAft>
-                <a:spcPts val="400"/>
-              </a:spcAft>
-            </a:pPr>
-            <a:r>
-              <a:rPr sz="1450" b="1" i="0">
-                <a:solidFill>
-                  <a:srgbClr val="1B2A5B"/>
-                </a:solidFill>
-                <a:latin typeface="Cambria"/>
-              </a:rPr>
-              <a:t>What a shower is</a:t>
-            </a:r>
-          </a:p>
-        </p:txBody>
-      </p:sp>
-      <p:sp>
-        <p:nvSpPr>
-          <p:cNvPr id="10" name="TextBox 9"/>
-          <p:cNvSpPr txBox="1"/>
-          <p:nvPr/>
-        </p:nvSpPr>
-        <p:spPr>
-          <a:xfrm>
-            <a:off x="768096" y="2907792"/>
-            <a:ext cx="3200400" cy="640080"/>
-          </a:xfrm>
-          <a:prstGeom prst="rect">
-            <a:avLst/>
-          </a:prstGeom>
-          <a:noFill/>
-        </p:spPr>
-        <p:txBody>
-          <a:bodyPr wrap="square" lIns="0" tIns="0" rIns="0" bIns="0" anchor="t">
-            <a:spAutoFit/>
-          </a:bodyPr>
-          <a:lstStyle/>
-          <a:p>
-            <a:pPr algn="l">
-              <a:lnSpc>
-                <a:spcPct val="113000"/>
-              </a:lnSpc>
-              <a:spcBef>
-                <a:spcPts val="0"/>
-              </a:spcBef>
-              <a:spcAft>
-                <a:spcPts val="400"/>
-              </a:spcAft>
-            </a:pPr>
-            <a:r>
-              <a:rPr sz="1200" b="0" i="0">
-                <a:solidFill>
-                  <a:srgbClr val="636B7A"/>
-                </a:solidFill>
-                <a:latin typeface="Calibri"/>
-              </a:rPr>
-              <a:t>Earth ploughing through a comet’s debris trail on the same dates each year; a grain of sand burning up 100 km overhead.</a:t>
-            </a:r>
-          </a:p>
-        </p:txBody>
-      </p:sp>
-      <p:sp>
-        <p:nvSpPr>
-          <p:cNvPr id="11" name="Rounded Rectangle 10"/>
-          <p:cNvSpPr/>
-          <p:nvPr/>
-        </p:nvSpPr>
-        <p:spPr>
-          <a:xfrm>
-            <a:off x="4325112" y="2377440"/>
-            <a:ext cx="3611880" cy="1234440"/>
-          </a:xfrm>
-          <a:prstGeom prst="roundRect">
-            <a:avLst>
-              <a:gd name="adj" fmla="val 10000"/>
-            </a:avLst>
-          </a:prstGeom>
-          <a:solidFill>
-            <a:srgbClr val="F3F5FA"/>
-          </a:solidFill>
-          <a:ln>
-            <a:noFill/>
-          </a:ln>
-          <a:effectLst/>
-        </p:spPr>
-        <p:style>
-          <a:lnRef idx="1">
-            <a:schemeClr val="accent1"/>
-          </a:lnRef>
-          <a:fillRef idx="3">
-            <a:schemeClr val="accent1"/>
-          </a:fillRef>
-          <a:effectRef idx="2">
-            <a:schemeClr val="accent1"/>
-          </a:effectRef>
-          <a:fontRef idx="minor">
-            <a:schemeClr val="lt1"/>
-          </a:fontRef>
-        </p:style>
-        <p:txBody>
-          <a:bodyPr rtlCol="0" anchor="ctr"/>
-          <a:lstStyle/>
-          <a:p>
-            <a:pPr algn="ctr"/>
-            <a:endParaRPr/>
-          </a:p>
-        </p:txBody>
-      </p:sp>
-      <p:sp>
-        <p:nvSpPr>
-          <p:cNvPr id="12" name="TextBox 11"/>
-          <p:cNvSpPr txBox="1"/>
-          <p:nvPr/>
-        </p:nvSpPr>
-        <p:spPr>
-          <a:xfrm>
-            <a:off x="4544568" y="2523744"/>
-            <a:ext cx="3200400" cy="365760"/>
-          </a:xfrm>
-          <a:prstGeom prst="rect">
-            <a:avLst/>
-          </a:prstGeom>
-          <a:noFill/>
-        </p:spPr>
-        <p:txBody>
-          <a:bodyPr wrap="square" lIns="0" tIns="0" rIns="0" bIns="0" anchor="t">
-            <a:spAutoFit/>
-          </a:bodyPr>
-          <a:lstStyle/>
-          <a:p>
-            <a:pPr algn="l">
-              <a:lnSpc>
-                <a:spcPct val="100000"/>
-              </a:lnSpc>
-              <a:spcBef>
-                <a:spcPts val="0"/>
-              </a:spcBef>
-              <a:spcAft>
-                <a:spcPts val="400"/>
-              </a:spcAft>
-            </a:pPr>
-            <a:r>
-              <a:rPr sz="1450" b="1" i="0">
-                <a:solidFill>
-                  <a:srgbClr val="1B2A5B"/>
-                </a:solidFill>
-                <a:latin typeface="Cambria"/>
-              </a:rPr>
-              <a:t>The radiant &amp; after-midnight</a:t>
-            </a:r>
-          </a:p>
-        </p:txBody>
-      </p:sp>
-      <p:sp>
-        <p:nvSpPr>
-          <p:cNvPr id="13" name="TextBox 12"/>
-          <p:cNvSpPr txBox="1"/>
-          <p:nvPr/>
-        </p:nvSpPr>
-        <p:spPr>
-          <a:xfrm>
-            <a:off x="4544568" y="2907792"/>
-            <a:ext cx="3200400" cy="640080"/>
-          </a:xfrm>
-          <a:prstGeom prst="rect">
-            <a:avLst/>
-          </a:prstGeom>
-          <a:noFill/>
-        </p:spPr>
-        <p:txBody>
-          <a:bodyPr wrap="square" lIns="0" tIns="0" rIns="0" bIns="0" anchor="t">
-            <a:spAutoFit/>
-          </a:bodyPr>
-          <a:lstStyle/>
-          <a:p>
-            <a:pPr algn="l">
-              <a:lnSpc>
-                <a:spcPct val="113000"/>
-              </a:lnSpc>
-              <a:spcBef>
-                <a:spcPts val="0"/>
-              </a:spcBef>
-              <a:spcAft>
-                <a:spcPts val="400"/>
-              </a:spcAft>
-            </a:pPr>
-            <a:r>
-              <a:rPr sz="1200" b="0" i="0">
-                <a:solidFill>
-                  <a:srgbClr val="636B7A"/>
-                </a:solidFill>
-                <a:latin typeface="Calibri"/>
-              </a:rPr>
-              <a:t>Why parallel meteors seem to fan from one point, and why the pre-dawn hours (Earth’s leading edge) always win.</a:t>
-            </a:r>
-          </a:p>
-        </p:txBody>
-      </p:sp>
-      <p:sp>
-        <p:nvSpPr>
-          <p:cNvPr id="14" name="Rounded Rectangle 13"/>
-          <p:cNvSpPr/>
-          <p:nvPr/>
-        </p:nvSpPr>
-        <p:spPr>
-          <a:xfrm>
-            <a:off x="8101583" y="2377440"/>
-            <a:ext cx="3611880" cy="1234440"/>
-          </a:xfrm>
-          <a:prstGeom prst="roundRect">
-            <a:avLst>
-              <a:gd name="adj" fmla="val 10000"/>
-            </a:avLst>
-          </a:prstGeom>
-          <a:solidFill>
-            <a:srgbClr val="F3F5FA"/>
-          </a:solidFill>
-          <a:ln>
-            <a:noFill/>
-          </a:ln>
-          <a:effectLst/>
-        </p:spPr>
-        <p:style>
-          <a:lnRef idx="1">
-            <a:schemeClr val="accent1"/>
-          </a:lnRef>
-          <a:fillRef idx="3">
-            <a:schemeClr val="accent1"/>
-          </a:fillRef>
-          <a:effectRef idx="2">
-            <a:schemeClr val="accent1"/>
-          </a:effectRef>
-          <a:fontRef idx="minor">
-            <a:schemeClr val="lt1"/>
-          </a:fontRef>
-        </p:style>
-        <p:txBody>
-          <a:bodyPr rtlCol="0" anchor="ctr"/>
-          <a:lstStyle/>
-          <a:p>
-            <a:pPr algn="ctr"/>
-            <a:endParaRPr/>
-          </a:p>
-        </p:txBody>
-      </p:sp>
-      <p:sp>
-        <p:nvSpPr>
-          <p:cNvPr id="15" name="TextBox 14"/>
-          <p:cNvSpPr txBox="1"/>
-          <p:nvPr/>
-        </p:nvSpPr>
-        <p:spPr>
-          <a:xfrm>
-            <a:off x="8321040" y="2523744"/>
-            <a:ext cx="3200400" cy="365760"/>
-          </a:xfrm>
-          <a:prstGeom prst="rect">
-            <a:avLst/>
-          </a:prstGeom>
-          <a:noFill/>
-        </p:spPr>
-        <p:txBody>
-          <a:bodyPr wrap="square" lIns="0" tIns="0" rIns="0" bIns="0" anchor="t">
-            <a:spAutoFit/>
-          </a:bodyPr>
-          <a:lstStyle/>
-          <a:p>
-            <a:pPr algn="l">
-              <a:lnSpc>
-                <a:spcPct val="100000"/>
-              </a:lnSpc>
-              <a:spcBef>
-                <a:spcPts val="0"/>
-              </a:spcBef>
-              <a:spcAft>
-                <a:spcPts val="400"/>
-              </a:spcAft>
-            </a:pPr>
-            <a:r>
-              <a:rPr sz="1450" b="1" i="0">
-                <a:solidFill>
-                  <a:srgbClr val="1B2A5B"/>
-                </a:solidFill>
-                <a:latin typeface="Cambria"/>
-              </a:rPr>
-              <a:t>Singapore reshuffles the ranking</a:t>
-            </a:r>
-          </a:p>
-        </p:txBody>
-      </p:sp>
-      <p:sp>
-        <p:nvSpPr>
-          <p:cNvPr id="16" name="TextBox 15"/>
-          <p:cNvSpPr txBox="1"/>
-          <p:nvPr/>
-        </p:nvSpPr>
-        <p:spPr>
-          <a:xfrm>
-            <a:off x="8321040" y="2907792"/>
-            <a:ext cx="3200400" cy="640080"/>
-          </a:xfrm>
-          <a:prstGeom prst="rect">
-            <a:avLst/>
-          </a:prstGeom>
-          <a:noFill/>
-        </p:spPr>
-        <p:txBody>
-          <a:bodyPr wrap="square" lIns="0" tIns="0" rIns="0" bIns="0" anchor="t">
-            <a:spAutoFit/>
-          </a:bodyPr>
-          <a:lstStyle/>
-          <a:p>
-            <a:pPr algn="l">
-              <a:lnSpc>
-                <a:spcPct val="113000"/>
-              </a:lnSpc>
-              <a:spcBef>
-                <a:spcPts val="0"/>
-              </a:spcBef>
-              <a:spcAft>
-                <a:spcPts val="400"/>
-              </a:spcAft>
-            </a:pPr>
-            <a:r>
-              <a:rPr sz="1200" b="0" i="0">
-                <a:solidFill>
-                  <a:srgbClr val="636B7A"/>
-                </a:solidFill>
-                <a:latin typeface="Calibri"/>
-              </a:rPr>
-              <a:t>Rate falls with the radiant’s height, so the famous Perseids and Quadrantids underperform here — while Halley’s Eta Aquariids and Orionids ride high and shine.</a:t>
-            </a:r>
-          </a:p>
-        </p:txBody>
-      </p:sp>
-      <p:sp>
-        <p:nvSpPr>
-          <p:cNvPr id="17" name="Rounded Rectangle 16"/>
-          <p:cNvSpPr/>
-          <p:nvPr/>
-        </p:nvSpPr>
-        <p:spPr>
-          <a:xfrm>
-            <a:off x="548640" y="3794760"/>
-            <a:ext cx="3611880" cy="1234440"/>
-          </a:xfrm>
-          <a:prstGeom prst="roundRect">
-            <a:avLst>
-              <a:gd name="adj" fmla="val 10000"/>
-            </a:avLst>
-          </a:prstGeom>
-          <a:solidFill>
-            <a:srgbClr val="F3F5FA"/>
-          </a:solidFill>
-          <a:ln>
-            <a:noFill/>
-          </a:ln>
-          <a:effectLst/>
-        </p:spPr>
-        <p:style>
-          <a:lnRef idx="1">
-            <a:schemeClr val="accent1"/>
-          </a:lnRef>
-          <a:fillRef idx="3">
-            <a:schemeClr val="accent1"/>
-          </a:fillRef>
-          <a:effectRef idx="2">
-            <a:schemeClr val="accent1"/>
-          </a:effectRef>
-          <a:fontRef idx="minor">
-            <a:schemeClr val="lt1"/>
-          </a:fontRef>
-        </p:style>
-        <p:txBody>
-          <a:bodyPr rtlCol="0" anchor="ctr"/>
-          <a:lstStyle/>
-          <a:p>
-            <a:pPr algn="ctr"/>
-            <a:endParaRPr/>
-          </a:p>
-        </p:txBody>
-      </p:sp>
-      <p:sp>
-        <p:nvSpPr>
-          <p:cNvPr id="18" name="TextBox 17"/>
-          <p:cNvSpPr txBox="1"/>
-          <p:nvPr/>
-        </p:nvSpPr>
-        <p:spPr>
-          <a:xfrm>
-            <a:off x="768096" y="3941064"/>
-            <a:ext cx="3200400" cy="365760"/>
-          </a:xfrm>
-          <a:prstGeom prst="rect">
-            <a:avLst/>
-          </a:prstGeom>
-          <a:noFill/>
-        </p:spPr>
-        <p:txBody>
-          <a:bodyPr wrap="square" lIns="0" tIns="0" rIns="0" bIns="0" anchor="t">
-            <a:spAutoFit/>
-          </a:bodyPr>
-          <a:lstStyle/>
-          <a:p>
-            <a:pPr algn="l">
-              <a:lnSpc>
-                <a:spcPct val="100000"/>
-              </a:lnSpc>
-              <a:spcBef>
-                <a:spcPts val="0"/>
-              </a:spcBef>
-              <a:spcAft>
-                <a:spcPts val="400"/>
-              </a:spcAft>
-            </a:pPr>
-            <a:r>
-              <a:rPr sz="1450" b="1" i="0">
-                <a:solidFill>
-                  <a:srgbClr val="1B2A5B"/>
-                </a:solidFill>
-                <a:latin typeface="Cambria"/>
-              </a:rPr>
-              <a:t>A live “next shower” panel</a:t>
-            </a:r>
-          </a:p>
-        </p:txBody>
-      </p:sp>
-      <p:sp>
-        <p:nvSpPr>
-          <p:cNvPr id="19" name="TextBox 18"/>
-          <p:cNvSpPr txBox="1"/>
-          <p:nvPr/>
-        </p:nvSpPr>
-        <p:spPr>
-          <a:xfrm>
-            <a:off x="768096" y="4325112"/>
-            <a:ext cx="3200400" cy="640080"/>
-          </a:xfrm>
-          <a:prstGeom prst="rect">
-            <a:avLst/>
-          </a:prstGeom>
-          <a:noFill/>
-        </p:spPr>
-        <p:txBody>
-          <a:bodyPr wrap="square" lIns="0" tIns="0" rIns="0" bIns="0" anchor="t">
-            <a:spAutoFit/>
-          </a:bodyPr>
-          <a:lstStyle/>
-          <a:p>
-            <a:pPr algn="l">
-              <a:lnSpc>
-                <a:spcPct val="113000"/>
-              </a:lnSpc>
-              <a:spcBef>
-                <a:spcPts val="0"/>
-              </a:spcBef>
-              <a:spcAft>
-                <a:spcPts val="400"/>
-              </a:spcAft>
-            </a:pPr>
-            <a:r>
-              <a:rPr sz="1200" b="0" i="0">
-                <a:solidFill>
-                  <a:srgbClr val="636B7A"/>
-                </a:solidFill>
-                <a:latin typeface="Calibri"/>
-              </a:rPr>
-              <a:t>Names the next shower, days to peak, its rate, how high the radiant climbs from SCOB, and this year’s Moon interference — all on-device.</a:t>
-            </a:r>
-          </a:p>
-        </p:txBody>
-      </p:sp>
-      <p:sp>
-        <p:nvSpPr>
-          <p:cNvPr id="20" name="Rounded Rectangle 19"/>
-          <p:cNvSpPr/>
-          <p:nvPr/>
-        </p:nvSpPr>
-        <p:spPr>
-          <a:xfrm>
-            <a:off x="4325112" y="3794760"/>
-            <a:ext cx="3611880" cy="1234440"/>
-          </a:xfrm>
-          <a:prstGeom prst="roundRect">
-            <a:avLst>
-              <a:gd name="adj" fmla="val 10000"/>
-            </a:avLst>
-          </a:prstGeom>
-          <a:solidFill>
-            <a:srgbClr val="F3F5FA"/>
-          </a:solidFill>
-          <a:ln>
-            <a:noFill/>
-          </a:ln>
-          <a:effectLst/>
-        </p:spPr>
-        <p:style>
-          <a:lnRef idx="1">
-            <a:schemeClr val="accent1"/>
-          </a:lnRef>
-          <a:fillRef idx="3">
-            <a:schemeClr val="accent1"/>
-          </a:fillRef>
-          <a:effectRef idx="2">
-            <a:schemeClr val="accent1"/>
-          </a:effectRef>
-          <a:fontRef idx="minor">
-            <a:schemeClr val="lt1"/>
-          </a:fontRef>
-        </p:style>
-        <p:txBody>
-          <a:bodyPr rtlCol="0" anchor="ctr"/>
-          <a:lstStyle/>
-          <a:p>
-            <a:pPr algn="ctr"/>
-            <a:endParaRPr/>
-          </a:p>
-        </p:txBody>
-      </p:sp>
-      <p:sp>
-        <p:nvSpPr>
-          <p:cNvPr id="21" name="TextBox 20"/>
-          <p:cNvSpPr txBox="1"/>
-          <p:nvPr/>
-        </p:nvSpPr>
-        <p:spPr>
-          <a:xfrm>
-            <a:off x="4544568" y="3941064"/>
-            <a:ext cx="3200400" cy="365760"/>
-          </a:xfrm>
-          <a:prstGeom prst="rect">
-            <a:avLst/>
-          </a:prstGeom>
-          <a:noFill/>
-        </p:spPr>
-        <p:txBody>
-          <a:bodyPr wrap="square" lIns="0" tIns="0" rIns="0" bIns="0" anchor="t">
-            <a:spAutoFit/>
-          </a:bodyPr>
-          <a:lstStyle/>
-          <a:p>
-            <a:pPr algn="l">
-              <a:lnSpc>
-                <a:spcPct val="100000"/>
-              </a:lnSpc>
-              <a:spcBef>
-                <a:spcPts val="0"/>
-              </a:spcBef>
-              <a:spcAft>
-                <a:spcPts val="400"/>
-              </a:spcAft>
-            </a:pPr>
-            <a:r>
-              <a:rPr sz="1450" b="1" i="0">
-                <a:solidFill>
-                  <a:srgbClr val="1B2A5B"/>
-                </a:solidFill>
-                <a:latin typeface="Cambria"/>
-              </a:rPr>
-              <a:t>The year ranked for us</a:t>
-            </a:r>
-          </a:p>
-        </p:txBody>
-      </p:sp>
-      <p:sp>
-        <p:nvSpPr>
-          <p:cNvPr id="22" name="TextBox 21"/>
-          <p:cNvSpPr txBox="1"/>
-          <p:nvPr/>
-        </p:nvSpPr>
-        <p:spPr>
-          <a:xfrm>
-            <a:off x="4544568" y="4325112"/>
-            <a:ext cx="3200400" cy="640080"/>
-          </a:xfrm>
-          <a:prstGeom prst="rect">
-            <a:avLst/>
-          </a:prstGeom>
-          <a:noFill/>
-        </p:spPr>
-        <p:txBody>
-          <a:bodyPr wrap="square" lIns="0" tIns="0" rIns="0" bIns="0" anchor="t">
-            <a:spAutoFit/>
-          </a:bodyPr>
-          <a:lstStyle/>
-          <a:p>
-            <a:pPr algn="l">
-              <a:lnSpc>
-                <a:spcPct val="113000"/>
-              </a:lnSpc>
-              <a:spcBef>
-                <a:spcPts val="0"/>
-              </a:spcBef>
-              <a:spcAft>
-                <a:spcPts val="400"/>
-              </a:spcAft>
-            </a:pPr>
-            <a:r>
-              <a:rPr sz="1200" b="0" i="0">
-                <a:solidFill>
-                  <a:srgbClr val="636B7A"/>
-                </a:solidFill>
-                <a:latin typeface="Calibri"/>
-              </a:rPr>
-              <a:t>A table of all nine major showers sorted by how well they actually fare from Singapore.</a:t>
-            </a:r>
-          </a:p>
-        </p:txBody>
-      </p:sp>
-      <p:sp>
-        <p:nvSpPr>
-          <p:cNvPr id="23" name="Rounded Rectangle 22"/>
-          <p:cNvSpPr/>
-          <p:nvPr/>
-        </p:nvSpPr>
-        <p:spPr>
-          <a:xfrm>
-            <a:off x="8101583" y="3794760"/>
-            <a:ext cx="3611880" cy="1234440"/>
-          </a:xfrm>
-          <a:prstGeom prst="roundRect">
-            <a:avLst>
-              <a:gd name="adj" fmla="val 10000"/>
-            </a:avLst>
-          </a:prstGeom>
-          <a:solidFill>
-            <a:srgbClr val="F3F5FA"/>
-          </a:solidFill>
-          <a:ln>
-            <a:noFill/>
-          </a:ln>
-          <a:effectLst/>
-        </p:spPr>
-        <p:style>
-          <a:lnRef idx="1">
-            <a:schemeClr val="accent1"/>
-          </a:lnRef>
-          <a:fillRef idx="3">
-            <a:schemeClr val="accent1"/>
-          </a:fillRef>
-          <a:effectRef idx="2">
-            <a:schemeClr val="accent1"/>
-          </a:effectRef>
-          <a:fontRef idx="minor">
-            <a:schemeClr val="lt1"/>
-          </a:fontRef>
-        </p:style>
-        <p:txBody>
-          <a:bodyPr rtlCol="0" anchor="ctr"/>
-          <a:lstStyle/>
-          <a:p>
-            <a:pPr algn="ctr"/>
-            <a:endParaRPr/>
-          </a:p>
-        </p:txBody>
-      </p:sp>
-      <p:sp>
-        <p:nvSpPr>
-          <p:cNvPr id="24" name="TextBox 23"/>
-          <p:cNvSpPr txBox="1"/>
-          <p:nvPr/>
-        </p:nvSpPr>
-        <p:spPr>
-          <a:xfrm>
-            <a:off x="8321040" y="3941064"/>
-            <a:ext cx="3200400" cy="365760"/>
-          </a:xfrm>
-          <a:prstGeom prst="rect">
-            <a:avLst/>
-          </a:prstGeom>
-          <a:noFill/>
-        </p:spPr>
-        <p:txBody>
-          <a:bodyPr wrap="square" lIns="0" tIns="0" rIns="0" bIns="0" anchor="t">
-            <a:spAutoFit/>
-          </a:bodyPr>
-          <a:lstStyle/>
-          <a:p>
-            <a:pPr algn="l">
-              <a:lnSpc>
-                <a:spcPct val="100000"/>
-              </a:lnSpc>
-              <a:spcBef>
-                <a:spcPts val="0"/>
-              </a:spcBef>
-              <a:spcAft>
-                <a:spcPts val="400"/>
-              </a:spcAft>
-            </a:pPr>
-            <a:r>
-              <a:rPr sz="1450" b="1" i="0">
-                <a:solidFill>
-                  <a:srgbClr val="1B2A5B"/>
-                </a:solidFill>
-                <a:latin typeface="Cambria"/>
-              </a:rPr>
-              <a:t>Where to find it</a:t>
-            </a:r>
-          </a:p>
-        </p:txBody>
-      </p:sp>
-      <p:sp>
-        <p:nvSpPr>
-          <p:cNvPr id="25" name="TextBox 24"/>
-          <p:cNvSpPr txBox="1"/>
-          <p:nvPr/>
-        </p:nvSpPr>
-        <p:spPr>
-          <a:xfrm>
-            <a:off x="8321040" y="4325112"/>
-            <a:ext cx="3200400" cy="640080"/>
-          </a:xfrm>
-          <a:prstGeom prst="rect">
-            <a:avLst/>
-          </a:prstGeom>
-          <a:noFill/>
-        </p:spPr>
-        <p:txBody>
-          <a:bodyPr wrap="square" lIns="0" tIns="0" rIns="0" bIns="0" anchor="t">
-            <a:spAutoFit/>
-          </a:bodyPr>
-          <a:lstStyle/>
-          <a:p>
-            <a:pPr algn="l">
-              <a:lnSpc>
-                <a:spcPct val="113000"/>
-              </a:lnSpc>
-              <a:spcBef>
-                <a:spcPts val="0"/>
-              </a:spcBef>
-              <a:spcAft>
-                <a:spcPts val="400"/>
-              </a:spcAft>
-            </a:pPr>
-            <a:r>
-              <a:rPr sz="1200" b="0" i="0">
-                <a:solidFill>
-                  <a:srgbClr val="636B7A"/>
-                </a:solidFill>
-                <a:latin typeface="Calibri"/>
-              </a:rPr>
-              <a:t>Linked from the dashboard menu, the almanac’s shower card, and the visitor Sky Guide (four languages).</a:t>
-            </a:r>
-          </a:p>
-        </p:txBody>
-      </p:sp>
-      <p:sp>
-        <p:nvSpPr>
-          <p:cNvPr id="26" name="RS_Classification">
-            <a:extLst>
-              <a:ext uri="{FF2B5EF4-FFF2-40B4-BE49-F238E27FC236}">
-                <a16:creationId xmlns:a16="http://schemas.microsoft.com/office/drawing/2014/main" id="{2375B548-02D6-6383-5DC1-367F1F6C4B7E}"/>
               </a:ext>
             </a:extLst>
           </p:cNvPr>
@@ -48820,7 +48820,7 @@
                 </a:solidFill>
                 <a:latin typeface="Calibri"/>
               </a:rPr>
-              <a:t>SCOB Night-Sky Dashboard  ·  Volunteer User Guide  ·  v3.48</a:t>
+              <a:t>SCOB Night-Sky Dashboard  ·  Volunteer User Guide  ·  v3.49</a:t>
             </a:r>
           </a:p>
         </p:txBody>
@@ -49968,7 +49968,7 @@
                 </a:solidFill>
                 <a:latin typeface="Calibri"/>
               </a:rPr>
-              <a:t>SCOB Night-Sky Dashboard  ·  Volunteer User Guide  ·  v3.48</a:t>
+              <a:t>SCOB Night-Sky Dashboard  ·  Volunteer User Guide  ·  v3.49</a:t>
             </a:r>
           </a:p>
         </p:txBody>
@@ -52727,7 +52727,7 @@
                 </a:solidFill>
                 <a:latin typeface="Calibri"/>
               </a:rPr>
-              <a:t>SCOB Night-Sky Dashboard  ·  Volunteer User Guide  ·  v3.48</a:t>
+              <a:t>SCOB Night-Sky Dashboard  ·  Volunteer User Guide  ·  v3.49</a:t>
             </a:r>
           </a:p>
         </p:txBody>
@@ -53730,7 +53730,7 @@
                 </a:solidFill>
                 <a:latin typeface="Calibri"/>
               </a:rPr>
-              <a:t>SCOB Night-Sky Dashboard  ·  Volunteer User Guide  ·  v3.48</a:t>
+              <a:t>SCOB Night-Sky Dashboard  ·  Volunteer User Guide  ·  v3.49</a:t>
             </a:r>
           </a:p>
         </p:txBody>
@@ -56767,7 +56767,7 @@
                 </a:solidFill>
                 <a:latin typeface="Calibri"/>
               </a:rPr>
-              <a:t>SCOB Night-Sky Dashboard  ·  Volunteer User Guide  ·  v3.48</a:t>
+              <a:t>SCOB Night-Sky Dashboard  ·  Volunteer User Guide  ·  v3.49</a:t>
             </a:r>
           </a:p>
         </p:txBody>

</xml_diff>

<commit_message>
improvement to meteors page
</commit_message>
<xml_diff>
--- a/SCOB-Dashboard-User-Guide.pptx
+++ b/SCOB-Dashboard-User-Guide.pptx
@@ -6635,7 +6635,7 @@
                 </a:solidFill>
                 <a:latin typeface="Calibri"/>
               </a:rPr>
-              <a:t>Version 3.49  ·  Updated weekly, ahead of the session</a:t>
+              <a:t>Version 3.50  ·  Updated weekly, ahead of the session</a:t>
             </a:r>
           </a:p>
         </p:txBody>
@@ -6885,7 +6885,7 @@
                 </a:solidFill>
                 <a:latin typeface="Calibri"/>
               </a:rPr>
-              <a:t>SCOB Night-Sky Dashboard  ·  Volunteer User Guide  ·  v3.49</a:t>
+              <a:t>SCOB Night-Sky Dashboard  ·  Volunteer User Guide  ·  v3.50</a:t>
             </a:r>
           </a:p>
         </p:txBody>
@@ -8119,7 +8119,7 @@
                 </a:solidFill>
                 <a:latin typeface="Calibri"/>
               </a:rPr>
-              <a:t>SCOB Night-Sky Dashboard  ·  Volunteer User Guide  ·  v3.49</a:t>
+              <a:t>SCOB Night-Sky Dashboard  ·  Volunteer User Guide  ·  v3.50</a:t>
             </a:r>
           </a:p>
         </p:txBody>
@@ -9237,7 +9237,7 @@
                 </a:solidFill>
                 <a:latin typeface="Calibri"/>
               </a:rPr>
-              <a:t>SCOB Night-Sky Dashboard  ·  Volunteer User Guide  ·  v3.49</a:t>
+              <a:t>SCOB Night-Sky Dashboard  ·  Volunteer User Guide  ·  v3.50</a:t>
             </a:r>
           </a:p>
         </p:txBody>
@@ -10024,7 +10024,7 @@
                 </a:solidFill>
                 <a:latin typeface="Calibri"/>
               </a:rPr>
-              <a:t>SCOB Night-Sky Dashboard  ·  Volunteer User Guide  ·  v3.49</a:t>
+              <a:t>SCOB Night-Sky Dashboard  ·  Volunteer User Guide  ·  v3.50</a:t>
             </a:r>
           </a:p>
         </p:txBody>
@@ -11196,7 +11196,7 @@
                 </a:solidFill>
                 <a:latin typeface="Calibri"/>
               </a:rPr>
-              <a:t>SCOB Night-Sky Dashboard  ·  Volunteer User Guide  ·  v3.49</a:t>
+              <a:t>SCOB Night-Sky Dashboard  ·  Volunteer User Guide  ·  v3.50</a:t>
             </a:r>
           </a:p>
         </p:txBody>
@@ -12377,7 +12377,7 @@
                 </a:solidFill>
                 <a:latin typeface="Calibri"/>
               </a:rPr>
-              <a:t>SCOB Night-Sky Dashboard  ·  Volunteer User Guide  ·  v3.49</a:t>
+              <a:t>SCOB Night-Sky Dashboard  ·  Volunteer User Guide  ·  v3.50</a:t>
             </a:r>
           </a:p>
         </p:txBody>
@@ -13165,7 +13165,7 @@
                 </a:solidFill>
                 <a:latin typeface="Calibri"/>
               </a:rPr>
-              <a:t>SCOB Night-Sky Dashboard  ·  Volunteer User Guide  ·  v3.49</a:t>
+              <a:t>SCOB Night-Sky Dashboard  ·  Volunteer User Guide  ·  v3.50</a:t>
             </a:r>
           </a:p>
         </p:txBody>
@@ -13934,7 +13934,7 @@
                 </a:solidFill>
                 <a:latin typeface="Calibri"/>
               </a:rPr>
-              <a:t>SCOB Night-Sky Dashboard  ·  Volunteer User Guide  ·  v3.49</a:t>
+              <a:t>SCOB Night-Sky Dashboard  ·  Volunteer User Guide  ·  v3.50</a:t>
             </a:r>
           </a:p>
         </p:txBody>
@@ -14903,7 +14903,7 @@
                 </a:solidFill>
                 <a:latin typeface="Calibri"/>
               </a:rPr>
-              <a:t>SCOB Night-Sky Dashboard  ·  Volunteer User Guide  ·  v3.49</a:t>
+              <a:t>SCOB Night-Sky Dashboard  ·  Volunteer User Guide  ·  v3.50</a:t>
             </a:r>
           </a:p>
         </p:txBody>
@@ -15791,7 +15791,7 @@
                 </a:solidFill>
                 <a:latin typeface="Calibri"/>
               </a:rPr>
-              <a:t>SCOB Night-Sky Dashboard  ·  Volunteer User Guide  ·  v3.49</a:t>
+              <a:t>SCOB Night-Sky Dashboard  ·  Volunteer User Guide  ·  v3.50</a:t>
             </a:r>
           </a:p>
         </p:txBody>
@@ -16755,7 +16755,7 @@
                 </a:solidFill>
                 <a:latin typeface="Calibri"/>
               </a:rPr>
-              <a:t>SCOB Night-Sky Dashboard  ·  Volunteer User Guide  ·  v3.49</a:t>
+              <a:t>SCOB Night-Sky Dashboard  ·  Volunteer User Guide  ·  v3.50</a:t>
             </a:r>
           </a:p>
         </p:txBody>
@@ -17623,7 +17623,7 @@
                 </a:solidFill>
                 <a:latin typeface="Calibri"/>
               </a:rPr>
-              <a:t>SCOB Night-Sky Dashboard  ·  Volunteer User Guide  ·  v3.49</a:t>
+              <a:t>SCOB Night-Sky Dashboard  ·  Volunteer User Guide  ·  v3.50</a:t>
             </a:r>
           </a:p>
         </p:txBody>
@@ -18695,7 +18695,7 @@
                 </a:solidFill>
                 <a:latin typeface="Calibri"/>
               </a:rPr>
-              <a:t>SCOB Night-Sky Dashboard  ·  Volunteer User Guide  ·  v3.49</a:t>
+              <a:t>SCOB Night-Sky Dashboard  ·  Volunteer User Guide  ·  v3.50</a:t>
             </a:r>
           </a:p>
         </p:txBody>
@@ -19411,7 +19411,7 @@
                 </a:solidFill>
                 <a:latin typeface="Calibri"/>
               </a:rPr>
-              <a:t>SCOB Night-Sky Dashboard  ·  Volunteer User Guide  ·  v3.49</a:t>
+              <a:t>SCOB Night-Sky Dashboard  ·  Volunteer User Guide  ·  v3.50</a:t>
             </a:r>
           </a:p>
         </p:txBody>
@@ -20558,7 +20558,7 @@
                 </a:solidFill>
                 <a:latin typeface="Calibri"/>
               </a:rPr>
-              <a:t>SCOB Night-Sky Dashboard  ·  Volunteer User Guide  ·  v3.49</a:t>
+              <a:t>SCOB Night-Sky Dashboard  ·  Volunteer User Guide  ·  v3.50</a:t>
             </a:r>
           </a:p>
         </p:txBody>
@@ -21705,7 +21705,7 @@
                 </a:solidFill>
                 <a:latin typeface="Calibri"/>
               </a:rPr>
-              <a:t>SCOB Night-Sky Dashboard  ·  Volunteer User Guide  ·  v3.49</a:t>
+              <a:t>SCOB Night-Sky Dashboard  ·  Volunteer User Guide  ·  v3.50</a:t>
             </a:r>
           </a:p>
         </p:txBody>
@@ -22852,7 +22852,7 @@
                 </a:solidFill>
                 <a:latin typeface="Calibri"/>
               </a:rPr>
-              <a:t>SCOB Night-Sky Dashboard  ·  Volunteer User Guide  ·  v3.49</a:t>
+              <a:t>SCOB Night-Sky Dashboard  ·  Volunteer User Guide  ·  v3.50</a:t>
             </a:r>
           </a:p>
         </p:txBody>
@@ -23999,7 +23999,7 @@
                 </a:solidFill>
                 <a:latin typeface="Calibri"/>
               </a:rPr>
-              <a:t>SCOB Night-Sky Dashboard  ·  Volunteer User Guide  ·  v3.49</a:t>
+              <a:t>SCOB Night-Sky Dashboard  ·  Volunteer User Guide  ·  v3.50</a:t>
             </a:r>
           </a:p>
         </p:txBody>
@@ -25146,7 +25146,7 @@
                 </a:solidFill>
                 <a:latin typeface="Calibri"/>
               </a:rPr>
-              <a:t>SCOB Night-Sky Dashboard  ·  Volunteer User Guide  ·  v3.49</a:t>
+              <a:t>SCOB Night-Sky Dashboard  ·  Volunteer User Guide  ·  v3.50</a:t>
             </a:r>
           </a:p>
         </p:txBody>
@@ -26293,7 +26293,7 @@
                 </a:solidFill>
                 <a:latin typeface="Calibri"/>
               </a:rPr>
-              <a:t>SCOB Night-Sky Dashboard  ·  Volunteer User Guide  ·  v3.49</a:t>
+              <a:t>SCOB Night-Sky Dashboard  ·  Volunteer User Guide  ·  v3.50</a:t>
             </a:r>
           </a:p>
         </p:txBody>
@@ -27440,7 +27440,7 @@
                 </a:solidFill>
                 <a:latin typeface="Calibri"/>
               </a:rPr>
-              <a:t>SCOB Night-Sky Dashboard  ·  Volunteer User Guide  ·  v3.49</a:t>
+              <a:t>SCOB Night-Sky Dashboard  ·  Volunteer User Guide  ·  v3.50</a:t>
             </a:r>
           </a:p>
         </p:txBody>
@@ -28602,7 +28602,7 @@
                 </a:solidFill>
                 <a:latin typeface="Calibri"/>
               </a:rPr>
-              <a:t>SCOB Night-Sky Dashboard  ·  Volunteer User Guide  ·  v3.49</a:t>
+              <a:t>SCOB Night-Sky Dashboard  ·  Volunteer User Guide  ·  v3.50</a:t>
             </a:r>
           </a:p>
         </p:txBody>
@@ -29410,7 +29410,7 @@
                 </a:solidFill>
                 <a:latin typeface="Calibri"/>
               </a:rPr>
-              <a:t>SCOB Night-Sky Dashboard  ·  Volunteer User Guide  ·  v3.49</a:t>
+              <a:t>SCOB Night-Sky Dashboard  ·  Volunteer User Guide  ·  v3.50</a:t>
             </a:r>
           </a:p>
         </p:txBody>
@@ -30557,7 +30557,7 @@
                 </a:solidFill>
                 <a:latin typeface="Calibri"/>
               </a:rPr>
-              <a:t>SCOB Night-Sky Dashboard  ·  Volunteer User Guide  ·  v3.49</a:t>
+              <a:t>SCOB Night-Sky Dashboard  ·  Volunteer User Guide  ·  v3.50</a:t>
             </a:r>
           </a:p>
         </p:txBody>
@@ -31704,7 +31704,7 @@
                 </a:solidFill>
                 <a:latin typeface="Calibri"/>
               </a:rPr>
-              <a:t>SCOB Night-Sky Dashboard  ·  Volunteer User Guide  ·  v3.49</a:t>
+              <a:t>SCOB Night-Sky Dashboard  ·  Volunteer User Guide  ·  v3.50</a:t>
             </a:r>
           </a:p>
         </p:txBody>
@@ -32851,7 +32851,7 @@
                 </a:solidFill>
                 <a:latin typeface="Calibri"/>
               </a:rPr>
-              <a:t>SCOB Night-Sky Dashboard  ·  Volunteer User Guide  ·  v3.49</a:t>
+              <a:t>SCOB Night-Sky Dashboard  ·  Volunteer User Guide  ·  v3.50</a:t>
             </a:r>
           </a:p>
         </p:txBody>
@@ -33998,7 +33998,7 @@
                 </a:solidFill>
                 <a:latin typeface="Calibri"/>
               </a:rPr>
-              <a:t>SCOB Night-Sky Dashboard  ·  Volunteer User Guide  ·  v3.49</a:t>
+              <a:t>SCOB Night-Sky Dashboard  ·  Volunteer User Guide  ·  v3.50</a:t>
             </a:r>
           </a:p>
         </p:txBody>
@@ -35145,7 +35145,7 @@
                 </a:solidFill>
                 <a:latin typeface="Calibri"/>
               </a:rPr>
-              <a:t>SCOB Night-Sky Dashboard  ·  Volunteer User Guide  ·  v3.49</a:t>
+              <a:t>SCOB Night-Sky Dashboard  ·  Volunteer User Guide  ·  v3.50</a:t>
             </a:r>
           </a:p>
         </p:txBody>
@@ -36292,7 +36292,7 @@
                 </a:solidFill>
                 <a:latin typeface="Calibri"/>
               </a:rPr>
-              <a:t>SCOB Night-Sky Dashboard  ·  Volunteer User Guide  ·  v3.49</a:t>
+              <a:t>SCOB Night-Sky Dashboard  ·  Volunteer User Guide  ·  v3.50</a:t>
             </a:r>
           </a:p>
         </p:txBody>
@@ -37439,7 +37439,7 @@
                 </a:solidFill>
                 <a:latin typeface="Calibri"/>
               </a:rPr>
-              <a:t>SCOB Night-Sky Dashboard  ·  Volunteer User Guide  ·  v3.49</a:t>
+              <a:t>SCOB Night-Sky Dashboard  ·  Volunteer User Guide  ·  v3.50</a:t>
             </a:r>
           </a:p>
         </p:txBody>
@@ -38586,7 +38586,7 @@
                 </a:solidFill>
                 <a:latin typeface="Calibri"/>
               </a:rPr>
-              <a:t>SCOB Night-Sky Dashboard  ·  Volunteer User Guide  ·  v3.49</a:t>
+              <a:t>SCOB Night-Sky Dashboard  ·  Volunteer User Guide  ·  v3.50</a:t>
             </a:r>
           </a:p>
         </p:txBody>
@@ -39733,7 +39733,7 @@
                 </a:solidFill>
                 <a:latin typeface="Calibri"/>
               </a:rPr>
-              <a:t>SCOB Night-Sky Dashboard  ·  Volunteer User Guide  ·  v3.49</a:t>
+              <a:t>SCOB Night-Sky Dashboard  ·  Volunteer User Guide  ·  v3.50</a:t>
             </a:r>
           </a:p>
         </p:txBody>
@@ -40895,7 +40895,7 @@
                 </a:solidFill>
                 <a:latin typeface="Calibri"/>
               </a:rPr>
-              <a:t>SCOB Night-Sky Dashboard  ·  Volunteer User Guide  ·  v3.49</a:t>
+              <a:t>SCOB Night-Sky Dashboard  ·  Volunteer User Guide  ·  v3.50</a:t>
             </a:r>
           </a:p>
         </p:txBody>
@@ -42042,7 +42042,7 @@
                 </a:solidFill>
                 <a:latin typeface="Calibri"/>
               </a:rPr>
-              <a:t>SCOB Night-Sky Dashboard  ·  Volunteer User Guide  ·  v3.49</a:t>
+              <a:t>SCOB Night-Sky Dashboard  ·  Volunteer User Guide  ·  v3.50</a:t>
             </a:r>
           </a:p>
         </p:txBody>
@@ -43189,7 +43189,7 @@
                 </a:solidFill>
                 <a:latin typeface="Calibri"/>
               </a:rPr>
-              <a:t>SCOB Night-Sky Dashboard  ·  Volunteer User Guide  ·  v3.49</a:t>
+              <a:t>SCOB Night-Sky Dashboard  ·  Volunteer User Guide  ·  v3.50</a:t>
             </a:r>
           </a:p>
         </p:txBody>
@@ -44336,7 +44336,7 @@
                 </a:solidFill>
                 <a:latin typeface="Calibri"/>
               </a:rPr>
-              <a:t>SCOB Night-Sky Dashboard  ·  Volunteer User Guide  ·  v3.49</a:t>
+              <a:t>SCOB Night-Sky Dashboard  ·  Volunteer User Guide  ·  v3.50</a:t>
             </a:r>
           </a:p>
         </p:txBody>
@@ -48820,7 +48820,7 @@
                 </a:solidFill>
                 <a:latin typeface="Calibri"/>
               </a:rPr>
-              <a:t>SCOB Night-Sky Dashboard  ·  Volunteer User Guide  ·  v3.49</a:t>
+              <a:t>SCOB Night-Sky Dashboard  ·  Volunteer User Guide  ·  v3.50</a:t>
             </a:r>
           </a:p>
         </p:txBody>
@@ -49968,7 +49968,7 @@
                 </a:solidFill>
                 <a:latin typeface="Calibri"/>
               </a:rPr>
-              <a:t>SCOB Night-Sky Dashboard  ·  Volunteer User Guide  ·  v3.49</a:t>
+              <a:t>SCOB Night-Sky Dashboard  ·  Volunteer User Guide  ·  v3.50</a:t>
             </a:r>
           </a:p>
         </p:txBody>
@@ -52727,7 +52727,7 @@
                 </a:solidFill>
                 <a:latin typeface="Calibri"/>
               </a:rPr>
-              <a:t>SCOB Night-Sky Dashboard  ·  Volunteer User Guide  ·  v3.49</a:t>
+              <a:t>SCOB Night-Sky Dashboard  ·  Volunteer User Guide  ·  v3.50</a:t>
             </a:r>
           </a:p>
         </p:txBody>
@@ -53730,7 +53730,7 @@
                 </a:solidFill>
                 <a:latin typeface="Calibri"/>
               </a:rPr>
-              <a:t>SCOB Night-Sky Dashboard  ·  Volunteer User Guide  ·  v3.49</a:t>
+              <a:t>SCOB Night-Sky Dashboard  ·  Volunteer User Guide  ·  v3.50</a:t>
             </a:r>
           </a:p>
         </p:txBody>
@@ -56767,7 +56767,7 @@
                 </a:solidFill>
                 <a:latin typeface="Calibri"/>
               </a:rPr>
-              <a:t>SCOB Night-Sky Dashboard  ·  Volunteer User Guide  ·  v3.49</a:t>
+              <a:t>SCOB Night-Sky Dashboard  ·  Volunteer User Guide  ·  v3.50</a:t>
             </a:r>
           </a:p>
         </p:txBody>

</xml_diff>